<commit_message>
Update proposal pack for two presenters
</commit_message>
<xml_diff>
--- a/deliverables/proposal_2026_06_03/PromoMind_project2_proposal_slides.pptx
+++ b/deliverables/proposal_2026_06_03/PromoMind_project2_proposal_slides.pptx
@@ -2,22 +2,22 @@
 <file path=ppt/presentation.xml><?xml version="1.0" encoding="utf-8"?>
 <p:presentation xmlns:p="http://schemas.openxmlformats.org/presentationml/2006/main">
   <p:sldMasterIdLst>
-    <p:sldMasterId xmlns:r="http://schemas.openxmlformats.org/officeDocument/2006/relationships" id="2147483648" r:id="R823218cfbcbf443c"/>
+    <p:sldMasterId xmlns:r="http://schemas.openxmlformats.org/officeDocument/2006/relationships" id="2147483648" r:id="Ra160d014e22a4562"/>
   </p:sldMasterIdLst>
   <p:notesMasterIdLst>
-    <p:notesMasterId xmlns:r="http://schemas.openxmlformats.org/officeDocument/2006/relationships" r:id="R41635af33bef4c95"/>
+    <p:notesMasterId xmlns:r="http://schemas.openxmlformats.org/officeDocument/2006/relationships" r:id="Rd2e43cd3831b499a"/>
   </p:notesMasterIdLst>
   <p:sldIdLst>
-    <p:sldId xmlns:r="http://schemas.openxmlformats.org/officeDocument/2006/relationships" id="256" r:id="Rfd081ed76ace4f9c"/>
-    <p:sldId xmlns:r="http://schemas.openxmlformats.org/officeDocument/2006/relationships" id="257" r:id="Rda7c5d5f7a29488b"/>
-    <p:sldId xmlns:r="http://schemas.openxmlformats.org/officeDocument/2006/relationships" id="258" r:id="R1a0cb3e887f14b76"/>
-    <p:sldId xmlns:r="http://schemas.openxmlformats.org/officeDocument/2006/relationships" id="259" r:id="R0a48fd728a994e54"/>
-    <p:sldId xmlns:r="http://schemas.openxmlformats.org/officeDocument/2006/relationships" id="260" r:id="Rda7ba6200d0c42f7"/>
-    <p:sldId xmlns:r="http://schemas.openxmlformats.org/officeDocument/2006/relationships" id="261" r:id="R107f838e951d4054"/>
-    <p:sldId xmlns:r="http://schemas.openxmlformats.org/officeDocument/2006/relationships" id="262" r:id="R5474ce42cd824e0e"/>
-    <p:sldId xmlns:r="http://schemas.openxmlformats.org/officeDocument/2006/relationships" id="263" r:id="R7e2fa83c39a54e00"/>
-    <p:sldId xmlns:r="http://schemas.openxmlformats.org/officeDocument/2006/relationships" id="264" r:id="Rcd9c94e963c84859"/>
-    <p:sldId xmlns:r="http://schemas.openxmlformats.org/officeDocument/2006/relationships" id="265" r:id="R00b18029baf2472c"/>
+    <p:sldId xmlns:r="http://schemas.openxmlformats.org/officeDocument/2006/relationships" id="256" r:id="Raf837e43db51409b"/>
+    <p:sldId xmlns:r="http://schemas.openxmlformats.org/officeDocument/2006/relationships" id="257" r:id="Rad72e6a366d447f1"/>
+    <p:sldId xmlns:r="http://schemas.openxmlformats.org/officeDocument/2006/relationships" id="258" r:id="Re0202f85da964bd4"/>
+    <p:sldId xmlns:r="http://schemas.openxmlformats.org/officeDocument/2006/relationships" id="259" r:id="R84d6e6faad9048eb"/>
+    <p:sldId xmlns:r="http://schemas.openxmlformats.org/officeDocument/2006/relationships" id="260" r:id="Rad799f77a3ab420d"/>
+    <p:sldId xmlns:r="http://schemas.openxmlformats.org/officeDocument/2006/relationships" id="261" r:id="R690ab79f4837429e"/>
+    <p:sldId xmlns:r="http://schemas.openxmlformats.org/officeDocument/2006/relationships" id="262" r:id="R04f12c217319425f"/>
+    <p:sldId xmlns:r="http://schemas.openxmlformats.org/officeDocument/2006/relationships" id="263" r:id="Rcc1a44470a5b406c"/>
+    <p:sldId xmlns:r="http://schemas.openxmlformats.org/officeDocument/2006/relationships" id="264" r:id="Rf6206406375f4922"/>
+    <p:sldId xmlns:r="http://schemas.openxmlformats.org/officeDocument/2006/relationships" id="265" r:id="R2e323ab93fcc4e12"/>
   </p:sldIdLst>
   <p:sldSz cx="12192000" cy="6858000"/>
   <p:notesSz cx="6858000" cy="9144000"/>
@@ -1158,7 +1158,7 @@
   </p:cSld>
   <p:clrMap bg1="lt1" tx1="dk1" bg2="lt2" tx2="dk2" accent1="accent1" accent2="accent2" accent3="accent3" accent4="accent4" accent5="accent5" accent6="accent6" hlink="hlink" folHlink="folHlink"/>
   <p:sldLayoutIdLst>
-    <p:sldLayoutId xmlns:r="http://schemas.openxmlformats.org/officeDocument/2006/relationships" id="2147483649" r:id="R2345054c0b5f47e5"/>
+    <p:sldLayoutId xmlns:r="http://schemas.openxmlformats.org/officeDocument/2006/relationships" id="2147483649" r:id="R32a0f5e3a5054414"/>
   </p:sldLayoutIdLst>
   <p:txStyles>
     <p:titleStyle>
@@ -1656,7 +1656,7 @@
           <p:cNvPr id="1" name="">
             <a:extLst xmlns:a="http://schemas.openxmlformats.org/drawingml/2006/main">
               <a:ext uri="{FF2B5EF4-FFF2-40B4-BE49-F238E27FC236}">
-                <a16:creationId xmlns:a16="http://schemas.microsoft.com/office/drawing/2014/main" id="{AAED06B8-AAE4-4485-B425-6C819D482C1C}"/>
+                <a16:creationId xmlns:a16="http://schemas.microsoft.com/office/drawing/2014/main" id="{85228D71-BF96-4C79-A7EC-3BB680B27BE8}"/>
               </a:ext>
             </a:extLst>
           </p:cNvPr>
@@ -1691,7 +1691,7 @@
           <p:cNvPr id="2" name="">
             <a:extLst xmlns:a="http://schemas.openxmlformats.org/drawingml/2006/main">
               <a:ext uri="{FF2B5EF4-FFF2-40B4-BE49-F238E27FC236}">
-                <a16:creationId xmlns:a16="http://schemas.microsoft.com/office/drawing/2014/main" id="{64197554-9790-42E0-ADD5-231343E95032}"/>
+                <a16:creationId xmlns:a16="http://schemas.microsoft.com/office/drawing/2014/main" id="{DA123D58-0C7E-4360-A78E-2720E1AD2ECA}"/>
               </a:ext>
             </a:extLst>
           </p:cNvPr>
@@ -1726,7 +1726,7 @@
           <p:cNvPr id="3" name="">
             <a:extLst xmlns:a="http://schemas.openxmlformats.org/drawingml/2006/main">
               <a:ext uri="{FF2B5EF4-FFF2-40B4-BE49-F238E27FC236}">
-                <a16:creationId xmlns:a16="http://schemas.microsoft.com/office/drawing/2014/main" id="{04869D8A-7291-45A3-9889-C1404837BC27}"/>
+                <a16:creationId xmlns:a16="http://schemas.microsoft.com/office/drawing/2014/main" id="{A65DF595-826A-413F-BAEA-24B1E34CAC77}"/>
               </a:ext>
             </a:extLst>
           </p:cNvPr>
@@ -1759,7 +1759,7 @@
           <p:cNvPr id="4" name="">
             <a:extLst xmlns:a="http://schemas.openxmlformats.org/drawingml/2006/main">
               <a:ext uri="{FF2B5EF4-FFF2-40B4-BE49-F238E27FC236}">
-                <a16:creationId xmlns:a16="http://schemas.microsoft.com/office/drawing/2014/main" id="{9251DB4D-3358-4D24-BD68-062F585C2605}"/>
+                <a16:creationId xmlns:a16="http://schemas.microsoft.com/office/drawing/2014/main" id="{429BD5E1-2F74-4EEE-9CF4-659AEC8A876E}"/>
               </a:ext>
             </a:extLst>
           </p:cNvPr>
@@ -1823,7 +1823,7 @@
           <p:cNvPr id="5" name="">
             <a:extLst xmlns:a="http://schemas.openxmlformats.org/drawingml/2006/main">
               <a:ext uri="{FF2B5EF4-FFF2-40B4-BE49-F238E27FC236}">
-                <a16:creationId xmlns:a16="http://schemas.microsoft.com/office/drawing/2014/main" id="{1A3532D4-58E9-4C5C-A11E-2BEDAFF4CC5E}"/>
+                <a16:creationId xmlns:a16="http://schemas.microsoft.com/office/drawing/2014/main" id="{B265388E-38B7-46DD-9F56-A0FCBDC927AF}"/>
               </a:ext>
             </a:extLst>
           </p:cNvPr>
@@ -1887,7 +1887,7 @@
           <p:cNvPr id="6" name="">
             <a:extLst xmlns:a="http://schemas.openxmlformats.org/drawingml/2006/main">
               <a:ext uri="{FF2B5EF4-FFF2-40B4-BE49-F238E27FC236}">
-                <a16:creationId xmlns:a16="http://schemas.microsoft.com/office/drawing/2014/main" id="{5D619103-8323-40D1-8045-7A0F3B08A465}"/>
+                <a16:creationId xmlns:a16="http://schemas.microsoft.com/office/drawing/2014/main" id="{3DBB8913-8AF3-45E1-AD94-231E83A2097D}"/>
               </a:ext>
             </a:extLst>
           </p:cNvPr>
@@ -1951,7 +1951,7 @@
           <p:cNvPr id="7" name="">
             <a:extLst xmlns:a="http://schemas.openxmlformats.org/drawingml/2006/main">
               <a:ext uri="{FF2B5EF4-FFF2-40B4-BE49-F238E27FC236}">
-                <a16:creationId xmlns:a16="http://schemas.microsoft.com/office/drawing/2014/main" id="{B062A089-9AF1-44EF-9DBE-58BCCFBBBC65}"/>
+                <a16:creationId xmlns:a16="http://schemas.microsoft.com/office/drawing/2014/main" id="{4F7718B4-BB83-4141-AEE5-AE87D91B0CC9}"/>
               </a:ext>
             </a:extLst>
           </p:cNvPr>
@@ -2015,7 +2015,7 @@
           <p:cNvPr id="8" name="">
             <a:extLst xmlns:a="http://schemas.openxmlformats.org/drawingml/2006/main">
               <a:ext uri="{FF2B5EF4-FFF2-40B4-BE49-F238E27FC236}">
-                <a16:creationId xmlns:a16="http://schemas.microsoft.com/office/drawing/2014/main" id="{298EF2F6-2CB7-489D-86F7-BD8D9F8C343A}"/>
+                <a16:creationId xmlns:a16="http://schemas.microsoft.com/office/drawing/2014/main" id="{E6DA6FDF-F950-420D-9045-31ECD5BCBDAB}"/>
               </a:ext>
             </a:extLst>
           </p:cNvPr>
@@ -2048,7 +2048,7 @@
           <p:cNvPr id="9" name="">
             <a:extLst xmlns:a="http://schemas.openxmlformats.org/drawingml/2006/main">
               <a:ext uri="{FF2B5EF4-FFF2-40B4-BE49-F238E27FC236}">
-                <a16:creationId xmlns:a16="http://schemas.microsoft.com/office/drawing/2014/main" id="{71DE1C67-21E8-48CD-A847-E7CEC38E4974}"/>
+                <a16:creationId xmlns:a16="http://schemas.microsoft.com/office/drawing/2014/main" id="{F3881BC2-BB88-45C0-BB51-A78EF64ACB0E}"/>
               </a:ext>
             </a:extLst>
           </p:cNvPr>
@@ -2112,7 +2112,7 @@
           <p:cNvPr id="10" name="">
             <a:extLst xmlns:a="http://schemas.openxmlformats.org/drawingml/2006/main">
               <a:ext uri="{FF2B5EF4-FFF2-40B4-BE49-F238E27FC236}">
-                <a16:creationId xmlns:a16="http://schemas.microsoft.com/office/drawing/2014/main" id="{69F1D3F1-7A22-47B0-B88E-39F3850BE170}"/>
+                <a16:creationId xmlns:a16="http://schemas.microsoft.com/office/drawing/2014/main" id="{B32F3845-8574-4D34-8F55-C02160D91A39}"/>
               </a:ext>
             </a:extLst>
           </p:cNvPr>
@@ -2176,7 +2176,7 @@
           <p:cNvPr id="11" name="">
             <a:extLst xmlns:a="http://schemas.openxmlformats.org/drawingml/2006/main">
               <a:ext uri="{FF2B5EF4-FFF2-40B4-BE49-F238E27FC236}">
-                <a16:creationId xmlns:a16="http://schemas.microsoft.com/office/drawing/2014/main" id="{63D79733-4034-45CE-8B46-7FADCCB27793}"/>
+                <a16:creationId xmlns:a16="http://schemas.microsoft.com/office/drawing/2014/main" id="{46428599-45A4-4503-9389-FBE59AFB8F65}"/>
               </a:ext>
             </a:extLst>
           </p:cNvPr>
@@ -2240,7 +2240,7 @@
           <p:cNvPr id="12" name="">
             <a:extLst xmlns:a="http://schemas.openxmlformats.org/drawingml/2006/main">
               <a:ext uri="{FF2B5EF4-FFF2-40B4-BE49-F238E27FC236}">
-                <a16:creationId xmlns:a16="http://schemas.microsoft.com/office/drawing/2014/main" id="{F4DA88E9-B575-4393-9C7A-F166E28B903B}"/>
+                <a16:creationId xmlns:a16="http://schemas.microsoft.com/office/drawing/2014/main" id="{A99820CA-6637-42D8-8D60-315B37B5E9A0}"/>
               </a:ext>
             </a:extLst>
           </p:cNvPr>
@@ -2273,7 +2273,7 @@
           <p:cNvPr id="13" name="">
             <a:extLst xmlns:a="http://schemas.openxmlformats.org/drawingml/2006/main">
               <a:ext uri="{FF2B5EF4-FFF2-40B4-BE49-F238E27FC236}">
-                <a16:creationId xmlns:a16="http://schemas.microsoft.com/office/drawing/2014/main" id="{77B34D09-6E0F-4451-AF63-D3F47D871076}"/>
+                <a16:creationId xmlns:a16="http://schemas.microsoft.com/office/drawing/2014/main" id="{FF9E70EE-5D34-4BB7-AEC0-4EF236D5D2C3}"/>
               </a:ext>
             </a:extLst>
           </p:cNvPr>
@@ -2337,7 +2337,7 @@
           <p:cNvPr id="14" name="">
             <a:extLst xmlns:a="http://schemas.openxmlformats.org/drawingml/2006/main">
               <a:ext uri="{FF2B5EF4-FFF2-40B4-BE49-F238E27FC236}">
-                <a16:creationId xmlns:a16="http://schemas.microsoft.com/office/drawing/2014/main" id="{0CE12682-B280-4A1E-913E-10079E4C07DF}"/>
+                <a16:creationId xmlns:a16="http://schemas.microsoft.com/office/drawing/2014/main" id="{C971A8F3-04B5-4C69-9B74-2A52FB60863A}"/>
               </a:ext>
             </a:extLst>
           </p:cNvPr>
@@ -2401,7 +2401,7 @@
           <p:cNvPr id="15" name="">
             <a:extLst xmlns:a="http://schemas.openxmlformats.org/drawingml/2006/main">
               <a:ext uri="{FF2B5EF4-FFF2-40B4-BE49-F238E27FC236}">
-                <a16:creationId xmlns:a16="http://schemas.microsoft.com/office/drawing/2014/main" id="{1DD195E8-2257-4D8A-A5AD-BC3C344BCB1E}"/>
+                <a16:creationId xmlns:a16="http://schemas.microsoft.com/office/drawing/2014/main" id="{7413443A-C5A5-4459-B774-A4C0ED816F76}"/>
               </a:ext>
             </a:extLst>
           </p:cNvPr>
@@ -2465,7 +2465,7 @@
           <p:cNvPr id="16" name="">
             <a:extLst xmlns:a="http://schemas.openxmlformats.org/drawingml/2006/main">
               <a:ext uri="{FF2B5EF4-FFF2-40B4-BE49-F238E27FC236}">
-                <a16:creationId xmlns:a16="http://schemas.microsoft.com/office/drawing/2014/main" id="{D2DAF89D-CE62-472E-B575-18FF02790602}"/>
+                <a16:creationId xmlns:a16="http://schemas.microsoft.com/office/drawing/2014/main" id="{5906B60B-F55B-410F-AE1A-0F822071320D}"/>
               </a:ext>
             </a:extLst>
           </p:cNvPr>
@@ -2498,7 +2498,7 @@
           <p:cNvPr id="17" name="">
             <a:extLst xmlns:a="http://schemas.openxmlformats.org/drawingml/2006/main">
               <a:ext uri="{FF2B5EF4-FFF2-40B4-BE49-F238E27FC236}">
-                <a16:creationId xmlns:a16="http://schemas.microsoft.com/office/drawing/2014/main" id="{6FAC906B-CEE7-4DB0-8030-0BC51F587226}"/>
+                <a16:creationId xmlns:a16="http://schemas.microsoft.com/office/drawing/2014/main" id="{1C75B99C-088E-4F9F-B192-38E6A446166C}"/>
               </a:ext>
             </a:extLst>
           </p:cNvPr>
@@ -2562,7 +2562,7 @@
           <p:cNvPr id="18" name="">
             <a:extLst xmlns:a="http://schemas.openxmlformats.org/drawingml/2006/main">
               <a:ext uri="{FF2B5EF4-FFF2-40B4-BE49-F238E27FC236}">
-                <a16:creationId xmlns:a16="http://schemas.microsoft.com/office/drawing/2014/main" id="{59390B01-7BD0-4666-98DD-43FEC0D2F634}"/>
+                <a16:creationId xmlns:a16="http://schemas.microsoft.com/office/drawing/2014/main" id="{A54E936A-FDB4-493F-ACCC-3B3A03BF07DE}"/>
               </a:ext>
             </a:extLst>
           </p:cNvPr>
@@ -2626,7 +2626,7 @@
           <p:cNvPr id="19" name="">
             <a:extLst xmlns:a="http://schemas.openxmlformats.org/drawingml/2006/main">
               <a:ext uri="{FF2B5EF4-FFF2-40B4-BE49-F238E27FC236}">
-                <a16:creationId xmlns:a16="http://schemas.microsoft.com/office/drawing/2014/main" id="{138F14C0-4ED7-4392-95EC-878F524202FC}"/>
+                <a16:creationId xmlns:a16="http://schemas.microsoft.com/office/drawing/2014/main" id="{4D0BB19F-D032-47BF-BFBE-71DFBBC52BA9}"/>
               </a:ext>
             </a:extLst>
           </p:cNvPr>
@@ -2690,7 +2690,7 @@
           <p:cNvPr id="20" name="">
             <a:extLst xmlns:a="http://schemas.openxmlformats.org/drawingml/2006/main">
               <a:ext uri="{FF2B5EF4-FFF2-40B4-BE49-F238E27FC236}">
-                <a16:creationId xmlns:a16="http://schemas.microsoft.com/office/drawing/2014/main" id="{D800809F-E4F4-4379-BA7B-E404771496A4}"/>
+                <a16:creationId xmlns:a16="http://schemas.microsoft.com/office/drawing/2014/main" id="{06E412F3-61E6-424E-9822-A2D714EB2EE3}"/>
               </a:ext>
             </a:extLst>
           </p:cNvPr>
@@ -2723,7 +2723,7 @@
           <p:cNvPr id="21" name="">
             <a:extLst xmlns:a="http://schemas.openxmlformats.org/drawingml/2006/main">
               <a:ext uri="{FF2B5EF4-FFF2-40B4-BE49-F238E27FC236}">
-                <a16:creationId xmlns:a16="http://schemas.microsoft.com/office/drawing/2014/main" id="{1F2105B0-E7FB-492D-AB97-0988064D689C}"/>
+                <a16:creationId xmlns:a16="http://schemas.microsoft.com/office/drawing/2014/main" id="{868441C8-8826-4866-9294-88A13452E4FC}"/>
               </a:ext>
             </a:extLst>
           </p:cNvPr>
@@ -2787,7 +2787,7 @@
           <p:cNvPr id="22" name="">
             <a:extLst xmlns:a="http://schemas.openxmlformats.org/drawingml/2006/main">
               <a:ext uri="{FF2B5EF4-FFF2-40B4-BE49-F238E27FC236}">
-                <a16:creationId xmlns:a16="http://schemas.microsoft.com/office/drawing/2014/main" id="{398D8EA6-ED5C-4A22-8A92-2DF2EF869376}"/>
+                <a16:creationId xmlns:a16="http://schemas.microsoft.com/office/drawing/2014/main" id="{8D9CD0FF-9DCA-402C-A0B2-6069CE4935F1}"/>
               </a:ext>
             </a:extLst>
           </p:cNvPr>
@@ -2851,7 +2851,7 @@
           <p:cNvPr id="23" name="">
             <a:extLst xmlns:a="http://schemas.openxmlformats.org/drawingml/2006/main">
               <a:ext uri="{FF2B5EF4-FFF2-40B4-BE49-F238E27FC236}">
-                <a16:creationId xmlns:a16="http://schemas.microsoft.com/office/drawing/2014/main" id="{B08F614D-BC96-4740-A0C6-3DF26D4B6DD8}"/>
+                <a16:creationId xmlns:a16="http://schemas.microsoft.com/office/drawing/2014/main" id="{551AF767-3FE2-4D43-B392-36E7F2D78EA2}"/>
               </a:ext>
             </a:extLst>
           </p:cNvPr>
@@ -2915,7 +2915,7 @@
           <p:cNvPr id="24" name="">
             <a:extLst xmlns:a="http://schemas.openxmlformats.org/drawingml/2006/main">
               <a:ext uri="{FF2B5EF4-FFF2-40B4-BE49-F238E27FC236}">
-                <a16:creationId xmlns:a16="http://schemas.microsoft.com/office/drawing/2014/main" id="{05A19D72-363C-4916-BBD5-820A5346E761}"/>
+                <a16:creationId xmlns:a16="http://schemas.microsoft.com/office/drawing/2014/main" id="{1741C7F7-AB59-43BE-8F64-74A1F8214FB4}"/>
               </a:ext>
             </a:extLst>
           </p:cNvPr>
@@ -2927,7 +2927,7 @@
         <p:spPr>
           <a:xfrm xmlns:a="http://schemas.openxmlformats.org/drawingml/2006/main">
             <a:off x="609600" y="5619750"/>
-            <a:ext cx="7620000" cy="228600"/>
+            <a:ext cx="8572500" cy="228600"/>
           </a:xfrm>
           <a:prstGeom xmlns:a="http://schemas.openxmlformats.org/drawingml/2006/main" prst="rect">
             <a:avLst/>
@@ -2969,7 +2969,7 @@
                 <a:ea typeface="Aptos"/>
                 <a:cs typeface="Aptos"/>
               </a:rPr>
-              <a:t>Team roles: A Data | B Models | C Reranking | D Demo and Integration</a:t>
+              <a:t>Presenter split: P1 dataset/problem/system setup | P2 methods/reranking/experiments/demo</a:t>
             </a:r>
           </a:p>
         </p:txBody>
@@ -2979,7 +2979,7 @@
           <p:cNvPr id="25" name="">
             <a:extLst xmlns:a="http://schemas.openxmlformats.org/drawingml/2006/main">
               <a:ext uri="{FF2B5EF4-FFF2-40B4-BE49-F238E27FC236}">
-                <a16:creationId xmlns:a16="http://schemas.microsoft.com/office/drawing/2014/main" id="{C03C3E3A-5299-4B82-9B5B-E35D2FE79AA8}"/>
+                <a16:creationId xmlns:a16="http://schemas.microsoft.com/office/drawing/2014/main" id="{445A8B93-41CD-439F-A697-66782F0137CE}"/>
               </a:ext>
             </a:extLst>
           </p:cNvPr>
@@ -3014,7 +3014,7 @@
           <p:cNvPr id="26" name="">
             <a:extLst xmlns:a="http://schemas.openxmlformats.org/drawingml/2006/main">
               <a:ext uri="{FF2B5EF4-FFF2-40B4-BE49-F238E27FC236}">
-                <a16:creationId xmlns:a16="http://schemas.microsoft.com/office/drawing/2014/main" id="{22EF67E4-4AF0-4382-8180-B496E85F803F}"/>
+                <a16:creationId xmlns:a16="http://schemas.microsoft.com/office/drawing/2014/main" id="{07A5E908-D6D5-4A32-A924-6FA401F5C091}"/>
               </a:ext>
             </a:extLst>
           </p:cNvPr>
@@ -3078,7 +3078,7 @@
           <p:cNvPr id="27" name="">
             <a:extLst xmlns:a="http://schemas.openxmlformats.org/drawingml/2006/main">
               <a:ext uri="{FF2B5EF4-FFF2-40B4-BE49-F238E27FC236}">
-                <a16:creationId xmlns:a16="http://schemas.microsoft.com/office/drawing/2014/main" id="{4E8BE054-5493-4710-A2E2-4A61C901A5FA}"/>
+                <a16:creationId xmlns:a16="http://schemas.microsoft.com/office/drawing/2014/main" id="{77BA6D3D-6FA8-4C51-8A2B-C06190C2B696}"/>
               </a:ext>
             </a:extLst>
           </p:cNvPr>
@@ -3140,7 +3140,7 @@
     </p:spTree>
     <p:extLst>
       <p:ext uri="{BB962C8B-B14F-4D97-AF65-F5344CB8AC3E}">
-        <p14:creationId xmlns:p14="http://schemas.microsoft.com/office/powerpoint/2010/main" val="1402518544"/>
+        <p14:creationId xmlns:p14="http://schemas.microsoft.com/office/powerpoint/2010/main" val="1821592576"/>
       </p:ext>
     </p:extLst>
   </p:cSld>
@@ -3164,7 +3164,7 @@
           <p:cNvPr id="1" name="">
             <a:extLst xmlns:a="http://schemas.openxmlformats.org/drawingml/2006/main">
               <a:ext uri="{FF2B5EF4-FFF2-40B4-BE49-F238E27FC236}">
-                <a16:creationId xmlns:a16="http://schemas.microsoft.com/office/drawing/2014/main" id="{3A625E70-C3B9-4154-985A-A09B4B9F7C6A}"/>
+                <a16:creationId xmlns:a16="http://schemas.microsoft.com/office/drawing/2014/main" id="{3F65BDD2-742B-406B-90BE-5691923AF97C}"/>
               </a:ext>
             </a:extLst>
           </p:cNvPr>
@@ -3199,7 +3199,7 @@
           <p:cNvPr id="2" name="">
             <a:extLst xmlns:a="http://schemas.openxmlformats.org/drawingml/2006/main">
               <a:ext uri="{FF2B5EF4-FFF2-40B4-BE49-F238E27FC236}">
-                <a16:creationId xmlns:a16="http://schemas.microsoft.com/office/drawing/2014/main" id="{3F1E9DDB-A0EC-4560-9127-03DF4055C7EC}"/>
+                <a16:creationId xmlns:a16="http://schemas.microsoft.com/office/drawing/2014/main" id="{CFF72E72-E651-4185-9EC1-891621FB3F42}"/>
               </a:ext>
             </a:extLst>
           </p:cNvPr>
@@ -3234,7 +3234,7 @@
           <p:cNvPr id="3" name="">
             <a:extLst xmlns:a="http://schemas.openxmlformats.org/drawingml/2006/main">
               <a:ext uri="{FF2B5EF4-FFF2-40B4-BE49-F238E27FC236}">
-                <a16:creationId xmlns:a16="http://schemas.microsoft.com/office/drawing/2014/main" id="{E419F32F-B189-4139-B582-C3673005A531}"/>
+                <a16:creationId xmlns:a16="http://schemas.microsoft.com/office/drawing/2014/main" id="{78ACBCF3-7D9A-49DF-BA2B-D343EFBD3F48}"/>
               </a:ext>
             </a:extLst>
           </p:cNvPr>
@@ -3298,7 +3298,7 @@
           <p:cNvPr id="4" name="">
             <a:extLst xmlns:a="http://schemas.openxmlformats.org/drawingml/2006/main">
               <a:ext uri="{FF2B5EF4-FFF2-40B4-BE49-F238E27FC236}">
-                <a16:creationId xmlns:a16="http://schemas.microsoft.com/office/drawing/2014/main" id="{FCDB30B3-1D3A-485C-B175-A647314A0767}"/>
+                <a16:creationId xmlns:a16="http://schemas.microsoft.com/office/drawing/2014/main" id="{15DC3D57-14A3-436F-9517-C8764CBBEF6B}"/>
               </a:ext>
             </a:extLst>
           </p:cNvPr>
@@ -3362,7 +3362,7 @@
           <p:cNvPr id="5" name="">
             <a:extLst xmlns:a="http://schemas.openxmlformats.org/drawingml/2006/main">
               <a:ext uri="{FF2B5EF4-FFF2-40B4-BE49-F238E27FC236}">
-                <a16:creationId xmlns:a16="http://schemas.microsoft.com/office/drawing/2014/main" id="{3672BF84-AF16-47A5-98EB-7D1208709072}"/>
+                <a16:creationId xmlns:a16="http://schemas.microsoft.com/office/drawing/2014/main" id="{CA5A66AF-C3FF-4A41-AB3C-B4D22FFD24D1}"/>
               </a:ext>
             </a:extLst>
           </p:cNvPr>
@@ -3416,7 +3416,7 @@
                 <a:ea typeface="Aptos"/>
                 <a:cs typeface="Aptos"/>
               </a:rPr>
-              <a:t>Each workstream owns both future implementation and its proposal section.</a:t>
+              <a:t>The proposal is split between two presenters so the meeting can focus on questions.</a:t>
             </a:r>
           </a:p>
         </p:txBody>
@@ -3426,7 +3426,7 @@
           <p:cNvPr id="6" name="">
             <a:extLst xmlns:a="http://schemas.openxmlformats.org/drawingml/2006/main">
               <a:ext uri="{FF2B5EF4-FFF2-40B4-BE49-F238E27FC236}">
-                <a16:creationId xmlns:a16="http://schemas.microsoft.com/office/drawing/2014/main" id="{83EFD9F0-DD2B-4909-A247-9A8350FEBE7F}"/>
+                <a16:creationId xmlns:a16="http://schemas.microsoft.com/office/drawing/2014/main" id="{0426A577-0C30-4230-9DB7-D252A850C55D}"/>
               </a:ext>
             </a:extLst>
           </p:cNvPr>
@@ -3438,7 +3438,7 @@
         <p:spPr>
           <a:xfrm xmlns:a="http://schemas.openxmlformats.org/drawingml/2006/main">
             <a:off x="666750" y="2266950"/>
-            <a:ext cx="2476500" cy="1352550"/>
+            <a:ext cx="5143500" cy="1352550"/>
           </a:xfrm>
           <a:prstGeom xmlns:a="http://schemas.openxmlformats.org/drawingml/2006/main" prst="rect">
             <a:avLst/>
@@ -3459,43 +3459,43 @@
           <p:cNvPr id="7" name="">
             <a:extLst xmlns:a="http://schemas.openxmlformats.org/drawingml/2006/main">
               <a:ext uri="{FF2B5EF4-FFF2-40B4-BE49-F238E27FC236}">
-                <a16:creationId xmlns:a16="http://schemas.microsoft.com/office/drawing/2014/main" id="{0009579F-382D-4710-A823-ED5203117664}"/>
-              </a:ext>
-            </a:extLst>
-          </p:cNvPr>
-          <p:cNvSpPr>
-            <a:spLocks xmlns:a="http://schemas.openxmlformats.org/drawingml/2006/main" noGrp="1"/>
-          </p:cNvSpPr>
-          <p:nvPr/>
-        </p:nvSpPr>
-        <p:spPr>
-          <a:xfrm xmlns:a="http://schemas.openxmlformats.org/drawingml/2006/main">
-            <a:off x="838200" y="2476500"/>
-            <a:ext cx="2000250" cy="228600"/>
-          </a:xfrm>
-          <a:prstGeom xmlns:a="http://schemas.openxmlformats.org/drawingml/2006/main" prst="rect">
-            <a:avLst/>
-          </a:prstGeom>
-          <a:solidFill xmlns:a="http://schemas.openxmlformats.org/drawingml/2006/main">
-            <a:srgbClr val="000000">
-              <a:alpha val="0"/>
-            </a:srgbClr>
-          </a:solidFill>
-          <a:ln xmlns:a="http://schemas.openxmlformats.org/drawingml/2006/main" w="0">
-            <a:solidFill>
-              <a:srgbClr val="000000">
-                <a:alpha val="0"/>
-              </a:srgbClr>
-            </a:solidFill>
-            <a:prstDash val="solid"/>
-          </a:ln>
-        </p:spPr>
-        <p:txBody>
-          <a:bodyPr xmlns:a="http://schemas.openxmlformats.org/drawingml/2006/main" lIns="0" tIns="0" rIns="0" bIns="0" anchor="t"/>
-          <a:lstStyle xmlns:a="http://schemas.openxmlformats.org/drawingml/2006/main"/>
-          <a:p xmlns:a="http://schemas.openxmlformats.org/drawingml/2006/main">
-            <a:pPr algn="l">
-              <a:defRPr sz="1350" b="1">
+                <a16:creationId xmlns:a16="http://schemas.microsoft.com/office/drawing/2014/main" id="{7C568C7E-8A0E-4C87-BB5C-5742033ECD99}"/>
+              </a:ext>
+            </a:extLst>
+          </p:cNvPr>
+          <p:cNvSpPr>
+            <a:spLocks xmlns:a="http://schemas.openxmlformats.org/drawingml/2006/main" noGrp="1"/>
+          </p:cNvSpPr>
+          <p:nvPr/>
+        </p:nvSpPr>
+        <p:spPr>
+          <a:xfrm xmlns:a="http://schemas.openxmlformats.org/drawingml/2006/main">
+            <a:off x="876300" y="2476500"/>
+            <a:ext cx="2095500" cy="228600"/>
+          </a:xfrm>
+          <a:prstGeom xmlns:a="http://schemas.openxmlformats.org/drawingml/2006/main" prst="rect">
+            <a:avLst/>
+          </a:prstGeom>
+          <a:solidFill xmlns:a="http://schemas.openxmlformats.org/drawingml/2006/main">
+            <a:srgbClr val="000000">
+              <a:alpha val="0"/>
+            </a:srgbClr>
+          </a:solidFill>
+          <a:ln xmlns:a="http://schemas.openxmlformats.org/drawingml/2006/main" w="0">
+            <a:solidFill>
+              <a:srgbClr val="000000">
+                <a:alpha val="0"/>
+              </a:srgbClr>
+            </a:solidFill>
+            <a:prstDash val="solid"/>
+          </a:ln>
+        </p:spPr>
+        <p:txBody>
+          <a:bodyPr xmlns:a="http://schemas.openxmlformats.org/drawingml/2006/main" lIns="0" tIns="0" rIns="0" bIns="0" anchor="t"/>
+          <a:lstStyle xmlns:a="http://schemas.openxmlformats.org/drawingml/2006/main"/>
+          <a:p xmlns:a="http://schemas.openxmlformats.org/drawingml/2006/main">
+            <a:pPr algn="l">
+              <a:defRPr sz="1500" b="1">
                 <a:solidFill>
                   <a:srgbClr val="146B4D"/>
                 </a:solidFill>
@@ -3505,7 +3505,7 @@
               </a:defRPr>
             </a:pPr>
             <a:r>
-              <a:rPr sz="1350" b="1">
+              <a:rPr sz="1500" b="1">
                 <a:solidFill>
                   <a:srgbClr val="146B4D"/>
                 </a:solidFill>
@@ -3513,7 +3513,7 @@
                 <a:ea typeface="Aptos"/>
                 <a:cs typeface="Aptos"/>
               </a:rPr>
-              <a:t>A Data</a:t>
+              <a:t>Presenter 1</a:t>
             </a:r>
           </a:p>
         </p:txBody>
@@ -3523,43 +3523,43 @@
           <p:cNvPr id="8" name="">
             <a:extLst xmlns:a="http://schemas.openxmlformats.org/drawingml/2006/main">
               <a:ext uri="{FF2B5EF4-FFF2-40B4-BE49-F238E27FC236}">
-                <a16:creationId xmlns:a16="http://schemas.microsoft.com/office/drawing/2014/main" id="{416A1D44-64F7-4290-8EAC-192C0D5F4FA1}"/>
-              </a:ext>
-            </a:extLst>
-          </p:cNvPr>
-          <p:cNvSpPr>
-            <a:spLocks xmlns:a="http://schemas.openxmlformats.org/drawingml/2006/main" noGrp="1"/>
-          </p:cNvSpPr>
-          <p:nvPr/>
-        </p:nvSpPr>
-        <p:spPr>
-          <a:xfrm xmlns:a="http://schemas.openxmlformats.org/drawingml/2006/main">
-            <a:off x="838200" y="2914650"/>
-            <a:ext cx="2095500" cy="476250"/>
-          </a:xfrm>
-          <a:prstGeom xmlns:a="http://schemas.openxmlformats.org/drawingml/2006/main" prst="rect">
-            <a:avLst/>
-          </a:prstGeom>
-          <a:solidFill xmlns:a="http://schemas.openxmlformats.org/drawingml/2006/main">
-            <a:srgbClr val="000000">
-              <a:alpha val="0"/>
-            </a:srgbClr>
-          </a:solidFill>
-          <a:ln xmlns:a="http://schemas.openxmlformats.org/drawingml/2006/main" w="0">
-            <a:solidFill>
-              <a:srgbClr val="000000">
-                <a:alpha val="0"/>
-              </a:srgbClr>
-            </a:solidFill>
-            <a:prstDash val="solid"/>
-          </a:ln>
-        </p:spPr>
-        <p:txBody>
-          <a:bodyPr xmlns:a="http://schemas.openxmlformats.org/drawingml/2006/main" lIns="0" tIns="0" rIns="0" bIns="0" anchor="t"/>
-          <a:lstStyle xmlns:a="http://schemas.openxmlformats.org/drawingml/2006/main"/>
-          <a:p xmlns:a="http://schemas.openxmlformats.org/drawingml/2006/main">
-            <a:pPr algn="l">
-              <a:defRPr sz="1050" b="0">
+                <a16:creationId xmlns:a16="http://schemas.microsoft.com/office/drawing/2014/main" id="{147C021C-B2B9-473A-8930-7C12228AE394}"/>
+              </a:ext>
+            </a:extLst>
+          </p:cNvPr>
+          <p:cNvSpPr>
+            <a:spLocks xmlns:a="http://schemas.openxmlformats.org/drawingml/2006/main" noGrp="1"/>
+          </p:cNvSpPr>
+          <p:nvPr/>
+        </p:nvSpPr>
+        <p:spPr>
+          <a:xfrm xmlns:a="http://schemas.openxmlformats.org/drawingml/2006/main">
+            <a:off x="876300" y="2914650"/>
+            <a:ext cx="4476750" cy="514350"/>
+          </a:xfrm>
+          <a:prstGeom xmlns:a="http://schemas.openxmlformats.org/drawingml/2006/main" prst="rect">
+            <a:avLst/>
+          </a:prstGeom>
+          <a:solidFill xmlns:a="http://schemas.openxmlformats.org/drawingml/2006/main">
+            <a:srgbClr val="000000">
+              <a:alpha val="0"/>
+            </a:srgbClr>
+          </a:solidFill>
+          <a:ln xmlns:a="http://schemas.openxmlformats.org/drawingml/2006/main" w="0">
+            <a:solidFill>
+              <a:srgbClr val="000000">
+                <a:alpha val="0"/>
+              </a:srgbClr>
+            </a:solidFill>
+            <a:prstDash val="solid"/>
+          </a:ln>
+        </p:spPr>
+        <p:txBody>
+          <a:bodyPr xmlns:a="http://schemas.openxmlformats.org/drawingml/2006/main" lIns="0" tIns="0" rIns="0" bIns="0" anchor="t"/>
+          <a:lstStyle xmlns:a="http://schemas.openxmlformats.org/drawingml/2006/main"/>
+          <a:p xmlns:a="http://schemas.openxmlformats.org/drawingml/2006/main">
+            <a:pPr algn="l">
+              <a:defRPr sz="1125" b="0">
                 <a:solidFill>
                   <a:srgbClr val="18201B"/>
                 </a:solidFill>
@@ -3569,7 +3569,7 @@
               </a:defRPr>
             </a:pPr>
             <a:r>
-              <a:rPr sz="1050" b="0">
+              <a:rPr sz="1125" b="0">
                 <a:solidFill>
                   <a:srgbClr val="18201B"/>
                 </a:solidFill>
@@ -3577,7 +3577,7 @@
                 <a:ea typeface="Aptos"/>
                 <a:cs typeface="Aptos"/>
               </a:rPr>
-              <a:t>Dataset, collection, split, EDA, leakage checks</a:t>
+              <a:t>Slides 1-5: motivation, dataset choice, feature examples, recommendation task, time split, system setup</a:t>
             </a:r>
           </a:p>
         </p:txBody>
@@ -3587,19 +3587,19 @@
           <p:cNvPr id="9" name="">
             <a:extLst xmlns:a="http://schemas.openxmlformats.org/drawingml/2006/main">
               <a:ext uri="{FF2B5EF4-FFF2-40B4-BE49-F238E27FC236}">
-                <a16:creationId xmlns:a16="http://schemas.microsoft.com/office/drawing/2014/main" id="{D06C87D7-2EC5-439F-A719-D7F9B77FC2FE}"/>
-              </a:ext>
-            </a:extLst>
-          </p:cNvPr>
-          <p:cNvSpPr>
-            <a:spLocks xmlns:a="http://schemas.openxmlformats.org/drawingml/2006/main" noGrp="1"/>
-          </p:cNvSpPr>
-          <p:nvPr/>
-        </p:nvSpPr>
-        <p:spPr>
-          <a:xfrm xmlns:a="http://schemas.openxmlformats.org/drawingml/2006/main">
-            <a:off x="3524250" y="2266950"/>
-            <a:ext cx="2476500" cy="1352550"/>
+                <a16:creationId xmlns:a16="http://schemas.microsoft.com/office/drawing/2014/main" id="{C5054B80-C53A-4C60-9782-D7C4B9818844}"/>
+              </a:ext>
+            </a:extLst>
+          </p:cNvPr>
+          <p:cNvSpPr>
+            <a:spLocks xmlns:a="http://schemas.openxmlformats.org/drawingml/2006/main" noGrp="1"/>
+          </p:cNvSpPr>
+          <p:nvPr/>
+        </p:nvSpPr>
+        <p:spPr>
+          <a:xfrm xmlns:a="http://schemas.openxmlformats.org/drawingml/2006/main">
+            <a:off x="6191250" y="2266950"/>
+            <a:ext cx="5143500" cy="1352550"/>
           </a:xfrm>
           <a:prstGeom xmlns:a="http://schemas.openxmlformats.org/drawingml/2006/main" prst="rect">
             <a:avLst/>
@@ -3620,43 +3620,43 @@
           <p:cNvPr id="10" name="">
             <a:extLst xmlns:a="http://schemas.openxmlformats.org/drawingml/2006/main">
               <a:ext uri="{FF2B5EF4-FFF2-40B4-BE49-F238E27FC236}">
-                <a16:creationId xmlns:a16="http://schemas.microsoft.com/office/drawing/2014/main" id="{7984F7A8-7505-462D-8EA6-D65E2659A347}"/>
-              </a:ext>
-            </a:extLst>
-          </p:cNvPr>
-          <p:cNvSpPr>
-            <a:spLocks xmlns:a="http://schemas.openxmlformats.org/drawingml/2006/main" noGrp="1"/>
-          </p:cNvSpPr>
-          <p:nvPr/>
-        </p:nvSpPr>
-        <p:spPr>
-          <a:xfrm xmlns:a="http://schemas.openxmlformats.org/drawingml/2006/main">
-            <a:off x="3695700" y="2476500"/>
-            <a:ext cx="2000250" cy="228600"/>
-          </a:xfrm>
-          <a:prstGeom xmlns:a="http://schemas.openxmlformats.org/drawingml/2006/main" prst="rect">
-            <a:avLst/>
-          </a:prstGeom>
-          <a:solidFill xmlns:a="http://schemas.openxmlformats.org/drawingml/2006/main">
-            <a:srgbClr val="000000">
-              <a:alpha val="0"/>
-            </a:srgbClr>
-          </a:solidFill>
-          <a:ln xmlns:a="http://schemas.openxmlformats.org/drawingml/2006/main" w="0">
-            <a:solidFill>
-              <a:srgbClr val="000000">
-                <a:alpha val="0"/>
-              </a:srgbClr>
-            </a:solidFill>
-            <a:prstDash val="solid"/>
-          </a:ln>
-        </p:spPr>
-        <p:txBody>
-          <a:bodyPr xmlns:a="http://schemas.openxmlformats.org/drawingml/2006/main" lIns="0" tIns="0" rIns="0" bIns="0" anchor="t"/>
-          <a:lstStyle xmlns:a="http://schemas.openxmlformats.org/drawingml/2006/main"/>
-          <a:p xmlns:a="http://schemas.openxmlformats.org/drawingml/2006/main">
-            <a:pPr algn="l">
-              <a:defRPr sz="1350" b="1">
+                <a16:creationId xmlns:a16="http://schemas.microsoft.com/office/drawing/2014/main" id="{D51650A1-0A34-4705-92F4-0B3A0D26B7AA}"/>
+              </a:ext>
+            </a:extLst>
+          </p:cNvPr>
+          <p:cNvSpPr>
+            <a:spLocks xmlns:a="http://schemas.openxmlformats.org/drawingml/2006/main" noGrp="1"/>
+          </p:cNvSpPr>
+          <p:nvPr/>
+        </p:nvSpPr>
+        <p:spPr>
+          <a:xfrm xmlns:a="http://schemas.openxmlformats.org/drawingml/2006/main">
+            <a:off x="6400800" y="2476500"/>
+            <a:ext cx="2095500" cy="228600"/>
+          </a:xfrm>
+          <a:prstGeom xmlns:a="http://schemas.openxmlformats.org/drawingml/2006/main" prst="rect">
+            <a:avLst/>
+          </a:prstGeom>
+          <a:solidFill xmlns:a="http://schemas.openxmlformats.org/drawingml/2006/main">
+            <a:srgbClr val="000000">
+              <a:alpha val="0"/>
+            </a:srgbClr>
+          </a:solidFill>
+          <a:ln xmlns:a="http://schemas.openxmlformats.org/drawingml/2006/main" w="0">
+            <a:solidFill>
+              <a:srgbClr val="000000">
+                <a:alpha val="0"/>
+              </a:srgbClr>
+            </a:solidFill>
+            <a:prstDash val="solid"/>
+          </a:ln>
+        </p:spPr>
+        <p:txBody>
+          <a:bodyPr xmlns:a="http://schemas.openxmlformats.org/drawingml/2006/main" lIns="0" tIns="0" rIns="0" bIns="0" anchor="t"/>
+          <a:lstStyle xmlns:a="http://schemas.openxmlformats.org/drawingml/2006/main"/>
+          <a:p xmlns:a="http://schemas.openxmlformats.org/drawingml/2006/main">
+            <a:pPr algn="l">
+              <a:defRPr sz="1500" b="1">
                 <a:solidFill>
                   <a:srgbClr val="2B5C9E"/>
                 </a:solidFill>
@@ -3666,7 +3666,7 @@
               </a:defRPr>
             </a:pPr>
             <a:r>
-              <a:rPr sz="1350" b="1">
+              <a:rPr sz="1500" b="1">
                 <a:solidFill>
                   <a:srgbClr val="2B5C9E"/>
                 </a:solidFill>
@@ -3674,7 +3674,7 @@
                 <a:ea typeface="Aptos"/>
                 <a:cs typeface="Aptos"/>
               </a:rPr>
-              <a:t>B Models</a:t>
+              <a:t>Presenter 2</a:t>
             </a:r>
           </a:p>
         </p:txBody>
@@ -3684,43 +3684,43 @@
           <p:cNvPr id="11" name="">
             <a:extLst xmlns:a="http://schemas.openxmlformats.org/drawingml/2006/main">
               <a:ext uri="{FF2B5EF4-FFF2-40B4-BE49-F238E27FC236}">
-                <a16:creationId xmlns:a16="http://schemas.microsoft.com/office/drawing/2014/main" id="{4D196DD1-96C7-46E9-9F47-52DAC4109A37}"/>
-              </a:ext>
-            </a:extLst>
-          </p:cNvPr>
-          <p:cNvSpPr>
-            <a:spLocks xmlns:a="http://schemas.openxmlformats.org/drawingml/2006/main" noGrp="1"/>
-          </p:cNvSpPr>
-          <p:nvPr/>
-        </p:nvSpPr>
-        <p:spPr>
-          <a:xfrm xmlns:a="http://schemas.openxmlformats.org/drawingml/2006/main">
-            <a:off x="3695700" y="2914650"/>
-            <a:ext cx="2095500" cy="476250"/>
-          </a:xfrm>
-          <a:prstGeom xmlns:a="http://schemas.openxmlformats.org/drawingml/2006/main" prst="rect">
-            <a:avLst/>
-          </a:prstGeom>
-          <a:solidFill xmlns:a="http://schemas.openxmlformats.org/drawingml/2006/main">
-            <a:srgbClr val="000000">
-              <a:alpha val="0"/>
-            </a:srgbClr>
-          </a:solidFill>
-          <a:ln xmlns:a="http://schemas.openxmlformats.org/drawingml/2006/main" w="0">
-            <a:solidFill>
-              <a:srgbClr val="000000">
-                <a:alpha val="0"/>
-              </a:srgbClr>
-            </a:solidFill>
-            <a:prstDash val="solid"/>
-          </a:ln>
-        </p:spPr>
-        <p:txBody>
-          <a:bodyPr xmlns:a="http://schemas.openxmlformats.org/drawingml/2006/main" lIns="0" tIns="0" rIns="0" bIns="0" anchor="t"/>
-          <a:lstStyle xmlns:a="http://schemas.openxmlformats.org/drawingml/2006/main"/>
-          <a:p xmlns:a="http://schemas.openxmlformats.org/drawingml/2006/main">
-            <a:pPr algn="l">
-              <a:defRPr sz="1050" b="0">
+                <a16:creationId xmlns:a16="http://schemas.microsoft.com/office/drawing/2014/main" id="{98367B62-EDC9-4CD3-9988-0361993AB8BB}"/>
+              </a:ext>
+            </a:extLst>
+          </p:cNvPr>
+          <p:cNvSpPr>
+            <a:spLocks xmlns:a="http://schemas.openxmlformats.org/drawingml/2006/main" noGrp="1"/>
+          </p:cNvSpPr>
+          <p:nvPr/>
+        </p:nvSpPr>
+        <p:spPr>
+          <a:xfrm xmlns:a="http://schemas.openxmlformats.org/drawingml/2006/main">
+            <a:off x="6400800" y="2914650"/>
+            <a:ext cx="4476750" cy="514350"/>
+          </a:xfrm>
+          <a:prstGeom xmlns:a="http://schemas.openxmlformats.org/drawingml/2006/main" prst="rect">
+            <a:avLst/>
+          </a:prstGeom>
+          <a:solidFill xmlns:a="http://schemas.openxmlformats.org/drawingml/2006/main">
+            <a:srgbClr val="000000">
+              <a:alpha val="0"/>
+            </a:srgbClr>
+          </a:solidFill>
+          <a:ln xmlns:a="http://schemas.openxmlformats.org/drawingml/2006/main" w="0">
+            <a:solidFill>
+              <a:srgbClr val="000000">
+                <a:alpha val="0"/>
+              </a:srgbClr>
+            </a:solidFill>
+            <a:prstDash val="solid"/>
+          </a:ln>
+        </p:spPr>
+        <p:txBody>
+          <a:bodyPr xmlns:a="http://schemas.openxmlformats.org/drawingml/2006/main" lIns="0" tIns="0" rIns="0" bIns="0" anchor="t"/>
+          <a:lstStyle xmlns:a="http://schemas.openxmlformats.org/drawingml/2006/main"/>
+          <a:p xmlns:a="http://schemas.openxmlformats.org/drawingml/2006/main">
+            <a:pPr algn="l">
+              <a:defRPr sz="1125" b="0">
                 <a:solidFill>
                   <a:srgbClr val="18201B"/>
                 </a:solidFill>
@@ -3730,7 +3730,7 @@
               </a:defRPr>
             </a:pPr>
             <a:r>
-              <a:rPr sz="1050" b="0">
+              <a:rPr sz="1125" b="0">
                 <a:solidFill>
                   <a:srgbClr val="18201B"/>
                 </a:solidFill>
@@ -3738,7 +3738,7 @@
                 <a:ea typeface="Aptos"/>
                 <a:cs typeface="Aptos"/>
               </a:rPr>
-              <a:t>Popularity, Category Popularity, ItemKNN, ALS, BPR</a:t>
+              <a:t>Slides 6-10: models, library acknowledgements, reranking design, experiments, demo, risks</a:t>
             </a:r>
           </a:p>
         </p:txBody>
@@ -3748,329 +3748,7 @@
           <p:cNvPr id="12" name="">
             <a:extLst xmlns:a="http://schemas.openxmlformats.org/drawingml/2006/main">
               <a:ext uri="{FF2B5EF4-FFF2-40B4-BE49-F238E27FC236}">
-                <a16:creationId xmlns:a16="http://schemas.microsoft.com/office/drawing/2014/main" id="{E39BE37B-166E-481C-A375-C71430DDCF28}"/>
-              </a:ext>
-            </a:extLst>
-          </p:cNvPr>
-          <p:cNvSpPr>
-            <a:spLocks xmlns:a="http://schemas.openxmlformats.org/drawingml/2006/main" noGrp="1"/>
-          </p:cNvSpPr>
-          <p:nvPr/>
-        </p:nvSpPr>
-        <p:spPr>
-          <a:xfrm xmlns:a="http://schemas.openxmlformats.org/drawingml/2006/main">
-            <a:off x="6381750" y="2266950"/>
-            <a:ext cx="2476500" cy="1352550"/>
-          </a:xfrm>
-          <a:prstGeom xmlns:a="http://schemas.openxmlformats.org/drawingml/2006/main" prst="rect">
-            <a:avLst/>
-          </a:prstGeom>
-          <a:solidFill xmlns:a="http://schemas.openxmlformats.org/drawingml/2006/main">
-            <a:srgbClr val="F5E7D2"/>
-          </a:solidFill>
-          <a:ln xmlns:a="http://schemas.openxmlformats.org/drawingml/2006/main" w="9525">
-            <a:solidFill>
-              <a:srgbClr val="B96F13"/>
-            </a:solidFill>
-            <a:prstDash val="solid"/>
-          </a:ln>
-        </p:spPr>
-      </p:sp>
-      <p:sp>
-        <p:nvSpPr>
-          <p:cNvPr id="13" name="">
-            <a:extLst xmlns:a="http://schemas.openxmlformats.org/drawingml/2006/main">
-              <a:ext uri="{FF2B5EF4-FFF2-40B4-BE49-F238E27FC236}">
-                <a16:creationId xmlns:a16="http://schemas.microsoft.com/office/drawing/2014/main" id="{9B5BDD51-B826-45FD-96D2-2B738F49A933}"/>
-              </a:ext>
-            </a:extLst>
-          </p:cNvPr>
-          <p:cNvSpPr>
-            <a:spLocks xmlns:a="http://schemas.openxmlformats.org/drawingml/2006/main" noGrp="1"/>
-          </p:cNvSpPr>
-          <p:nvPr/>
-        </p:nvSpPr>
-        <p:spPr>
-          <a:xfrm xmlns:a="http://schemas.openxmlformats.org/drawingml/2006/main">
-            <a:off x="6553200" y="2476500"/>
-            <a:ext cx="2000250" cy="228600"/>
-          </a:xfrm>
-          <a:prstGeom xmlns:a="http://schemas.openxmlformats.org/drawingml/2006/main" prst="rect">
-            <a:avLst/>
-          </a:prstGeom>
-          <a:solidFill xmlns:a="http://schemas.openxmlformats.org/drawingml/2006/main">
-            <a:srgbClr val="000000">
-              <a:alpha val="0"/>
-            </a:srgbClr>
-          </a:solidFill>
-          <a:ln xmlns:a="http://schemas.openxmlformats.org/drawingml/2006/main" w="0">
-            <a:solidFill>
-              <a:srgbClr val="000000">
-                <a:alpha val="0"/>
-              </a:srgbClr>
-            </a:solidFill>
-            <a:prstDash val="solid"/>
-          </a:ln>
-        </p:spPr>
-        <p:txBody>
-          <a:bodyPr xmlns:a="http://schemas.openxmlformats.org/drawingml/2006/main" lIns="0" tIns="0" rIns="0" bIns="0" anchor="t"/>
-          <a:lstStyle xmlns:a="http://schemas.openxmlformats.org/drawingml/2006/main"/>
-          <a:p xmlns:a="http://schemas.openxmlformats.org/drawingml/2006/main">
-            <a:pPr algn="l">
-              <a:defRPr sz="1350" b="1">
-                <a:solidFill>
-                  <a:srgbClr val="B96F13"/>
-                </a:solidFill>
-                <a:latin typeface="Aptos"/>
-                <a:ea typeface="Aptos"/>
-                <a:cs typeface="Aptos"/>
-              </a:defRPr>
-            </a:pPr>
-            <a:r>
-              <a:rPr sz="1350" b="1">
-                <a:solidFill>
-                  <a:srgbClr val="B96F13"/>
-                </a:solidFill>
-                <a:latin typeface="Aptos"/>
-                <a:ea typeface="Aptos"/>
-                <a:cs typeface="Aptos"/>
-              </a:rPr>
-              <a:t>C Reranking</a:t>
-            </a:r>
-          </a:p>
-        </p:txBody>
-      </p:sp>
-      <p:sp>
-        <p:nvSpPr>
-          <p:cNvPr id="14" name="">
-            <a:extLst xmlns:a="http://schemas.openxmlformats.org/drawingml/2006/main">
-              <a:ext uri="{FF2B5EF4-FFF2-40B4-BE49-F238E27FC236}">
-                <a16:creationId xmlns:a16="http://schemas.microsoft.com/office/drawing/2014/main" id="{BF201CAB-4356-4DAA-BFA5-F7AD8E8B68D1}"/>
-              </a:ext>
-            </a:extLst>
-          </p:cNvPr>
-          <p:cNvSpPr>
-            <a:spLocks xmlns:a="http://schemas.openxmlformats.org/drawingml/2006/main" noGrp="1"/>
-          </p:cNvSpPr>
-          <p:nvPr/>
-        </p:nvSpPr>
-        <p:spPr>
-          <a:xfrm xmlns:a="http://schemas.openxmlformats.org/drawingml/2006/main">
-            <a:off x="6553200" y="2914650"/>
-            <a:ext cx="2095500" cy="476250"/>
-          </a:xfrm>
-          <a:prstGeom xmlns:a="http://schemas.openxmlformats.org/drawingml/2006/main" prst="rect">
-            <a:avLst/>
-          </a:prstGeom>
-          <a:solidFill xmlns:a="http://schemas.openxmlformats.org/drawingml/2006/main">
-            <a:srgbClr val="000000">
-              <a:alpha val="0"/>
-            </a:srgbClr>
-          </a:solidFill>
-          <a:ln xmlns:a="http://schemas.openxmlformats.org/drawingml/2006/main" w="0">
-            <a:solidFill>
-              <a:srgbClr val="000000">
-                <a:alpha val="0"/>
-              </a:srgbClr>
-            </a:solidFill>
-            <a:prstDash val="solid"/>
-          </a:ln>
-        </p:spPr>
-        <p:txBody>
-          <a:bodyPr xmlns:a="http://schemas.openxmlformats.org/drawingml/2006/main" lIns="0" tIns="0" rIns="0" bIns="0" anchor="t"/>
-          <a:lstStyle xmlns:a="http://schemas.openxmlformats.org/drawingml/2006/main"/>
-          <a:p xmlns:a="http://schemas.openxmlformats.org/drawingml/2006/main">
-            <a:pPr algn="l">
-              <a:defRPr sz="1050" b="0">
-                <a:solidFill>
-                  <a:srgbClr val="18201B"/>
-                </a:solidFill>
-                <a:latin typeface="Aptos"/>
-                <a:ea typeface="Aptos"/>
-                <a:cs typeface="Aptos"/>
-              </a:defRPr>
-            </a:pPr>
-            <a:r>
-              <a:rPr sz="1050" b="0">
-                <a:solidFill>
-                  <a:srgbClr val="18201B"/>
-                </a:solidFill>
-                <a:latin typeface="Aptos"/>
-                <a:ea typeface="Aptos"/>
-                <a:cs typeface="Aptos"/>
-              </a:rPr>
-              <a:t>Promotion/coupon features, discount proxy, Business Utility</a:t>
-            </a:r>
-          </a:p>
-        </p:txBody>
-      </p:sp>
-      <p:sp>
-        <p:nvSpPr>
-          <p:cNvPr id="15" name="">
-            <a:extLst xmlns:a="http://schemas.openxmlformats.org/drawingml/2006/main">
-              <a:ext uri="{FF2B5EF4-FFF2-40B4-BE49-F238E27FC236}">
-                <a16:creationId xmlns:a16="http://schemas.microsoft.com/office/drawing/2014/main" id="{40C493A7-90E5-4A5D-A4A1-35A23E5752C4}"/>
-              </a:ext>
-            </a:extLst>
-          </p:cNvPr>
-          <p:cNvSpPr>
-            <a:spLocks xmlns:a="http://schemas.openxmlformats.org/drawingml/2006/main" noGrp="1"/>
-          </p:cNvSpPr>
-          <p:nvPr/>
-        </p:nvSpPr>
-        <p:spPr>
-          <a:xfrm xmlns:a="http://schemas.openxmlformats.org/drawingml/2006/main">
-            <a:off x="9239250" y="2266950"/>
-            <a:ext cx="2476500" cy="1352550"/>
-          </a:xfrm>
-          <a:prstGeom xmlns:a="http://schemas.openxmlformats.org/drawingml/2006/main" prst="rect">
-            <a:avLst/>
-          </a:prstGeom>
-          <a:solidFill xmlns:a="http://schemas.openxmlformats.org/drawingml/2006/main">
-            <a:srgbClr val="F0DDDB"/>
-          </a:solidFill>
-          <a:ln xmlns:a="http://schemas.openxmlformats.org/drawingml/2006/main" w="9525">
-            <a:solidFill>
-              <a:srgbClr val="9C3B38"/>
-            </a:solidFill>
-            <a:prstDash val="solid"/>
-          </a:ln>
-        </p:spPr>
-      </p:sp>
-      <p:sp>
-        <p:nvSpPr>
-          <p:cNvPr id="16" name="">
-            <a:extLst xmlns:a="http://schemas.openxmlformats.org/drawingml/2006/main">
-              <a:ext uri="{FF2B5EF4-FFF2-40B4-BE49-F238E27FC236}">
-                <a16:creationId xmlns:a16="http://schemas.microsoft.com/office/drawing/2014/main" id="{0D698401-077E-42B6-8796-B54CC969EAAE}"/>
-              </a:ext>
-            </a:extLst>
-          </p:cNvPr>
-          <p:cNvSpPr>
-            <a:spLocks xmlns:a="http://schemas.openxmlformats.org/drawingml/2006/main" noGrp="1"/>
-          </p:cNvSpPr>
-          <p:nvPr/>
-        </p:nvSpPr>
-        <p:spPr>
-          <a:xfrm xmlns:a="http://schemas.openxmlformats.org/drawingml/2006/main">
-            <a:off x="9410700" y="2476500"/>
-            <a:ext cx="2000250" cy="228600"/>
-          </a:xfrm>
-          <a:prstGeom xmlns:a="http://schemas.openxmlformats.org/drawingml/2006/main" prst="rect">
-            <a:avLst/>
-          </a:prstGeom>
-          <a:solidFill xmlns:a="http://schemas.openxmlformats.org/drawingml/2006/main">
-            <a:srgbClr val="000000">
-              <a:alpha val="0"/>
-            </a:srgbClr>
-          </a:solidFill>
-          <a:ln xmlns:a="http://schemas.openxmlformats.org/drawingml/2006/main" w="0">
-            <a:solidFill>
-              <a:srgbClr val="000000">
-                <a:alpha val="0"/>
-              </a:srgbClr>
-            </a:solidFill>
-            <a:prstDash val="solid"/>
-          </a:ln>
-        </p:spPr>
-        <p:txBody>
-          <a:bodyPr xmlns:a="http://schemas.openxmlformats.org/drawingml/2006/main" lIns="0" tIns="0" rIns="0" bIns="0" anchor="t"/>
-          <a:lstStyle xmlns:a="http://schemas.openxmlformats.org/drawingml/2006/main"/>
-          <a:p xmlns:a="http://schemas.openxmlformats.org/drawingml/2006/main">
-            <a:pPr algn="l">
-              <a:defRPr sz="1350" b="1">
-                <a:solidFill>
-                  <a:srgbClr val="9C3B38"/>
-                </a:solidFill>
-                <a:latin typeface="Aptos"/>
-                <a:ea typeface="Aptos"/>
-                <a:cs typeface="Aptos"/>
-              </a:defRPr>
-            </a:pPr>
-            <a:r>
-              <a:rPr sz="1350" b="1">
-                <a:solidFill>
-                  <a:srgbClr val="9C3B38"/>
-                </a:solidFill>
-                <a:latin typeface="Aptos"/>
-                <a:ea typeface="Aptos"/>
-                <a:cs typeface="Aptos"/>
-              </a:rPr>
-              <a:t>D Integration</a:t>
-            </a:r>
-          </a:p>
-        </p:txBody>
-      </p:sp>
-      <p:sp>
-        <p:nvSpPr>
-          <p:cNvPr id="17" name="">
-            <a:extLst xmlns:a="http://schemas.openxmlformats.org/drawingml/2006/main">
-              <a:ext uri="{FF2B5EF4-FFF2-40B4-BE49-F238E27FC236}">
-                <a16:creationId xmlns:a16="http://schemas.microsoft.com/office/drawing/2014/main" id="{1302603A-3869-4391-8FFC-DBD9DCB0E089}"/>
-              </a:ext>
-            </a:extLst>
-          </p:cNvPr>
-          <p:cNvSpPr>
-            <a:spLocks xmlns:a="http://schemas.openxmlformats.org/drawingml/2006/main" noGrp="1"/>
-          </p:cNvSpPr>
-          <p:nvPr/>
-        </p:nvSpPr>
-        <p:spPr>
-          <a:xfrm xmlns:a="http://schemas.openxmlformats.org/drawingml/2006/main">
-            <a:off x="9410700" y="2914650"/>
-            <a:ext cx="2095500" cy="476250"/>
-          </a:xfrm>
-          <a:prstGeom xmlns:a="http://schemas.openxmlformats.org/drawingml/2006/main" prst="rect">
-            <a:avLst/>
-          </a:prstGeom>
-          <a:solidFill xmlns:a="http://schemas.openxmlformats.org/drawingml/2006/main">
-            <a:srgbClr val="000000">
-              <a:alpha val="0"/>
-            </a:srgbClr>
-          </a:solidFill>
-          <a:ln xmlns:a="http://schemas.openxmlformats.org/drawingml/2006/main" w="0">
-            <a:solidFill>
-              <a:srgbClr val="000000">
-                <a:alpha val="0"/>
-              </a:srgbClr>
-            </a:solidFill>
-            <a:prstDash val="solid"/>
-          </a:ln>
-        </p:spPr>
-        <p:txBody>
-          <a:bodyPr xmlns:a="http://schemas.openxmlformats.org/drawingml/2006/main" lIns="0" tIns="0" rIns="0" bIns="0" anchor="t"/>
-          <a:lstStyle xmlns:a="http://schemas.openxmlformats.org/drawingml/2006/main"/>
-          <a:p xmlns:a="http://schemas.openxmlformats.org/drawingml/2006/main">
-            <a:pPr algn="l">
-              <a:defRPr sz="1050" b="0">
-                <a:solidFill>
-                  <a:srgbClr val="18201B"/>
-                </a:solidFill>
-                <a:latin typeface="Aptos"/>
-                <a:ea typeface="Aptos"/>
-                <a:cs typeface="Aptos"/>
-              </a:defRPr>
-            </a:pPr>
-            <a:r>
-              <a:rPr sz="1050" b="0">
-                <a:solidFill>
-                  <a:srgbClr val="18201B"/>
-                </a:solidFill>
-                <a:latin typeface="Aptos"/>
-                <a:ea typeface="Aptos"/>
-                <a:cs typeface="Aptos"/>
-              </a:rPr>
-              <a:t>Architecture, Streamlit demo, optional LightGCN, final deck</a:t>
-            </a:r>
-          </a:p>
-        </p:txBody>
-      </p:sp>
-      <p:sp>
-        <p:nvSpPr>
-          <p:cNvPr id="18" name="">
-            <a:extLst xmlns:a="http://schemas.openxmlformats.org/drawingml/2006/main">
-              <a:ext uri="{FF2B5EF4-FFF2-40B4-BE49-F238E27FC236}">
-                <a16:creationId xmlns:a16="http://schemas.microsoft.com/office/drawing/2014/main" id="{CAC09FDA-C40D-44D0-82E3-7CB57215420F}"/>
+                <a16:creationId xmlns:a16="http://schemas.microsoft.com/office/drawing/2014/main" id="{8804F81C-C710-40DB-B1A2-ACC83233EDA2}"/>
               </a:ext>
             </a:extLst>
           </p:cNvPr>
@@ -4100,10 +3778,10 @@
       </p:sp>
       <p:sp>
         <p:nvSpPr>
-          <p:cNvPr id="19" name="">
-            <a:extLst xmlns:a="http://schemas.openxmlformats.org/drawingml/2006/main">
-              <a:ext uri="{FF2B5EF4-FFF2-40B4-BE49-F238E27FC236}">
-                <a16:creationId xmlns:a16="http://schemas.microsoft.com/office/drawing/2014/main" id="{4829A086-F473-415E-896E-8FCFBCB00C55}"/>
+          <p:cNvPr id="13" name="">
+            <a:extLst xmlns:a="http://schemas.openxmlformats.org/drawingml/2006/main">
+              <a:ext uri="{FF2B5EF4-FFF2-40B4-BE49-F238E27FC236}">
+                <a16:creationId xmlns:a16="http://schemas.microsoft.com/office/drawing/2014/main" id="{A3E60AA0-D84D-4344-8D4C-2223DFC99119}"/>
               </a:ext>
             </a:extLst>
           </p:cNvPr>
@@ -4133,10 +3811,10 @@
       </p:sp>
       <p:sp>
         <p:nvSpPr>
-          <p:cNvPr id="20" name="">
-            <a:extLst xmlns:a="http://schemas.openxmlformats.org/drawingml/2006/main">
-              <a:ext uri="{FF2B5EF4-FFF2-40B4-BE49-F238E27FC236}">
-                <a16:creationId xmlns:a16="http://schemas.microsoft.com/office/drawing/2014/main" id="{3BECF618-8F76-47A2-86FC-97FAFA7860C1}"/>
+          <p:cNvPr id="14" name="">
+            <a:extLst xmlns:a="http://schemas.openxmlformats.org/drawingml/2006/main">
+              <a:ext uri="{FF2B5EF4-FFF2-40B4-BE49-F238E27FC236}">
+                <a16:creationId xmlns:a16="http://schemas.microsoft.com/office/drawing/2014/main" id="{2609C248-15B7-482F-B2BD-7D9F3612385F}"/>
               </a:ext>
             </a:extLst>
           </p:cNvPr>
@@ -4197,10 +3875,10 @@
       </p:sp>
       <p:sp>
         <p:nvSpPr>
-          <p:cNvPr id="21" name="">
-            <a:extLst xmlns:a="http://schemas.openxmlformats.org/drawingml/2006/main">
-              <a:ext uri="{FF2B5EF4-FFF2-40B4-BE49-F238E27FC236}">
-                <a16:creationId xmlns:a16="http://schemas.microsoft.com/office/drawing/2014/main" id="{EA0F9702-2202-45CA-8AC7-CDB8DE29F02A}"/>
+          <p:cNvPr id="15" name="">
+            <a:extLst xmlns:a="http://schemas.openxmlformats.org/drawingml/2006/main">
+              <a:ext uri="{FF2B5EF4-FFF2-40B4-BE49-F238E27FC236}">
+                <a16:creationId xmlns:a16="http://schemas.microsoft.com/office/drawing/2014/main" id="{6B49B9EC-2E08-4FE6-9888-F1CD7F932B2A}"/>
               </a:ext>
             </a:extLst>
           </p:cNvPr>
@@ -4232,10 +3910,10 @@
       </p:sp>
       <p:sp>
         <p:nvSpPr>
-          <p:cNvPr id="22" name="">
-            <a:extLst xmlns:a="http://schemas.openxmlformats.org/drawingml/2006/main">
-              <a:ext uri="{FF2B5EF4-FFF2-40B4-BE49-F238E27FC236}">
-                <a16:creationId xmlns:a16="http://schemas.microsoft.com/office/drawing/2014/main" id="{26A16282-517F-4C95-9A38-6FEB1A5409EA}"/>
+          <p:cNvPr id="16" name="">
+            <a:extLst xmlns:a="http://schemas.openxmlformats.org/drawingml/2006/main">
+              <a:ext uri="{FF2B5EF4-FFF2-40B4-BE49-F238E27FC236}">
+                <a16:creationId xmlns:a16="http://schemas.microsoft.com/office/drawing/2014/main" id="{9315056A-F3E8-466B-AA7E-2D22FEDADECF}"/>
               </a:ext>
             </a:extLst>
           </p:cNvPr>
@@ -4296,10 +3974,10 @@
       </p:sp>
       <p:sp>
         <p:nvSpPr>
-          <p:cNvPr id="23" name="">
-            <a:extLst xmlns:a="http://schemas.openxmlformats.org/drawingml/2006/main">
-              <a:ext uri="{FF2B5EF4-FFF2-40B4-BE49-F238E27FC236}">
-                <a16:creationId xmlns:a16="http://schemas.microsoft.com/office/drawing/2014/main" id="{0E85F0FA-60CB-411F-BB04-7F027B49F097}"/>
+          <p:cNvPr id="17" name="">
+            <a:extLst xmlns:a="http://schemas.openxmlformats.org/drawingml/2006/main">
+              <a:ext uri="{FF2B5EF4-FFF2-40B4-BE49-F238E27FC236}">
+                <a16:creationId xmlns:a16="http://schemas.microsoft.com/office/drawing/2014/main" id="{A5CB4C94-5006-479A-8C2B-80463E9B0831}"/>
               </a:ext>
             </a:extLst>
           </p:cNvPr>
@@ -4331,10 +4009,10 @@
       </p:sp>
       <p:sp>
         <p:nvSpPr>
-          <p:cNvPr id="24" name="">
-            <a:extLst xmlns:a="http://schemas.openxmlformats.org/drawingml/2006/main">
-              <a:ext uri="{FF2B5EF4-FFF2-40B4-BE49-F238E27FC236}">
-                <a16:creationId xmlns:a16="http://schemas.microsoft.com/office/drawing/2014/main" id="{3683E769-BE0D-495E-8568-3453C12BCE0E}"/>
+          <p:cNvPr id="18" name="">
+            <a:extLst xmlns:a="http://schemas.openxmlformats.org/drawingml/2006/main">
+              <a:ext uri="{FF2B5EF4-FFF2-40B4-BE49-F238E27FC236}">
+                <a16:creationId xmlns:a16="http://schemas.microsoft.com/office/drawing/2014/main" id="{1561036E-F452-4B84-A028-570489006776}"/>
               </a:ext>
             </a:extLst>
           </p:cNvPr>
@@ -4395,10 +4073,10 @@
       </p:sp>
       <p:sp>
         <p:nvSpPr>
-          <p:cNvPr id="25" name="">
-            <a:extLst xmlns:a="http://schemas.openxmlformats.org/drawingml/2006/main">
-              <a:ext uri="{FF2B5EF4-FFF2-40B4-BE49-F238E27FC236}">
-                <a16:creationId xmlns:a16="http://schemas.microsoft.com/office/drawing/2014/main" id="{5093DEA5-1777-4D7C-9757-29CA3D17D838}"/>
+          <p:cNvPr id="19" name="">
+            <a:extLst xmlns:a="http://schemas.openxmlformats.org/drawingml/2006/main">
+              <a:ext uri="{FF2B5EF4-FFF2-40B4-BE49-F238E27FC236}">
+                <a16:creationId xmlns:a16="http://schemas.microsoft.com/office/drawing/2014/main" id="{2B50B171-59A2-42BA-BAE9-90855359F306}"/>
               </a:ext>
             </a:extLst>
           </p:cNvPr>
@@ -4430,10 +4108,10 @@
       </p:sp>
       <p:sp>
         <p:nvSpPr>
-          <p:cNvPr id="26" name="">
-            <a:extLst xmlns:a="http://schemas.openxmlformats.org/drawingml/2006/main">
-              <a:ext uri="{FF2B5EF4-FFF2-40B4-BE49-F238E27FC236}">
-                <a16:creationId xmlns:a16="http://schemas.microsoft.com/office/drawing/2014/main" id="{21E81C82-2D37-4B17-8F71-ED9E03830D33}"/>
+          <p:cNvPr id="20" name="">
+            <a:extLst xmlns:a="http://schemas.openxmlformats.org/drawingml/2006/main">
+              <a:ext uri="{FF2B5EF4-FFF2-40B4-BE49-F238E27FC236}">
+                <a16:creationId xmlns:a16="http://schemas.microsoft.com/office/drawing/2014/main" id="{3B9EBAD8-99E8-4B63-82E4-78DB2F220880}"/>
               </a:ext>
             </a:extLst>
           </p:cNvPr>
@@ -4494,10 +4172,10 @@
       </p:sp>
       <p:sp>
         <p:nvSpPr>
-          <p:cNvPr id="27" name="">
-            <a:extLst xmlns:a="http://schemas.openxmlformats.org/drawingml/2006/main">
-              <a:ext uri="{FF2B5EF4-FFF2-40B4-BE49-F238E27FC236}">
-                <a16:creationId xmlns:a16="http://schemas.microsoft.com/office/drawing/2014/main" id="{E94AC61C-A9AA-4EE0-8E06-48BB561D21FD}"/>
+          <p:cNvPr id="21" name="">
+            <a:extLst xmlns:a="http://schemas.openxmlformats.org/drawingml/2006/main">
+              <a:ext uri="{FF2B5EF4-FFF2-40B4-BE49-F238E27FC236}">
+                <a16:creationId xmlns:a16="http://schemas.microsoft.com/office/drawing/2014/main" id="{BA4982E1-D59E-4BA7-BA3D-F454CCEF17DC}"/>
               </a:ext>
             </a:extLst>
           </p:cNvPr>
@@ -4529,10 +4207,10 @@
       </p:sp>
       <p:sp>
         <p:nvSpPr>
-          <p:cNvPr id="28" name="">
-            <a:extLst xmlns:a="http://schemas.openxmlformats.org/drawingml/2006/main">
-              <a:ext uri="{FF2B5EF4-FFF2-40B4-BE49-F238E27FC236}">
-                <a16:creationId xmlns:a16="http://schemas.microsoft.com/office/drawing/2014/main" id="{881F3B8A-4781-453B-AAEB-DD4D124F0137}"/>
+          <p:cNvPr id="22" name="">
+            <a:extLst xmlns:a="http://schemas.openxmlformats.org/drawingml/2006/main">
+              <a:ext uri="{FF2B5EF4-FFF2-40B4-BE49-F238E27FC236}">
+                <a16:creationId xmlns:a16="http://schemas.microsoft.com/office/drawing/2014/main" id="{CC97E024-FE24-4D5A-A999-46590D19EA46}"/>
               </a:ext>
             </a:extLst>
           </p:cNvPr>
@@ -4593,10 +4271,10 @@
       </p:sp>
       <p:sp>
         <p:nvSpPr>
-          <p:cNvPr id="29" name="">
-            <a:extLst xmlns:a="http://schemas.openxmlformats.org/drawingml/2006/main">
-              <a:ext uri="{FF2B5EF4-FFF2-40B4-BE49-F238E27FC236}">
-                <a16:creationId xmlns:a16="http://schemas.microsoft.com/office/drawing/2014/main" id="{7F5575FA-70ED-40CC-91A9-7F46F5E6C7D3}"/>
+          <p:cNvPr id="23" name="">
+            <a:extLst xmlns:a="http://schemas.openxmlformats.org/drawingml/2006/main">
+              <a:ext uri="{FF2B5EF4-FFF2-40B4-BE49-F238E27FC236}">
+                <a16:creationId xmlns:a16="http://schemas.microsoft.com/office/drawing/2014/main" id="{17FCBC0B-A861-4744-A585-819F061086B1}"/>
               </a:ext>
             </a:extLst>
           </p:cNvPr>
@@ -4628,10 +4306,10 @@
       </p:sp>
       <p:sp>
         <p:nvSpPr>
-          <p:cNvPr id="30" name="">
-            <a:extLst xmlns:a="http://schemas.openxmlformats.org/drawingml/2006/main">
-              <a:ext uri="{FF2B5EF4-FFF2-40B4-BE49-F238E27FC236}">
-                <a16:creationId xmlns:a16="http://schemas.microsoft.com/office/drawing/2014/main" id="{9C3C15CD-B3A2-42F5-B460-1E8692CC87D6}"/>
+          <p:cNvPr id="24" name="">
+            <a:extLst xmlns:a="http://schemas.openxmlformats.org/drawingml/2006/main">
+              <a:ext uri="{FF2B5EF4-FFF2-40B4-BE49-F238E27FC236}">
+                <a16:creationId xmlns:a16="http://schemas.microsoft.com/office/drawing/2014/main" id="{E7F5C008-A670-404F-BA36-DE61AA60604E}"/>
               </a:ext>
             </a:extLst>
           </p:cNvPr>
@@ -4692,10 +4370,10 @@
       </p:sp>
       <p:sp>
         <p:nvSpPr>
-          <p:cNvPr id="31" name="">
-            <a:extLst xmlns:a="http://schemas.openxmlformats.org/drawingml/2006/main">
-              <a:ext uri="{FF2B5EF4-FFF2-40B4-BE49-F238E27FC236}">
-                <a16:creationId xmlns:a16="http://schemas.microsoft.com/office/drawing/2014/main" id="{D35541A9-F325-4FFF-8E8A-0C51EDDF4E66}"/>
+          <p:cNvPr id="25" name="">
+            <a:extLst xmlns:a="http://schemas.openxmlformats.org/drawingml/2006/main">
+              <a:ext uri="{FF2B5EF4-FFF2-40B4-BE49-F238E27FC236}">
+                <a16:creationId xmlns:a16="http://schemas.microsoft.com/office/drawing/2014/main" id="{D3D03E89-66A0-4CD1-BAA0-0C3D8AA89709}"/>
               </a:ext>
             </a:extLst>
           </p:cNvPr>
@@ -4725,10 +4403,10 @@
       </p:sp>
       <p:sp>
         <p:nvSpPr>
-          <p:cNvPr id="32" name="">
-            <a:extLst xmlns:a="http://schemas.openxmlformats.org/drawingml/2006/main">
-              <a:ext uri="{FF2B5EF4-FFF2-40B4-BE49-F238E27FC236}">
-                <a16:creationId xmlns:a16="http://schemas.microsoft.com/office/drawing/2014/main" id="{25EA8141-4DA3-45DC-946C-EDE133498D7D}"/>
+          <p:cNvPr id="26" name="">
+            <a:extLst xmlns:a="http://schemas.openxmlformats.org/drawingml/2006/main">
+              <a:ext uri="{FF2B5EF4-FFF2-40B4-BE49-F238E27FC236}">
+                <a16:creationId xmlns:a16="http://schemas.microsoft.com/office/drawing/2014/main" id="{F28B7187-32F6-432B-8AE0-9B66AED6B527}"/>
               </a:ext>
             </a:extLst>
           </p:cNvPr>
@@ -4758,10 +4436,10 @@
       </p:sp>
       <p:sp>
         <p:nvSpPr>
-          <p:cNvPr id="33" name="">
-            <a:extLst xmlns:a="http://schemas.openxmlformats.org/drawingml/2006/main">
-              <a:ext uri="{FF2B5EF4-FFF2-40B4-BE49-F238E27FC236}">
-                <a16:creationId xmlns:a16="http://schemas.microsoft.com/office/drawing/2014/main" id="{35B4D08C-AE48-4C14-8423-02D75C45E184}"/>
+          <p:cNvPr id="27" name="">
+            <a:extLst xmlns:a="http://schemas.openxmlformats.org/drawingml/2006/main">
+              <a:ext uri="{FF2B5EF4-FFF2-40B4-BE49-F238E27FC236}">
+                <a16:creationId xmlns:a16="http://schemas.microsoft.com/office/drawing/2014/main" id="{512CC481-E70C-454E-82EE-D51956486327}"/>
               </a:ext>
             </a:extLst>
           </p:cNvPr>
@@ -4822,10 +4500,10 @@
       </p:sp>
       <p:sp>
         <p:nvSpPr>
-          <p:cNvPr id="34" name="">
-            <a:extLst xmlns:a="http://schemas.openxmlformats.org/drawingml/2006/main">
-              <a:ext uri="{FF2B5EF4-FFF2-40B4-BE49-F238E27FC236}">
-                <a16:creationId xmlns:a16="http://schemas.microsoft.com/office/drawing/2014/main" id="{B2B40D2D-92F5-4330-9959-5B6AFB8EF25F}"/>
+          <p:cNvPr id="28" name="">
+            <a:extLst xmlns:a="http://schemas.openxmlformats.org/drawingml/2006/main">
+              <a:ext uri="{FF2B5EF4-FFF2-40B4-BE49-F238E27FC236}">
+                <a16:creationId xmlns:a16="http://schemas.microsoft.com/office/drawing/2014/main" id="{DB69FC0D-DE65-4547-AF87-05253691700A}"/>
               </a:ext>
             </a:extLst>
           </p:cNvPr>
@@ -4857,10 +4535,10 @@
       </p:sp>
       <p:sp>
         <p:nvSpPr>
-          <p:cNvPr id="35" name="">
-            <a:extLst xmlns:a="http://schemas.openxmlformats.org/drawingml/2006/main">
-              <a:ext uri="{FF2B5EF4-FFF2-40B4-BE49-F238E27FC236}">
-                <a16:creationId xmlns:a16="http://schemas.microsoft.com/office/drawing/2014/main" id="{211C35E0-F144-4A40-AB23-6DCD9026AB6F}"/>
+          <p:cNvPr id="29" name="">
+            <a:extLst xmlns:a="http://schemas.openxmlformats.org/drawingml/2006/main">
+              <a:ext uri="{FF2B5EF4-FFF2-40B4-BE49-F238E27FC236}">
+                <a16:creationId xmlns:a16="http://schemas.microsoft.com/office/drawing/2014/main" id="{7A81FEFB-0147-428D-ABE8-F9036B40BEE2}"/>
               </a:ext>
             </a:extLst>
           </p:cNvPr>
@@ -4921,10 +4599,10 @@
       </p:sp>
       <p:sp>
         <p:nvSpPr>
-          <p:cNvPr id="36" name="">
-            <a:extLst xmlns:a="http://schemas.openxmlformats.org/drawingml/2006/main">
-              <a:ext uri="{FF2B5EF4-FFF2-40B4-BE49-F238E27FC236}">
-                <a16:creationId xmlns:a16="http://schemas.microsoft.com/office/drawing/2014/main" id="{702AB968-31A4-4901-951F-6AAC0EAF2FEE}"/>
+          <p:cNvPr id="30" name="">
+            <a:extLst xmlns:a="http://schemas.openxmlformats.org/drawingml/2006/main">
+              <a:ext uri="{FF2B5EF4-FFF2-40B4-BE49-F238E27FC236}">
+                <a16:creationId xmlns:a16="http://schemas.microsoft.com/office/drawing/2014/main" id="{CD9F06DD-B908-4562-84A1-59D01DAFD622}"/>
               </a:ext>
             </a:extLst>
           </p:cNvPr>
@@ -4956,10 +4634,10 @@
       </p:sp>
       <p:sp>
         <p:nvSpPr>
-          <p:cNvPr id="37" name="">
-            <a:extLst xmlns:a="http://schemas.openxmlformats.org/drawingml/2006/main">
-              <a:ext uri="{FF2B5EF4-FFF2-40B4-BE49-F238E27FC236}">
-                <a16:creationId xmlns:a16="http://schemas.microsoft.com/office/drawing/2014/main" id="{8BCC5D15-2A0E-4874-BD8D-E4EFD80AD838}"/>
+          <p:cNvPr id="31" name="">
+            <a:extLst xmlns:a="http://schemas.openxmlformats.org/drawingml/2006/main">
+              <a:ext uri="{FF2B5EF4-FFF2-40B4-BE49-F238E27FC236}">
+                <a16:creationId xmlns:a16="http://schemas.microsoft.com/office/drawing/2014/main" id="{0E44C147-469D-4475-A673-B055D385A77D}"/>
               </a:ext>
             </a:extLst>
           </p:cNvPr>
@@ -5020,10 +4698,10 @@
       </p:sp>
       <p:sp>
         <p:nvSpPr>
-          <p:cNvPr id="38" name="">
-            <a:extLst xmlns:a="http://schemas.openxmlformats.org/drawingml/2006/main">
-              <a:ext uri="{FF2B5EF4-FFF2-40B4-BE49-F238E27FC236}">
-                <a16:creationId xmlns:a16="http://schemas.microsoft.com/office/drawing/2014/main" id="{544CC54B-2CCC-4922-A551-C269D26D6329}"/>
+          <p:cNvPr id="32" name="">
+            <a:extLst xmlns:a="http://schemas.openxmlformats.org/drawingml/2006/main">
+              <a:ext uri="{FF2B5EF4-FFF2-40B4-BE49-F238E27FC236}">
+                <a16:creationId xmlns:a16="http://schemas.microsoft.com/office/drawing/2014/main" id="{479511B3-0D40-46ED-9675-06BC78C74D35}"/>
               </a:ext>
             </a:extLst>
           </p:cNvPr>
@@ -5055,10 +4733,10 @@
       </p:sp>
       <p:sp>
         <p:nvSpPr>
-          <p:cNvPr id="39" name="">
-            <a:extLst xmlns:a="http://schemas.openxmlformats.org/drawingml/2006/main">
-              <a:ext uri="{FF2B5EF4-FFF2-40B4-BE49-F238E27FC236}">
-                <a16:creationId xmlns:a16="http://schemas.microsoft.com/office/drawing/2014/main" id="{AD5855EA-9EAC-463A-A48C-E159E62BAB7F}"/>
+          <p:cNvPr id="33" name="">
+            <a:extLst xmlns:a="http://schemas.openxmlformats.org/drawingml/2006/main">
+              <a:ext uri="{FF2B5EF4-FFF2-40B4-BE49-F238E27FC236}">
+                <a16:creationId xmlns:a16="http://schemas.microsoft.com/office/drawing/2014/main" id="{239E88CD-5411-4021-A395-28F4C70C6F60}"/>
               </a:ext>
             </a:extLst>
           </p:cNvPr>
@@ -5119,10 +4797,10 @@
       </p:sp>
       <p:sp>
         <p:nvSpPr>
-          <p:cNvPr id="40" name="">
-            <a:extLst xmlns:a="http://schemas.openxmlformats.org/drawingml/2006/main">
-              <a:ext uri="{FF2B5EF4-FFF2-40B4-BE49-F238E27FC236}">
-                <a16:creationId xmlns:a16="http://schemas.microsoft.com/office/drawing/2014/main" id="{72B3AE49-7E7C-4245-B9E3-9F47CEC0B679}"/>
+          <p:cNvPr id="34" name="">
+            <a:extLst xmlns:a="http://schemas.openxmlformats.org/drawingml/2006/main">
+              <a:ext uri="{FF2B5EF4-FFF2-40B4-BE49-F238E27FC236}">
+                <a16:creationId xmlns:a16="http://schemas.microsoft.com/office/drawing/2014/main" id="{97545360-9984-487F-A310-488FF22965C6}"/>
               </a:ext>
             </a:extLst>
           </p:cNvPr>
@@ -5154,10 +4832,10 @@
       </p:sp>
       <p:sp>
         <p:nvSpPr>
-          <p:cNvPr id="41" name="">
-            <a:extLst xmlns:a="http://schemas.openxmlformats.org/drawingml/2006/main">
-              <a:ext uri="{FF2B5EF4-FFF2-40B4-BE49-F238E27FC236}">
-                <a16:creationId xmlns:a16="http://schemas.microsoft.com/office/drawing/2014/main" id="{893DAB6C-1D6B-4225-9D8E-73938FD0AA17}"/>
+          <p:cNvPr id="35" name="">
+            <a:extLst xmlns:a="http://schemas.openxmlformats.org/drawingml/2006/main">
+              <a:ext uri="{FF2B5EF4-FFF2-40B4-BE49-F238E27FC236}">
+                <a16:creationId xmlns:a16="http://schemas.microsoft.com/office/drawing/2014/main" id="{140A917F-8FD4-40DF-AB3A-02F7D144E06A}"/>
               </a:ext>
             </a:extLst>
           </p:cNvPr>
@@ -5218,10 +4896,10 @@
       </p:sp>
       <p:sp>
         <p:nvSpPr>
-          <p:cNvPr id="42" name="">
-            <a:extLst xmlns:a="http://schemas.openxmlformats.org/drawingml/2006/main">
-              <a:ext uri="{FF2B5EF4-FFF2-40B4-BE49-F238E27FC236}">
-                <a16:creationId xmlns:a16="http://schemas.microsoft.com/office/drawing/2014/main" id="{88A0FB85-9122-486B-8482-8F77388A48B7}"/>
+          <p:cNvPr id="36" name="">
+            <a:extLst xmlns:a="http://schemas.openxmlformats.org/drawingml/2006/main">
+              <a:ext uri="{FF2B5EF4-FFF2-40B4-BE49-F238E27FC236}">
+                <a16:creationId xmlns:a16="http://schemas.microsoft.com/office/drawing/2014/main" id="{58E45C1A-63A9-4BCB-B51D-B509C2577252}"/>
               </a:ext>
             </a:extLst>
           </p:cNvPr>
@@ -5282,10 +4960,10 @@
       </p:sp>
       <p:sp>
         <p:nvSpPr>
-          <p:cNvPr id="43" name="">
-            <a:extLst xmlns:a="http://schemas.openxmlformats.org/drawingml/2006/main">
-              <a:ext uri="{FF2B5EF4-FFF2-40B4-BE49-F238E27FC236}">
-                <a16:creationId xmlns:a16="http://schemas.microsoft.com/office/drawing/2014/main" id="{20A1C26A-9FFE-485D-BF9F-0CC60853BED9}"/>
+          <p:cNvPr id="37" name="">
+            <a:extLst xmlns:a="http://schemas.openxmlformats.org/drawingml/2006/main">
+              <a:ext uri="{FF2B5EF4-FFF2-40B4-BE49-F238E27FC236}">
+                <a16:creationId xmlns:a16="http://schemas.microsoft.com/office/drawing/2014/main" id="{8671E1F3-F375-41DE-B355-B08DE03672CC}"/>
               </a:ext>
             </a:extLst>
           </p:cNvPr>
@@ -5317,10 +4995,10 @@
       </p:sp>
       <p:sp>
         <p:nvSpPr>
-          <p:cNvPr id="44" name="">
-            <a:extLst xmlns:a="http://schemas.openxmlformats.org/drawingml/2006/main">
-              <a:ext uri="{FF2B5EF4-FFF2-40B4-BE49-F238E27FC236}">
-                <a16:creationId xmlns:a16="http://schemas.microsoft.com/office/drawing/2014/main" id="{9F581494-8807-425B-AB96-269F238E6ABF}"/>
+          <p:cNvPr id="38" name="">
+            <a:extLst xmlns:a="http://schemas.openxmlformats.org/drawingml/2006/main">
+              <a:ext uri="{FF2B5EF4-FFF2-40B4-BE49-F238E27FC236}">
+                <a16:creationId xmlns:a16="http://schemas.microsoft.com/office/drawing/2014/main" id="{E0FAE73A-C0EC-4E86-ACD6-D37E85C7038C}"/>
               </a:ext>
             </a:extLst>
           </p:cNvPr>
@@ -5381,10 +5059,10 @@
       </p:sp>
       <p:sp>
         <p:nvSpPr>
-          <p:cNvPr id="45" name="">
-            <a:extLst xmlns:a="http://schemas.openxmlformats.org/drawingml/2006/main">
-              <a:ext uri="{FF2B5EF4-FFF2-40B4-BE49-F238E27FC236}">
-                <a16:creationId xmlns:a16="http://schemas.microsoft.com/office/drawing/2014/main" id="{6328DBCA-7404-4C61-9216-E3690883D491}"/>
+          <p:cNvPr id="39" name="">
+            <a:extLst xmlns:a="http://schemas.openxmlformats.org/drawingml/2006/main">
+              <a:ext uri="{FF2B5EF4-FFF2-40B4-BE49-F238E27FC236}">
+                <a16:creationId xmlns:a16="http://schemas.microsoft.com/office/drawing/2014/main" id="{F1A700AB-C3BC-4270-8F54-852F5CC6121C}"/>
               </a:ext>
             </a:extLst>
           </p:cNvPr>
@@ -5446,7 +5124,7 @@
     </p:spTree>
     <p:extLst>
       <p:ext uri="{BB962C8B-B14F-4D97-AF65-F5344CB8AC3E}">
-        <p14:creationId xmlns:p14="http://schemas.microsoft.com/office/powerpoint/2010/main" val="273321252"/>
+        <p14:creationId xmlns:p14="http://schemas.microsoft.com/office/powerpoint/2010/main" val="274438013"/>
       </p:ext>
     </p:extLst>
   </p:cSld>
@@ -5470,7 +5148,7 @@
           <p:cNvPr id="1" name="">
             <a:extLst xmlns:a="http://schemas.openxmlformats.org/drawingml/2006/main">
               <a:ext uri="{FF2B5EF4-FFF2-40B4-BE49-F238E27FC236}">
-                <a16:creationId xmlns:a16="http://schemas.microsoft.com/office/drawing/2014/main" id="{DBEDEC5D-941D-4DCB-8712-3AEE9574E9E6}"/>
+                <a16:creationId xmlns:a16="http://schemas.microsoft.com/office/drawing/2014/main" id="{7746DC3D-556E-443C-82E8-3870F264C33B}"/>
               </a:ext>
             </a:extLst>
           </p:cNvPr>
@@ -5505,7 +5183,7 @@
           <p:cNvPr id="2" name="">
             <a:extLst xmlns:a="http://schemas.openxmlformats.org/drawingml/2006/main">
               <a:ext uri="{FF2B5EF4-FFF2-40B4-BE49-F238E27FC236}">
-                <a16:creationId xmlns:a16="http://schemas.microsoft.com/office/drawing/2014/main" id="{5DD46FDF-AC3C-460A-89A5-8F7F51436928}"/>
+                <a16:creationId xmlns:a16="http://schemas.microsoft.com/office/drawing/2014/main" id="{7F1559D6-5D8C-4049-A0EC-86C827785748}"/>
               </a:ext>
             </a:extLst>
           </p:cNvPr>
@@ -5540,7 +5218,7 @@
           <p:cNvPr id="3" name="">
             <a:extLst xmlns:a="http://schemas.openxmlformats.org/drawingml/2006/main">
               <a:ext uri="{FF2B5EF4-FFF2-40B4-BE49-F238E27FC236}">
-                <a16:creationId xmlns:a16="http://schemas.microsoft.com/office/drawing/2014/main" id="{F9B53CDF-3CD9-4696-891B-6CBCBB988251}"/>
+                <a16:creationId xmlns:a16="http://schemas.microsoft.com/office/drawing/2014/main" id="{AC039C43-BED8-4E51-8009-1E2BD830577E}"/>
               </a:ext>
             </a:extLst>
           </p:cNvPr>
@@ -5604,7 +5282,7 @@
           <p:cNvPr id="4" name="">
             <a:extLst xmlns:a="http://schemas.openxmlformats.org/drawingml/2006/main">
               <a:ext uri="{FF2B5EF4-FFF2-40B4-BE49-F238E27FC236}">
-                <a16:creationId xmlns:a16="http://schemas.microsoft.com/office/drawing/2014/main" id="{B96B71F6-F925-449F-B6C0-FD5699BE9F65}"/>
+                <a16:creationId xmlns:a16="http://schemas.microsoft.com/office/drawing/2014/main" id="{AED60A9C-D4EB-4CF2-9869-E39D32855238}"/>
               </a:ext>
             </a:extLst>
           </p:cNvPr>
@@ -5668,7 +5346,7 @@
           <p:cNvPr id="5" name="">
             <a:extLst xmlns:a="http://schemas.openxmlformats.org/drawingml/2006/main">
               <a:ext uri="{FF2B5EF4-FFF2-40B4-BE49-F238E27FC236}">
-                <a16:creationId xmlns:a16="http://schemas.microsoft.com/office/drawing/2014/main" id="{F1CB4927-2AE6-4444-A800-DEA9895E3DC0}"/>
+                <a16:creationId xmlns:a16="http://schemas.microsoft.com/office/drawing/2014/main" id="{9630C643-EA77-4C89-B35F-084E5E2E05FD}"/>
               </a:ext>
             </a:extLst>
           </p:cNvPr>
@@ -5732,7 +5410,7 @@
           <p:cNvPr id="6" name="">
             <a:extLst xmlns:a="http://schemas.openxmlformats.org/drawingml/2006/main">
               <a:ext uri="{FF2B5EF4-FFF2-40B4-BE49-F238E27FC236}">
-                <a16:creationId xmlns:a16="http://schemas.microsoft.com/office/drawing/2014/main" id="{7C3B34CC-1751-43AB-B400-B47AFD239655}"/>
+                <a16:creationId xmlns:a16="http://schemas.microsoft.com/office/drawing/2014/main" id="{15D6E32C-04B5-47D0-92B9-A9FD611EA411}"/>
               </a:ext>
             </a:extLst>
           </p:cNvPr>
@@ -5765,7 +5443,7 @@
           <p:cNvPr id="7" name="">
             <a:extLst xmlns:a="http://schemas.openxmlformats.org/drawingml/2006/main">
               <a:ext uri="{FF2B5EF4-FFF2-40B4-BE49-F238E27FC236}">
-                <a16:creationId xmlns:a16="http://schemas.microsoft.com/office/drawing/2014/main" id="{C9112537-5D86-4B47-A986-5B987341D1BE}"/>
+                <a16:creationId xmlns:a16="http://schemas.microsoft.com/office/drawing/2014/main" id="{FF7BD196-CCD8-4828-B2EE-66202FDA80F5}"/>
               </a:ext>
             </a:extLst>
           </p:cNvPr>
@@ -5829,7 +5507,7 @@
           <p:cNvPr id="8" name="">
             <a:extLst xmlns:a="http://schemas.openxmlformats.org/drawingml/2006/main">
               <a:ext uri="{FF2B5EF4-FFF2-40B4-BE49-F238E27FC236}">
-                <a16:creationId xmlns:a16="http://schemas.microsoft.com/office/drawing/2014/main" id="{EF8EBC2B-9607-4B8E-A0BA-AB56FD3DB0DB}"/>
+                <a16:creationId xmlns:a16="http://schemas.microsoft.com/office/drawing/2014/main" id="{C5A5137A-059B-4679-87DA-95D661349907}"/>
               </a:ext>
             </a:extLst>
           </p:cNvPr>
@@ -5893,7 +5571,7 @@
           <p:cNvPr id="9" name="">
             <a:extLst xmlns:a="http://schemas.openxmlformats.org/drawingml/2006/main">
               <a:ext uri="{FF2B5EF4-FFF2-40B4-BE49-F238E27FC236}">
-                <a16:creationId xmlns:a16="http://schemas.microsoft.com/office/drawing/2014/main" id="{9928D185-8B4A-45DA-9AA0-893081A1A5B7}"/>
+                <a16:creationId xmlns:a16="http://schemas.microsoft.com/office/drawing/2014/main" id="{5CE93590-CF83-4697-9A05-242FF00F554B}"/>
               </a:ext>
             </a:extLst>
           </p:cNvPr>
@@ -5926,7 +5604,7 @@
           <p:cNvPr id="10" name="">
             <a:extLst xmlns:a="http://schemas.openxmlformats.org/drawingml/2006/main">
               <a:ext uri="{FF2B5EF4-FFF2-40B4-BE49-F238E27FC236}">
-                <a16:creationId xmlns:a16="http://schemas.microsoft.com/office/drawing/2014/main" id="{2BBDEBF9-EAAB-4A22-8C75-4C6F396C29D3}"/>
+                <a16:creationId xmlns:a16="http://schemas.microsoft.com/office/drawing/2014/main" id="{BFBB76E2-18CB-46FD-B70E-2EAA1CA4223B}"/>
               </a:ext>
             </a:extLst>
           </p:cNvPr>
@@ -5990,7 +5668,7 @@
           <p:cNvPr id="11" name="">
             <a:extLst xmlns:a="http://schemas.openxmlformats.org/drawingml/2006/main">
               <a:ext uri="{FF2B5EF4-FFF2-40B4-BE49-F238E27FC236}">
-                <a16:creationId xmlns:a16="http://schemas.microsoft.com/office/drawing/2014/main" id="{30B4540B-AC74-4DD0-9DC2-4D0F6BD4EF97}"/>
+                <a16:creationId xmlns:a16="http://schemas.microsoft.com/office/drawing/2014/main" id="{70E96BE2-9C30-4EE6-A152-F15FA3A5B795}"/>
               </a:ext>
             </a:extLst>
           </p:cNvPr>
@@ -6054,7 +5732,7 @@
           <p:cNvPr id="12" name="">
             <a:extLst xmlns:a="http://schemas.openxmlformats.org/drawingml/2006/main">
               <a:ext uri="{FF2B5EF4-FFF2-40B4-BE49-F238E27FC236}">
-                <a16:creationId xmlns:a16="http://schemas.microsoft.com/office/drawing/2014/main" id="{9190B7E5-A47D-4D4C-A190-7663D5FA022F}"/>
+                <a16:creationId xmlns:a16="http://schemas.microsoft.com/office/drawing/2014/main" id="{94D62F86-48C0-44A2-86DC-845205976415}"/>
               </a:ext>
             </a:extLst>
           </p:cNvPr>
@@ -6087,7 +5765,7 @@
           <p:cNvPr id="13" name="">
             <a:extLst xmlns:a="http://schemas.openxmlformats.org/drawingml/2006/main">
               <a:ext uri="{FF2B5EF4-FFF2-40B4-BE49-F238E27FC236}">
-                <a16:creationId xmlns:a16="http://schemas.microsoft.com/office/drawing/2014/main" id="{2E81E57F-8B2C-4E7C-8111-6F7208FD0C15}"/>
+                <a16:creationId xmlns:a16="http://schemas.microsoft.com/office/drawing/2014/main" id="{32C8E83A-C593-4A2A-8D8E-A4B440C438F0}"/>
               </a:ext>
             </a:extLst>
           </p:cNvPr>
@@ -6151,7 +5829,7 @@
           <p:cNvPr id="14" name="">
             <a:extLst xmlns:a="http://schemas.openxmlformats.org/drawingml/2006/main">
               <a:ext uri="{FF2B5EF4-FFF2-40B4-BE49-F238E27FC236}">
-                <a16:creationId xmlns:a16="http://schemas.microsoft.com/office/drawing/2014/main" id="{0CFFFBDF-FCA4-48E4-B459-9DBA08A0DEFD}"/>
+                <a16:creationId xmlns:a16="http://schemas.microsoft.com/office/drawing/2014/main" id="{C29E0F59-0D0B-40BE-A486-974FE1CB5CB8}"/>
               </a:ext>
             </a:extLst>
           </p:cNvPr>
@@ -6215,7 +5893,7 @@
           <p:cNvPr id="15" name="">
             <a:extLst xmlns:a="http://schemas.openxmlformats.org/drawingml/2006/main">
               <a:ext uri="{FF2B5EF4-FFF2-40B4-BE49-F238E27FC236}">
-                <a16:creationId xmlns:a16="http://schemas.microsoft.com/office/drawing/2014/main" id="{F4629123-E78E-4579-8A3A-1FB5D151072C}"/>
+                <a16:creationId xmlns:a16="http://schemas.microsoft.com/office/drawing/2014/main" id="{4DD0FB52-4EB4-401F-A94E-1119142F6D52}"/>
               </a:ext>
             </a:extLst>
           </p:cNvPr>
@@ -6250,7 +5928,7 @@
           <p:cNvPr id="16" name="">
             <a:extLst xmlns:a="http://schemas.openxmlformats.org/drawingml/2006/main">
               <a:ext uri="{FF2B5EF4-FFF2-40B4-BE49-F238E27FC236}">
-                <a16:creationId xmlns:a16="http://schemas.microsoft.com/office/drawing/2014/main" id="{84BC5EC3-039A-4547-A803-C2ECE49A9CAE}"/>
+                <a16:creationId xmlns:a16="http://schemas.microsoft.com/office/drawing/2014/main" id="{BEA9F5C0-F8D2-4A6F-94AC-E633DDC7E127}"/>
               </a:ext>
             </a:extLst>
           </p:cNvPr>
@@ -6285,7 +5963,7 @@
           <p:cNvPr id="17" name="">
             <a:extLst xmlns:a="http://schemas.openxmlformats.org/drawingml/2006/main">
               <a:ext uri="{FF2B5EF4-FFF2-40B4-BE49-F238E27FC236}">
-                <a16:creationId xmlns:a16="http://schemas.microsoft.com/office/drawing/2014/main" id="{723F615F-E5B2-48B5-93FE-FF527ED08EA4}"/>
+                <a16:creationId xmlns:a16="http://schemas.microsoft.com/office/drawing/2014/main" id="{851B4804-C4FE-47EA-B843-4B8B7DAF5D0B}"/>
               </a:ext>
             </a:extLst>
           </p:cNvPr>
@@ -6318,7 +5996,7 @@
           <p:cNvPr id="18" name="">
             <a:extLst xmlns:a="http://schemas.openxmlformats.org/drawingml/2006/main">
               <a:ext uri="{FF2B5EF4-FFF2-40B4-BE49-F238E27FC236}">
-                <a16:creationId xmlns:a16="http://schemas.microsoft.com/office/drawing/2014/main" id="{E21C5C00-5097-4719-BBF0-B12BB8CCBF1D}"/>
+                <a16:creationId xmlns:a16="http://schemas.microsoft.com/office/drawing/2014/main" id="{AA23B82C-D797-4F43-963A-A2F7465BAAAC}"/>
               </a:ext>
             </a:extLst>
           </p:cNvPr>
@@ -6382,7 +6060,7 @@
           <p:cNvPr id="19" name="">
             <a:extLst xmlns:a="http://schemas.openxmlformats.org/drawingml/2006/main">
               <a:ext uri="{FF2B5EF4-FFF2-40B4-BE49-F238E27FC236}">
-                <a16:creationId xmlns:a16="http://schemas.microsoft.com/office/drawing/2014/main" id="{5A4B32E4-C261-48AF-9EE3-5E771118B54C}"/>
+                <a16:creationId xmlns:a16="http://schemas.microsoft.com/office/drawing/2014/main" id="{BFB1E109-ED9F-4F86-9E67-F4C6F710F831}"/>
               </a:ext>
             </a:extLst>
           </p:cNvPr>
@@ -6446,7 +6124,7 @@
           <p:cNvPr id="20" name="">
             <a:extLst xmlns:a="http://schemas.openxmlformats.org/drawingml/2006/main">
               <a:ext uri="{FF2B5EF4-FFF2-40B4-BE49-F238E27FC236}">
-                <a16:creationId xmlns:a16="http://schemas.microsoft.com/office/drawing/2014/main" id="{B4CD2329-7FB7-4B87-AC88-504030CFE606}"/>
+                <a16:creationId xmlns:a16="http://schemas.microsoft.com/office/drawing/2014/main" id="{BA09FCC9-5DF3-4C04-A394-E692F1708816}"/>
               </a:ext>
             </a:extLst>
           </p:cNvPr>
@@ -6481,7 +6159,7 @@
           <p:cNvPr id="21" name="">
             <a:extLst xmlns:a="http://schemas.openxmlformats.org/drawingml/2006/main">
               <a:ext uri="{FF2B5EF4-FFF2-40B4-BE49-F238E27FC236}">
-                <a16:creationId xmlns:a16="http://schemas.microsoft.com/office/drawing/2014/main" id="{ABA9C090-1486-425E-8889-CB1CEA6AD846}"/>
+                <a16:creationId xmlns:a16="http://schemas.microsoft.com/office/drawing/2014/main" id="{C8620D86-11E9-42DB-A6ED-E9DA45EF3BBC}"/>
               </a:ext>
             </a:extLst>
           </p:cNvPr>
@@ -6545,7 +6223,7 @@
           <p:cNvPr id="22" name="">
             <a:extLst xmlns:a="http://schemas.openxmlformats.org/drawingml/2006/main">
               <a:ext uri="{FF2B5EF4-FFF2-40B4-BE49-F238E27FC236}">
-                <a16:creationId xmlns:a16="http://schemas.microsoft.com/office/drawing/2014/main" id="{17EDC4AB-AB83-43EF-A490-195CD004F24A}"/>
+                <a16:creationId xmlns:a16="http://schemas.microsoft.com/office/drawing/2014/main" id="{5AC367CD-D5A5-4F00-875C-B200E5EEA112}"/>
               </a:ext>
             </a:extLst>
           </p:cNvPr>
@@ -6607,7 +6285,7 @@
     </p:spTree>
     <p:extLst>
       <p:ext uri="{BB962C8B-B14F-4D97-AF65-F5344CB8AC3E}">
-        <p14:creationId xmlns:p14="http://schemas.microsoft.com/office/powerpoint/2010/main" val="465137739"/>
+        <p14:creationId xmlns:p14="http://schemas.microsoft.com/office/powerpoint/2010/main" val="151181302"/>
       </p:ext>
     </p:extLst>
   </p:cSld>
@@ -6631,7 +6309,7 @@
           <p:cNvPr id="1" name="">
             <a:extLst xmlns:a="http://schemas.openxmlformats.org/drawingml/2006/main">
               <a:ext uri="{FF2B5EF4-FFF2-40B4-BE49-F238E27FC236}">
-                <a16:creationId xmlns:a16="http://schemas.microsoft.com/office/drawing/2014/main" id="{B25029A1-C671-4B37-A1F0-341030BF9CA4}"/>
+                <a16:creationId xmlns:a16="http://schemas.microsoft.com/office/drawing/2014/main" id="{0504F595-9BDC-4466-832A-B2B14B2C36B2}"/>
               </a:ext>
             </a:extLst>
           </p:cNvPr>
@@ -6666,7 +6344,7 @@
           <p:cNvPr id="2" name="">
             <a:extLst xmlns:a="http://schemas.openxmlformats.org/drawingml/2006/main">
               <a:ext uri="{FF2B5EF4-FFF2-40B4-BE49-F238E27FC236}">
-                <a16:creationId xmlns:a16="http://schemas.microsoft.com/office/drawing/2014/main" id="{11BD0B75-579C-4D29-B7CC-324F540DA628}"/>
+                <a16:creationId xmlns:a16="http://schemas.microsoft.com/office/drawing/2014/main" id="{FAA12E53-6B24-403C-81E5-1C2A089AECCA}"/>
               </a:ext>
             </a:extLst>
           </p:cNvPr>
@@ -6701,7 +6379,7 @@
           <p:cNvPr id="3" name="">
             <a:extLst xmlns:a="http://schemas.openxmlformats.org/drawingml/2006/main">
               <a:ext uri="{FF2B5EF4-FFF2-40B4-BE49-F238E27FC236}">
-                <a16:creationId xmlns:a16="http://schemas.microsoft.com/office/drawing/2014/main" id="{E21C7A9F-41C4-4AB9-875B-0424DAAAA509}"/>
+                <a16:creationId xmlns:a16="http://schemas.microsoft.com/office/drawing/2014/main" id="{02972E91-0D17-4C62-8DCF-8CE81FEE70C8}"/>
               </a:ext>
             </a:extLst>
           </p:cNvPr>
@@ -6765,7 +6443,7 @@
           <p:cNvPr id="4" name="">
             <a:extLst xmlns:a="http://schemas.openxmlformats.org/drawingml/2006/main">
               <a:ext uri="{FF2B5EF4-FFF2-40B4-BE49-F238E27FC236}">
-                <a16:creationId xmlns:a16="http://schemas.microsoft.com/office/drawing/2014/main" id="{FD39F5E4-EB05-4041-944A-E513E5D3C53C}"/>
+                <a16:creationId xmlns:a16="http://schemas.microsoft.com/office/drawing/2014/main" id="{8042A5AE-5725-484C-A453-BCAEF295EAE6}"/>
               </a:ext>
             </a:extLst>
           </p:cNvPr>
@@ -6829,7 +6507,7 @@
           <p:cNvPr id="5" name="">
             <a:extLst xmlns:a="http://schemas.openxmlformats.org/drawingml/2006/main">
               <a:ext uri="{FF2B5EF4-FFF2-40B4-BE49-F238E27FC236}">
-                <a16:creationId xmlns:a16="http://schemas.microsoft.com/office/drawing/2014/main" id="{1E3B838C-EDAA-4487-9972-B2AADF623688}"/>
+                <a16:creationId xmlns:a16="http://schemas.microsoft.com/office/drawing/2014/main" id="{E487556F-76B8-416F-B580-6971F555156A}"/>
               </a:ext>
             </a:extLst>
           </p:cNvPr>
@@ -6893,7 +6571,7 @@
           <p:cNvPr id="6" name="">
             <a:extLst xmlns:a="http://schemas.openxmlformats.org/drawingml/2006/main">
               <a:ext uri="{FF2B5EF4-FFF2-40B4-BE49-F238E27FC236}">
-                <a16:creationId xmlns:a16="http://schemas.microsoft.com/office/drawing/2014/main" id="{8254624F-2FFE-4C4E-89C7-F02EAF7357E1}"/>
+                <a16:creationId xmlns:a16="http://schemas.microsoft.com/office/drawing/2014/main" id="{DC9E4BC3-6F0D-4EB6-A13B-03EF84322E55}"/>
               </a:ext>
             </a:extLst>
           </p:cNvPr>
@@ -6926,7 +6604,7 @@
           <p:cNvPr id="7" name="">
             <a:extLst xmlns:a="http://schemas.openxmlformats.org/drawingml/2006/main">
               <a:ext uri="{FF2B5EF4-FFF2-40B4-BE49-F238E27FC236}">
-                <a16:creationId xmlns:a16="http://schemas.microsoft.com/office/drawing/2014/main" id="{71FB1504-7538-4881-B42C-2A2E1F5E977E}"/>
+                <a16:creationId xmlns:a16="http://schemas.microsoft.com/office/drawing/2014/main" id="{9A5A0D9D-FCDC-4B89-BE1B-C6618B7D2DE9}"/>
               </a:ext>
             </a:extLst>
           </p:cNvPr>
@@ -6990,7 +6668,7 @@
           <p:cNvPr id="8" name="">
             <a:extLst xmlns:a="http://schemas.openxmlformats.org/drawingml/2006/main">
               <a:ext uri="{FF2B5EF4-FFF2-40B4-BE49-F238E27FC236}">
-                <a16:creationId xmlns:a16="http://schemas.microsoft.com/office/drawing/2014/main" id="{FD4E9242-9FA2-4701-8623-BCFFFBFC2941}"/>
+                <a16:creationId xmlns:a16="http://schemas.microsoft.com/office/drawing/2014/main" id="{360C6E56-20AC-485C-BC4F-7C8C227ADE26}"/>
               </a:ext>
             </a:extLst>
           </p:cNvPr>
@@ -7054,7 +6732,7 @@
           <p:cNvPr id="9" name="">
             <a:extLst xmlns:a="http://schemas.openxmlformats.org/drawingml/2006/main">
               <a:ext uri="{FF2B5EF4-FFF2-40B4-BE49-F238E27FC236}">
-                <a16:creationId xmlns:a16="http://schemas.microsoft.com/office/drawing/2014/main" id="{E7088E85-3578-418E-A1C7-50F41EE84605}"/>
+                <a16:creationId xmlns:a16="http://schemas.microsoft.com/office/drawing/2014/main" id="{F0880FA8-EA82-4DE0-85EF-79DC34BDE325}"/>
               </a:ext>
             </a:extLst>
           </p:cNvPr>
@@ -7118,7 +6796,7 @@
           <p:cNvPr id="10" name="">
             <a:extLst xmlns:a="http://schemas.openxmlformats.org/drawingml/2006/main">
               <a:ext uri="{FF2B5EF4-FFF2-40B4-BE49-F238E27FC236}">
-                <a16:creationId xmlns:a16="http://schemas.microsoft.com/office/drawing/2014/main" id="{C96A5FA6-33CE-4783-AAF8-0A6C1DA35C38}"/>
+                <a16:creationId xmlns:a16="http://schemas.microsoft.com/office/drawing/2014/main" id="{3A762B5D-5334-4A0F-A51A-E55B1AD25D89}"/>
               </a:ext>
             </a:extLst>
           </p:cNvPr>
@@ -7151,7 +6829,7 @@
           <p:cNvPr id="11" name="">
             <a:extLst xmlns:a="http://schemas.openxmlformats.org/drawingml/2006/main">
               <a:ext uri="{FF2B5EF4-FFF2-40B4-BE49-F238E27FC236}">
-                <a16:creationId xmlns:a16="http://schemas.microsoft.com/office/drawing/2014/main" id="{57A51C5F-530F-4FA3-8957-8EBC84EDA00E}"/>
+                <a16:creationId xmlns:a16="http://schemas.microsoft.com/office/drawing/2014/main" id="{1C112413-6AEB-4F5D-999F-0C7063B0B6B3}"/>
               </a:ext>
             </a:extLst>
           </p:cNvPr>
@@ -7215,7 +6893,7 @@
           <p:cNvPr id="12" name="">
             <a:extLst xmlns:a="http://schemas.openxmlformats.org/drawingml/2006/main">
               <a:ext uri="{FF2B5EF4-FFF2-40B4-BE49-F238E27FC236}">
-                <a16:creationId xmlns:a16="http://schemas.microsoft.com/office/drawing/2014/main" id="{F0F9C46E-4296-4834-AA2E-8D2C430589C5}"/>
+                <a16:creationId xmlns:a16="http://schemas.microsoft.com/office/drawing/2014/main" id="{4D60968B-4E17-47DA-A036-433781F7693B}"/>
               </a:ext>
             </a:extLst>
           </p:cNvPr>
@@ -7279,7 +6957,7 @@
           <p:cNvPr id="13" name="">
             <a:extLst xmlns:a="http://schemas.openxmlformats.org/drawingml/2006/main">
               <a:ext uri="{FF2B5EF4-FFF2-40B4-BE49-F238E27FC236}">
-                <a16:creationId xmlns:a16="http://schemas.microsoft.com/office/drawing/2014/main" id="{93E77B92-0B91-4CC1-A582-F98ECDB948CE}"/>
+                <a16:creationId xmlns:a16="http://schemas.microsoft.com/office/drawing/2014/main" id="{C1A26669-E744-44FC-BEFE-853B9005EE04}"/>
               </a:ext>
             </a:extLst>
           </p:cNvPr>
@@ -7343,7 +7021,7 @@
           <p:cNvPr id="14" name="">
             <a:extLst xmlns:a="http://schemas.openxmlformats.org/drawingml/2006/main">
               <a:ext uri="{FF2B5EF4-FFF2-40B4-BE49-F238E27FC236}">
-                <a16:creationId xmlns:a16="http://schemas.microsoft.com/office/drawing/2014/main" id="{0A6EC3A0-8089-4F4E-B71C-998FC70775AC}"/>
+                <a16:creationId xmlns:a16="http://schemas.microsoft.com/office/drawing/2014/main" id="{C24FB20D-CAE4-42A6-B6B9-7E0D4D8F13D7}"/>
               </a:ext>
             </a:extLst>
           </p:cNvPr>
@@ -7376,7 +7054,7 @@
           <p:cNvPr id="15" name="">
             <a:extLst xmlns:a="http://schemas.openxmlformats.org/drawingml/2006/main">
               <a:ext uri="{FF2B5EF4-FFF2-40B4-BE49-F238E27FC236}">
-                <a16:creationId xmlns:a16="http://schemas.microsoft.com/office/drawing/2014/main" id="{F27EE53B-66A8-4492-8550-3C6FD3A18699}"/>
+                <a16:creationId xmlns:a16="http://schemas.microsoft.com/office/drawing/2014/main" id="{33640F05-B070-4074-963C-5847BD18D159}"/>
               </a:ext>
             </a:extLst>
           </p:cNvPr>
@@ -7440,7 +7118,7 @@
           <p:cNvPr id="16" name="">
             <a:extLst xmlns:a="http://schemas.openxmlformats.org/drawingml/2006/main">
               <a:ext uri="{FF2B5EF4-FFF2-40B4-BE49-F238E27FC236}">
-                <a16:creationId xmlns:a16="http://schemas.microsoft.com/office/drawing/2014/main" id="{F190A25C-FEC2-4E2E-BFAC-8E6EF27DA395}"/>
+                <a16:creationId xmlns:a16="http://schemas.microsoft.com/office/drawing/2014/main" id="{F02C8E99-0C9F-4CBB-B081-8CBC9DFC52C2}"/>
               </a:ext>
             </a:extLst>
           </p:cNvPr>
@@ -7504,7 +7182,7 @@
           <p:cNvPr id="17" name="">
             <a:extLst xmlns:a="http://schemas.openxmlformats.org/drawingml/2006/main">
               <a:ext uri="{FF2B5EF4-FFF2-40B4-BE49-F238E27FC236}">
-                <a16:creationId xmlns:a16="http://schemas.microsoft.com/office/drawing/2014/main" id="{F2D7D5E4-9F60-4F83-9BD2-01C9510B350E}"/>
+                <a16:creationId xmlns:a16="http://schemas.microsoft.com/office/drawing/2014/main" id="{069207E6-1852-4AFB-9EF3-E09266161870}"/>
               </a:ext>
             </a:extLst>
           </p:cNvPr>
@@ -7568,7 +7246,7 @@
           <p:cNvPr id="18" name="">
             <a:extLst xmlns:a="http://schemas.openxmlformats.org/drawingml/2006/main">
               <a:ext uri="{FF2B5EF4-FFF2-40B4-BE49-F238E27FC236}">
-                <a16:creationId xmlns:a16="http://schemas.microsoft.com/office/drawing/2014/main" id="{32891BE4-AB17-4AD3-A8C1-C843AF5104F8}"/>
+                <a16:creationId xmlns:a16="http://schemas.microsoft.com/office/drawing/2014/main" id="{6475D126-9D90-4B46-B8C3-FAD73BC0764C}"/>
               </a:ext>
             </a:extLst>
           </p:cNvPr>
@@ -7601,7 +7279,7 @@
           <p:cNvPr id="19" name="">
             <a:extLst xmlns:a="http://schemas.openxmlformats.org/drawingml/2006/main">
               <a:ext uri="{FF2B5EF4-FFF2-40B4-BE49-F238E27FC236}">
-                <a16:creationId xmlns:a16="http://schemas.microsoft.com/office/drawing/2014/main" id="{4EC7710D-83A6-482A-8E29-43615F0DFDDA}"/>
+                <a16:creationId xmlns:a16="http://schemas.microsoft.com/office/drawing/2014/main" id="{040705DF-6B79-4B42-9A00-640AC57A20F6}"/>
               </a:ext>
             </a:extLst>
           </p:cNvPr>
@@ -7665,7 +7343,7 @@
           <p:cNvPr id="20" name="">
             <a:extLst xmlns:a="http://schemas.openxmlformats.org/drawingml/2006/main">
               <a:ext uri="{FF2B5EF4-FFF2-40B4-BE49-F238E27FC236}">
-                <a16:creationId xmlns:a16="http://schemas.microsoft.com/office/drawing/2014/main" id="{DBFD8D45-2A85-4592-93C4-B7CCC490BEBC}"/>
+                <a16:creationId xmlns:a16="http://schemas.microsoft.com/office/drawing/2014/main" id="{52F3129E-D853-43A9-AA7C-7D68C4AFFAE0}"/>
               </a:ext>
             </a:extLst>
           </p:cNvPr>
@@ -7729,7 +7407,7 @@
           <p:cNvPr id="21" name="">
             <a:extLst xmlns:a="http://schemas.openxmlformats.org/drawingml/2006/main">
               <a:ext uri="{FF2B5EF4-FFF2-40B4-BE49-F238E27FC236}">
-                <a16:creationId xmlns:a16="http://schemas.microsoft.com/office/drawing/2014/main" id="{CC3D1B59-5E00-4335-8E48-ACE8643561B6}"/>
+                <a16:creationId xmlns:a16="http://schemas.microsoft.com/office/drawing/2014/main" id="{B45F8B31-5B95-4A05-B164-49C7A3C31F8B}"/>
               </a:ext>
             </a:extLst>
           </p:cNvPr>
@@ -7793,7 +7471,7 @@
           <p:cNvPr id="22" name="">
             <a:extLst xmlns:a="http://schemas.openxmlformats.org/drawingml/2006/main">
               <a:ext uri="{FF2B5EF4-FFF2-40B4-BE49-F238E27FC236}">
-                <a16:creationId xmlns:a16="http://schemas.microsoft.com/office/drawing/2014/main" id="{AF54D28F-2C5F-480B-960A-BF69346817F7}"/>
+                <a16:creationId xmlns:a16="http://schemas.microsoft.com/office/drawing/2014/main" id="{1036084F-E8B1-4025-B25B-2E4A8AA256EF}"/>
               </a:ext>
             </a:extLst>
           </p:cNvPr>
@@ -7826,7 +7504,7 @@
           <p:cNvPr id="23" name="">
             <a:extLst xmlns:a="http://schemas.openxmlformats.org/drawingml/2006/main">
               <a:ext uri="{FF2B5EF4-FFF2-40B4-BE49-F238E27FC236}">
-                <a16:creationId xmlns:a16="http://schemas.microsoft.com/office/drawing/2014/main" id="{66FD06DA-B90D-4F4F-A634-A2FD63D859F2}"/>
+                <a16:creationId xmlns:a16="http://schemas.microsoft.com/office/drawing/2014/main" id="{0365DF55-F614-4A27-992F-D1748A3BF0D1}"/>
               </a:ext>
             </a:extLst>
           </p:cNvPr>
@@ -7890,7 +7568,7 @@
           <p:cNvPr id="24" name="">
             <a:extLst xmlns:a="http://schemas.openxmlformats.org/drawingml/2006/main">
               <a:ext uri="{FF2B5EF4-FFF2-40B4-BE49-F238E27FC236}">
-                <a16:creationId xmlns:a16="http://schemas.microsoft.com/office/drawing/2014/main" id="{E60386D8-C075-46BC-AEBD-F4B0F4E01291}"/>
+                <a16:creationId xmlns:a16="http://schemas.microsoft.com/office/drawing/2014/main" id="{5F4A6E5F-75D5-49A4-99FA-58FC50C7555E}"/>
               </a:ext>
             </a:extLst>
           </p:cNvPr>
@@ -7954,7 +7632,7 @@
           <p:cNvPr id="25" name="">
             <a:extLst xmlns:a="http://schemas.openxmlformats.org/drawingml/2006/main">
               <a:ext uri="{FF2B5EF4-FFF2-40B4-BE49-F238E27FC236}">
-                <a16:creationId xmlns:a16="http://schemas.microsoft.com/office/drawing/2014/main" id="{72566205-8799-47B6-A3F5-E360D31F0851}"/>
+                <a16:creationId xmlns:a16="http://schemas.microsoft.com/office/drawing/2014/main" id="{7D49F235-8F37-4670-BF96-998304456D7E}"/>
               </a:ext>
             </a:extLst>
           </p:cNvPr>
@@ -8018,19 +7696,19 @@
           <p:cNvPr id="26" name="">
             <a:extLst xmlns:a="http://schemas.openxmlformats.org/drawingml/2006/main">
               <a:ext uri="{FF2B5EF4-FFF2-40B4-BE49-F238E27FC236}">
-                <a16:creationId xmlns:a16="http://schemas.microsoft.com/office/drawing/2014/main" id="{F0E86E90-0605-4B24-8B16-BDFEF733109F}"/>
-              </a:ext>
-            </a:extLst>
-          </p:cNvPr>
-          <p:cNvSpPr>
-            <a:spLocks xmlns:a="http://schemas.openxmlformats.org/drawingml/2006/main" noGrp="1"/>
-          </p:cNvSpPr>
-          <p:nvPr/>
-        </p:nvSpPr>
-        <p:spPr>
-          <a:xfrm xmlns:a="http://schemas.openxmlformats.org/drawingml/2006/main">
-            <a:off x="609600" y="3524250"/>
-            <a:ext cx="10096500" cy="1952625"/>
+                <a16:creationId xmlns:a16="http://schemas.microsoft.com/office/drawing/2014/main" id="{4254C151-4E52-4833-AE6F-3F24FC355462}"/>
+              </a:ext>
+            </a:extLst>
+          </p:cNvPr>
+          <p:cNvSpPr>
+            <a:spLocks xmlns:a="http://schemas.openxmlformats.org/drawingml/2006/main" noGrp="1"/>
+          </p:cNvSpPr>
+          <p:nvPr/>
+        </p:nvSpPr>
+        <p:spPr>
+          <a:xfrm xmlns:a="http://schemas.openxmlformats.org/drawingml/2006/main">
+            <a:off x="609600" y="3467100"/>
+            <a:ext cx="10096500" cy="2114550"/>
           </a:xfrm>
           <a:prstGeom xmlns:a="http://schemas.openxmlformats.org/drawingml/2006/main" prst="rect">
             <a:avLst/>
@@ -8051,18 +7729,18 @@
           <p:cNvPr id="27" name="">
             <a:extLst xmlns:a="http://schemas.openxmlformats.org/drawingml/2006/main">
               <a:ext uri="{FF2B5EF4-FFF2-40B4-BE49-F238E27FC236}">
-                <a16:creationId xmlns:a16="http://schemas.microsoft.com/office/drawing/2014/main" id="{5426D3FF-C141-4935-BDE1-8D32E0408569}"/>
-              </a:ext>
-            </a:extLst>
-          </p:cNvPr>
-          <p:cNvSpPr>
-            <a:spLocks xmlns:a="http://schemas.openxmlformats.org/drawingml/2006/main" noGrp="1"/>
-          </p:cNvSpPr>
-          <p:nvPr/>
-        </p:nvSpPr>
-        <p:spPr>
-          <a:xfrm xmlns:a="http://schemas.openxmlformats.org/drawingml/2006/main">
-            <a:off x="838200" y="3752850"/>
+                <a16:creationId xmlns:a16="http://schemas.microsoft.com/office/drawing/2014/main" id="{FFAC585E-DC6C-448C-BC9A-44FBFC3C5CFE}"/>
+              </a:ext>
+            </a:extLst>
+          </p:cNvPr>
+          <p:cNvSpPr>
+            <a:spLocks xmlns:a="http://schemas.openxmlformats.org/drawingml/2006/main" noGrp="1"/>
+          </p:cNvSpPr>
+          <p:nvPr/>
+        </p:nvSpPr>
+        <p:spPr>
+          <a:xfrm xmlns:a="http://schemas.openxmlformats.org/drawingml/2006/main">
+            <a:off x="838200" y="3695700"/>
             <a:ext cx="1428750" cy="285750"/>
           </a:xfrm>
           <a:prstGeom xmlns:a="http://schemas.openxmlformats.org/drawingml/2006/main" prst="rect">
@@ -8084,18 +7762,18 @@
           <p:cNvPr id="28" name="">
             <a:extLst xmlns:a="http://schemas.openxmlformats.org/drawingml/2006/main">
               <a:ext uri="{FF2B5EF4-FFF2-40B4-BE49-F238E27FC236}">
-                <a16:creationId xmlns:a16="http://schemas.microsoft.com/office/drawing/2014/main" id="{7FF5D522-B0D3-488A-91E6-CE3C753FDFBB}"/>
-              </a:ext>
-            </a:extLst>
-          </p:cNvPr>
-          <p:cNvSpPr>
-            <a:spLocks xmlns:a="http://schemas.openxmlformats.org/drawingml/2006/main" noGrp="1"/>
-          </p:cNvSpPr>
-          <p:nvPr/>
-        </p:nvSpPr>
-        <p:spPr>
-          <a:xfrm xmlns:a="http://schemas.openxmlformats.org/drawingml/2006/main">
-            <a:off x="952500" y="3819525"/>
+                <a16:creationId xmlns:a16="http://schemas.microsoft.com/office/drawing/2014/main" id="{AE1094E8-50D1-40EA-8AD5-5ADDC31C3DA9}"/>
+              </a:ext>
+            </a:extLst>
+          </p:cNvPr>
+          <p:cNvSpPr>
+            <a:spLocks xmlns:a="http://schemas.openxmlformats.org/drawingml/2006/main" noGrp="1"/>
+          </p:cNvSpPr>
+          <p:nvPr/>
+        </p:nvSpPr>
+        <p:spPr>
+          <a:xfrm xmlns:a="http://schemas.openxmlformats.org/drawingml/2006/main">
+            <a:off x="952500" y="3762375"/>
             <a:ext cx="1200150" cy="171450"/>
           </a:xfrm>
           <a:prstGeom xmlns:a="http://schemas.openxmlformats.org/drawingml/2006/main" prst="rect">
@@ -8148,43 +7826,43 @@
           <p:cNvPr id="29" name="">
             <a:extLst xmlns:a="http://schemas.openxmlformats.org/drawingml/2006/main">
               <a:ext uri="{FF2B5EF4-FFF2-40B4-BE49-F238E27FC236}">
-                <a16:creationId xmlns:a16="http://schemas.microsoft.com/office/drawing/2014/main" id="{EA586D7C-6DC0-4648-9CCF-A2FDEA96FB19}"/>
-              </a:ext>
-            </a:extLst>
-          </p:cNvPr>
-          <p:cNvSpPr>
-            <a:spLocks xmlns:a="http://schemas.openxmlformats.org/drawingml/2006/main" noGrp="1"/>
-          </p:cNvSpPr>
-          <p:nvPr/>
-        </p:nvSpPr>
-        <p:spPr>
-          <a:xfrm xmlns:a="http://schemas.openxmlformats.org/drawingml/2006/main">
-            <a:off x="838200" y="4171950"/>
-            <a:ext cx="9334500" cy="533400"/>
-          </a:xfrm>
-          <a:prstGeom xmlns:a="http://schemas.openxmlformats.org/drawingml/2006/main" prst="rect">
-            <a:avLst/>
-          </a:prstGeom>
-          <a:solidFill xmlns:a="http://schemas.openxmlformats.org/drawingml/2006/main">
-            <a:srgbClr val="000000">
-              <a:alpha val="0"/>
-            </a:srgbClr>
-          </a:solidFill>
-          <a:ln xmlns:a="http://schemas.openxmlformats.org/drawingml/2006/main" w="0">
-            <a:solidFill>
-              <a:srgbClr val="000000">
-                <a:alpha val="0"/>
-              </a:srgbClr>
-            </a:solidFill>
-            <a:prstDash val="solid"/>
-          </a:ln>
-        </p:spPr>
-        <p:txBody>
-          <a:bodyPr xmlns:a="http://schemas.openxmlformats.org/drawingml/2006/main" lIns="0" tIns="0" rIns="0" bIns="0" anchor="t"/>
-          <a:lstStyle xmlns:a="http://schemas.openxmlformats.org/drawingml/2006/main"/>
-          <a:p xmlns:a="http://schemas.openxmlformats.org/drawingml/2006/main">
-            <a:pPr algn="l">
-              <a:defRPr sz="1725" b="1">
+                <a16:creationId xmlns:a16="http://schemas.microsoft.com/office/drawing/2014/main" id="{8DF24849-5647-4817-858E-8A8A12751645}"/>
+              </a:ext>
+            </a:extLst>
+          </p:cNvPr>
+          <p:cNvSpPr>
+            <a:spLocks xmlns:a="http://schemas.openxmlformats.org/drawingml/2006/main" noGrp="1"/>
+          </p:cNvSpPr>
+          <p:nvPr/>
+        </p:nvSpPr>
+        <p:spPr>
+          <a:xfrm xmlns:a="http://schemas.openxmlformats.org/drawingml/2006/main">
+            <a:off x="838200" y="4114800"/>
+            <a:ext cx="9334500" cy="438150"/>
+          </a:xfrm>
+          <a:prstGeom xmlns:a="http://schemas.openxmlformats.org/drawingml/2006/main" prst="rect">
+            <a:avLst/>
+          </a:prstGeom>
+          <a:solidFill xmlns:a="http://schemas.openxmlformats.org/drawingml/2006/main">
+            <a:srgbClr val="000000">
+              <a:alpha val="0"/>
+            </a:srgbClr>
+          </a:solidFill>
+          <a:ln xmlns:a="http://schemas.openxmlformats.org/drawingml/2006/main" w="0">
+            <a:solidFill>
+              <a:srgbClr val="000000">
+                <a:alpha val="0"/>
+              </a:srgbClr>
+            </a:solidFill>
+            <a:prstDash val="solid"/>
+          </a:ln>
+        </p:spPr>
+        <p:txBody>
+          <a:bodyPr xmlns:a="http://schemas.openxmlformats.org/drawingml/2006/main" lIns="0" tIns="0" rIns="0" bIns="0" anchor="t"/>
+          <a:lstStyle xmlns:a="http://schemas.openxmlformats.org/drawingml/2006/main"/>
+          <a:p xmlns:a="http://schemas.openxmlformats.org/drawingml/2006/main">
+            <a:pPr algn="l">
+              <a:defRPr sz="1650" b="1">
                 <a:solidFill>
                   <a:srgbClr val="18201B"/>
                 </a:solidFill>
@@ -8194,7 +7872,7 @@
               </a:defRPr>
             </a:pPr>
             <a:r>
-              <a:rPr sz="1725" b="1">
+              <a:rPr sz="1650" b="1">
                 <a:solidFill>
                   <a:srgbClr val="18201B"/>
                 </a:solidFill>
@@ -8212,43 +7890,107 @@
           <p:cNvPr id="30" name="">
             <a:extLst xmlns:a="http://schemas.openxmlformats.org/drawingml/2006/main">
               <a:ext uri="{FF2B5EF4-FFF2-40B4-BE49-F238E27FC236}">
-                <a16:creationId xmlns:a16="http://schemas.microsoft.com/office/drawing/2014/main" id="{3CCFB96C-1FCF-42AF-895D-995003AE008A}"/>
-              </a:ext>
-            </a:extLst>
-          </p:cNvPr>
-          <p:cNvSpPr>
-            <a:spLocks xmlns:a="http://schemas.openxmlformats.org/drawingml/2006/main" noGrp="1"/>
-          </p:cNvSpPr>
-          <p:nvPr/>
-        </p:nvSpPr>
-        <p:spPr>
-          <a:xfrm xmlns:a="http://schemas.openxmlformats.org/drawingml/2006/main">
-            <a:off x="838200" y="4724400"/>
-            <a:ext cx="8572500" cy="457200"/>
-          </a:xfrm>
-          <a:prstGeom xmlns:a="http://schemas.openxmlformats.org/drawingml/2006/main" prst="rect">
-            <a:avLst/>
-          </a:prstGeom>
-          <a:solidFill xmlns:a="http://schemas.openxmlformats.org/drawingml/2006/main">
-            <a:srgbClr val="000000">
-              <a:alpha val="0"/>
-            </a:srgbClr>
-          </a:solidFill>
-          <a:ln xmlns:a="http://schemas.openxmlformats.org/drawingml/2006/main" w="0">
-            <a:solidFill>
-              <a:srgbClr val="000000">
-                <a:alpha val="0"/>
-              </a:srgbClr>
-            </a:solidFill>
-            <a:prstDash val="solid"/>
-          </a:ln>
-        </p:spPr>
-        <p:txBody>
-          <a:bodyPr xmlns:a="http://schemas.openxmlformats.org/drawingml/2006/main" lIns="0" tIns="0" rIns="0" bIns="0" anchor="t"/>
-          <a:lstStyle xmlns:a="http://schemas.openxmlformats.org/drawingml/2006/main"/>
-          <a:p xmlns:a="http://schemas.openxmlformats.org/drawingml/2006/main">
-            <a:pPr algn="l">
-              <a:defRPr sz="1350" b="0">
+                <a16:creationId xmlns:a16="http://schemas.microsoft.com/office/drawing/2014/main" id="{DDEC69B2-85A6-4BC0-8A68-245A6DD8FC54}"/>
+              </a:ext>
+            </a:extLst>
+          </p:cNvPr>
+          <p:cNvSpPr>
+            <a:spLocks xmlns:a="http://schemas.openxmlformats.org/drawingml/2006/main" noGrp="1"/>
+          </p:cNvSpPr>
+          <p:nvPr/>
+        </p:nvSpPr>
+        <p:spPr>
+          <a:xfrm xmlns:a="http://schemas.openxmlformats.org/drawingml/2006/main">
+            <a:off x="838200" y="4629150"/>
+            <a:ext cx="9334500" cy="514350"/>
+          </a:xfrm>
+          <a:prstGeom xmlns:a="http://schemas.openxmlformats.org/drawingml/2006/main" prst="rect">
+            <a:avLst/>
+          </a:prstGeom>
+          <a:solidFill xmlns:a="http://schemas.openxmlformats.org/drawingml/2006/main">
+            <a:srgbClr val="000000">
+              <a:alpha val="0"/>
+            </a:srgbClr>
+          </a:solidFill>
+          <a:ln xmlns:a="http://schemas.openxmlformats.org/drawingml/2006/main" w="0">
+            <a:solidFill>
+              <a:srgbClr val="000000">
+                <a:alpha val="0"/>
+              </a:srgbClr>
+            </a:solidFill>
+            <a:prstDash val="solid"/>
+          </a:ln>
+        </p:spPr>
+        <p:txBody>
+          <a:bodyPr xmlns:a="http://schemas.openxmlformats.org/drawingml/2006/main" lIns="0" tIns="0" rIns="0" bIns="0" anchor="t"/>
+          <a:lstStyle xmlns:a="http://schemas.openxmlformats.org/drawingml/2006/main"/>
+          <a:p xmlns:a="http://schemas.openxmlformats.org/drawingml/2006/main">
+            <a:pPr algn="l">
+              <a:defRPr sz="1275" b="0">
+                <a:solidFill>
+                  <a:srgbClr val="18201B"/>
+                </a:solidFill>
+                <a:latin typeface="Aptos"/>
+                <a:ea typeface="Aptos"/>
+                <a:cs typeface="Aptos"/>
+              </a:defRPr>
+            </a:pPr>
+            <a:r>
+              <a:rPr sz="1275" b="0">
+                <a:solidFill>
+                  <a:srgbClr val="18201B"/>
+                </a:solidFill>
+                <a:latin typeface="Aptos"/>
+                <a:ea typeface="Aptos"/>
+                <a:cs typeface="Aptos"/>
+              </a:rPr>
+              <a:t>Feature examples: household_id, basket_id, product_id, week, quantity, sales_value, retail/coupon discounts, department, category, brand, promotion exposure, campaign/coupon mapping, income/age/household size.</a:t>
+            </a:r>
+          </a:p>
+        </p:txBody>
+      </p:sp>
+      <p:sp>
+        <p:nvSpPr>
+          <p:cNvPr id="31" name="">
+            <a:extLst xmlns:a="http://schemas.openxmlformats.org/drawingml/2006/main">
+              <a:ext uri="{FF2B5EF4-FFF2-40B4-BE49-F238E27FC236}">
+                <a16:creationId xmlns:a16="http://schemas.microsoft.com/office/drawing/2014/main" id="{6F5C37B9-6266-4994-8D20-B9031A0CEB3C}"/>
+              </a:ext>
+            </a:extLst>
+          </p:cNvPr>
+          <p:cNvSpPr>
+            <a:spLocks xmlns:a="http://schemas.openxmlformats.org/drawingml/2006/main" noGrp="1"/>
+          </p:cNvSpPr>
+          <p:nvPr/>
+        </p:nvSpPr>
+        <p:spPr>
+          <a:xfrm xmlns:a="http://schemas.openxmlformats.org/drawingml/2006/main">
+            <a:off x="838200" y="5219700"/>
+            <a:ext cx="8572500" cy="247650"/>
+          </a:xfrm>
+          <a:prstGeom xmlns:a="http://schemas.openxmlformats.org/drawingml/2006/main" prst="rect">
+            <a:avLst/>
+          </a:prstGeom>
+          <a:solidFill xmlns:a="http://schemas.openxmlformats.org/drawingml/2006/main">
+            <a:srgbClr val="000000">
+              <a:alpha val="0"/>
+            </a:srgbClr>
+          </a:solidFill>
+          <a:ln xmlns:a="http://schemas.openxmlformats.org/drawingml/2006/main" w="0">
+            <a:solidFill>
+              <a:srgbClr val="000000">
+                <a:alpha val="0"/>
+              </a:srgbClr>
+            </a:solidFill>
+            <a:prstDash val="solid"/>
+          </a:ln>
+        </p:spPr>
+        <p:txBody>
+          <a:bodyPr xmlns:a="http://schemas.openxmlformats.org/drawingml/2006/main" lIns="0" tIns="0" rIns="0" bIns="0" anchor="t"/>
+          <a:lstStyle xmlns:a="http://schemas.openxmlformats.org/drawingml/2006/main"/>
+          <a:p xmlns:a="http://schemas.openxmlformats.org/drawingml/2006/main">
+            <a:pPr algn="l">
+              <a:defRPr sz="1200" b="0">
                 <a:solidFill>
                   <a:srgbClr val="667267"/>
                 </a:solidFill>
@@ -8258,7 +8000,7 @@
               </a:defRPr>
             </a:pPr>
             <a:r>
-              <a:rPr sz="1350" b="0">
+              <a:rPr sz="1200" b="0">
                 <a:solidFill>
                   <a:srgbClr val="667267"/>
                 </a:solidFill>
@@ -8266,17 +8008,17 @@
                 <a:ea typeface="Aptos"/>
                 <a:cs typeface="Aptos"/>
               </a:rPr>
-              <a:t>The table mix is why this dataset is stronger than plain next-basket data: it supports product recommendation and promotion/coupon decision logic.</a:t>
-            </a:r>
-          </a:p>
-        </p:txBody>
-      </p:sp>
-      <p:sp>
-        <p:nvSpPr>
-          <p:cNvPr id="31" name="">
-            <a:extLst xmlns:a="http://schemas.openxmlformats.org/drawingml/2006/main">
-              <a:ext uri="{FF2B5EF4-FFF2-40B4-BE49-F238E27FC236}">
-                <a16:creationId xmlns:a16="http://schemas.microsoft.com/office/drawing/2014/main" id="{68A1A4FF-A32B-4ADE-9949-6F6A7CB5D6A0}"/>
+              <a:t>This lets us explain what the dataset looks like before introducing recommendation models.</a:t>
+            </a:r>
+          </a:p>
+        </p:txBody>
+      </p:sp>
+      <p:sp>
+        <p:nvSpPr>
+          <p:cNvPr id="32" name="">
+            <a:extLst xmlns:a="http://schemas.openxmlformats.org/drawingml/2006/main">
+              <a:ext uri="{FF2B5EF4-FFF2-40B4-BE49-F238E27FC236}">
+                <a16:creationId xmlns:a16="http://schemas.microsoft.com/office/drawing/2014/main" id="{8CA2739C-DA63-4450-90D4-7972A0EA6D16}"/>
               </a:ext>
             </a:extLst>
           </p:cNvPr>
@@ -8308,10 +8050,10 @@
       </p:sp>
       <p:sp>
         <p:nvSpPr>
-          <p:cNvPr id="32" name="">
-            <a:extLst xmlns:a="http://schemas.openxmlformats.org/drawingml/2006/main">
-              <a:ext uri="{FF2B5EF4-FFF2-40B4-BE49-F238E27FC236}">
-                <a16:creationId xmlns:a16="http://schemas.microsoft.com/office/drawing/2014/main" id="{281747C1-E5D1-4BDC-8D37-A37D81107DD8}"/>
+          <p:cNvPr id="33" name="">
+            <a:extLst xmlns:a="http://schemas.openxmlformats.org/drawingml/2006/main">
+              <a:ext uri="{FF2B5EF4-FFF2-40B4-BE49-F238E27FC236}">
+                <a16:creationId xmlns:a16="http://schemas.microsoft.com/office/drawing/2014/main" id="{42668B05-225A-40EB-B0FA-962CB85C29D8}"/>
               </a:ext>
             </a:extLst>
           </p:cNvPr>
@@ -8372,10 +8114,10 @@
       </p:sp>
       <p:sp>
         <p:nvSpPr>
-          <p:cNvPr id="33" name="">
-            <a:extLst xmlns:a="http://schemas.openxmlformats.org/drawingml/2006/main">
-              <a:ext uri="{FF2B5EF4-FFF2-40B4-BE49-F238E27FC236}">
-                <a16:creationId xmlns:a16="http://schemas.microsoft.com/office/drawing/2014/main" id="{2CD37C12-4A56-49A3-8F95-D84F9C54B7A7}"/>
+          <p:cNvPr id="34" name="">
+            <a:extLst xmlns:a="http://schemas.openxmlformats.org/drawingml/2006/main">
+              <a:ext uri="{FF2B5EF4-FFF2-40B4-BE49-F238E27FC236}">
+                <a16:creationId xmlns:a16="http://schemas.microsoft.com/office/drawing/2014/main" id="{41F9F3AC-E5F9-40FD-9C4B-F19A6B09E965}"/>
               </a:ext>
             </a:extLst>
           </p:cNvPr>
@@ -8437,7 +8179,7 @@
     </p:spTree>
     <p:extLst>
       <p:ext uri="{BB962C8B-B14F-4D97-AF65-F5344CB8AC3E}">
-        <p14:creationId xmlns:p14="http://schemas.microsoft.com/office/powerpoint/2010/main" val="1236416258"/>
+        <p14:creationId xmlns:p14="http://schemas.microsoft.com/office/powerpoint/2010/main" val="457623549"/>
       </p:ext>
     </p:extLst>
   </p:cSld>
@@ -8461,7 +8203,7 @@
           <p:cNvPr id="1" name="">
             <a:extLst xmlns:a="http://schemas.openxmlformats.org/drawingml/2006/main">
               <a:ext uri="{FF2B5EF4-FFF2-40B4-BE49-F238E27FC236}">
-                <a16:creationId xmlns:a16="http://schemas.microsoft.com/office/drawing/2014/main" id="{83235830-5CDE-4BFD-A40F-FB5F34803CC5}"/>
+                <a16:creationId xmlns:a16="http://schemas.microsoft.com/office/drawing/2014/main" id="{1D208EF8-4144-4192-977A-7AC4323C0081}"/>
               </a:ext>
             </a:extLst>
           </p:cNvPr>
@@ -8496,7 +8238,7 @@
           <p:cNvPr id="2" name="">
             <a:extLst xmlns:a="http://schemas.openxmlformats.org/drawingml/2006/main">
               <a:ext uri="{FF2B5EF4-FFF2-40B4-BE49-F238E27FC236}">
-                <a16:creationId xmlns:a16="http://schemas.microsoft.com/office/drawing/2014/main" id="{E6232127-DB1D-475B-8DFF-64DF9D7D6E43}"/>
+                <a16:creationId xmlns:a16="http://schemas.microsoft.com/office/drawing/2014/main" id="{67507A11-8F15-4989-9E2C-D41232D009D7}"/>
               </a:ext>
             </a:extLst>
           </p:cNvPr>
@@ -8531,7 +8273,7 @@
           <p:cNvPr id="3" name="">
             <a:extLst xmlns:a="http://schemas.openxmlformats.org/drawingml/2006/main">
               <a:ext uri="{FF2B5EF4-FFF2-40B4-BE49-F238E27FC236}">
-                <a16:creationId xmlns:a16="http://schemas.microsoft.com/office/drawing/2014/main" id="{7A1E622A-FC8B-4B8B-A8F5-D6F1B0FD7E62}"/>
+                <a16:creationId xmlns:a16="http://schemas.microsoft.com/office/drawing/2014/main" id="{57352E78-601D-4393-B7EB-FB143A17238F}"/>
               </a:ext>
             </a:extLst>
           </p:cNvPr>
@@ -8595,7 +8337,7 @@
           <p:cNvPr id="4" name="">
             <a:extLst xmlns:a="http://schemas.openxmlformats.org/drawingml/2006/main">
               <a:ext uri="{FF2B5EF4-FFF2-40B4-BE49-F238E27FC236}">
-                <a16:creationId xmlns:a16="http://schemas.microsoft.com/office/drawing/2014/main" id="{A3E91B87-62D0-4EAC-B162-19BF8AA0A629}"/>
+                <a16:creationId xmlns:a16="http://schemas.microsoft.com/office/drawing/2014/main" id="{C141FD34-7A26-4B7C-9725-914B26DD3732}"/>
               </a:ext>
             </a:extLst>
           </p:cNvPr>
@@ -8659,7 +8401,7 @@
           <p:cNvPr id="5" name="">
             <a:extLst xmlns:a="http://schemas.openxmlformats.org/drawingml/2006/main">
               <a:ext uri="{FF2B5EF4-FFF2-40B4-BE49-F238E27FC236}">
-                <a16:creationId xmlns:a16="http://schemas.microsoft.com/office/drawing/2014/main" id="{753A76E6-9DB7-48C9-8482-E25F4E138C5F}"/>
+                <a16:creationId xmlns:a16="http://schemas.microsoft.com/office/drawing/2014/main" id="{BFAC20DB-27E4-4405-A2A0-52EDC26A6927}"/>
               </a:ext>
             </a:extLst>
           </p:cNvPr>
@@ -8723,7 +8465,7 @@
           <p:cNvPr id="6" name="">
             <a:extLst xmlns:a="http://schemas.openxmlformats.org/drawingml/2006/main">
               <a:ext uri="{FF2B5EF4-FFF2-40B4-BE49-F238E27FC236}">
-                <a16:creationId xmlns:a16="http://schemas.microsoft.com/office/drawing/2014/main" id="{AFCB455E-B793-421D-8D3F-FC205E534D7F}"/>
+                <a16:creationId xmlns:a16="http://schemas.microsoft.com/office/drawing/2014/main" id="{B81B8C4A-9E7E-4498-9EE9-3DF6323CF08A}"/>
               </a:ext>
             </a:extLst>
           </p:cNvPr>
@@ -8787,7 +8529,7 @@
           <p:cNvPr id="7" name="">
             <a:extLst xmlns:a="http://schemas.openxmlformats.org/drawingml/2006/main">
               <a:ext uri="{FF2B5EF4-FFF2-40B4-BE49-F238E27FC236}">
-                <a16:creationId xmlns:a16="http://schemas.microsoft.com/office/drawing/2014/main" id="{CD1D6E72-938A-4F88-867F-D3483747DA10}"/>
+                <a16:creationId xmlns:a16="http://schemas.microsoft.com/office/drawing/2014/main" id="{69D3B9AB-4130-4F5C-BCE5-9982F5C404C6}"/>
               </a:ext>
             </a:extLst>
           </p:cNvPr>
@@ -8820,7 +8562,7 @@
           <p:cNvPr id="8" name="">
             <a:extLst xmlns:a="http://schemas.openxmlformats.org/drawingml/2006/main">
               <a:ext uri="{FF2B5EF4-FFF2-40B4-BE49-F238E27FC236}">
-                <a16:creationId xmlns:a16="http://schemas.microsoft.com/office/drawing/2014/main" id="{10E3A787-D91F-4C93-BD11-32667FD77CDD}"/>
+                <a16:creationId xmlns:a16="http://schemas.microsoft.com/office/drawing/2014/main" id="{B2D49F8C-A3FB-486A-9367-678E2AA93C6F}"/>
               </a:ext>
             </a:extLst>
           </p:cNvPr>
@@ -8884,7 +8626,7 @@
           <p:cNvPr id="9" name="">
             <a:extLst xmlns:a="http://schemas.openxmlformats.org/drawingml/2006/main">
               <a:ext uri="{FF2B5EF4-FFF2-40B4-BE49-F238E27FC236}">
-                <a16:creationId xmlns:a16="http://schemas.microsoft.com/office/drawing/2014/main" id="{1D44AAAF-4AEF-4DEF-93FE-958FF3AF3D7D}"/>
+                <a16:creationId xmlns:a16="http://schemas.microsoft.com/office/drawing/2014/main" id="{40212FC5-8D5A-4976-9E8C-538F85E3D1C5}"/>
               </a:ext>
             </a:extLst>
           </p:cNvPr>
@@ -8971,7 +8713,7 @@
           <p:cNvPr id="10" name="">
             <a:extLst xmlns:a="http://schemas.openxmlformats.org/drawingml/2006/main">
               <a:ext uri="{FF2B5EF4-FFF2-40B4-BE49-F238E27FC236}">
-                <a16:creationId xmlns:a16="http://schemas.microsoft.com/office/drawing/2014/main" id="{1C972403-2430-470D-BCFE-D4330063AD60}"/>
+                <a16:creationId xmlns:a16="http://schemas.microsoft.com/office/drawing/2014/main" id="{E003A3E2-261F-49B3-AA45-6AA31BFBBF0D}"/>
               </a:ext>
             </a:extLst>
           </p:cNvPr>
@@ -9004,7 +8746,7 @@
           <p:cNvPr id="11" name="">
             <a:extLst xmlns:a="http://schemas.openxmlformats.org/drawingml/2006/main">
               <a:ext uri="{FF2B5EF4-FFF2-40B4-BE49-F238E27FC236}">
-                <a16:creationId xmlns:a16="http://schemas.microsoft.com/office/drawing/2014/main" id="{ABF367BD-AFA6-451A-A9D9-5575E09161F0}"/>
+                <a16:creationId xmlns:a16="http://schemas.microsoft.com/office/drawing/2014/main" id="{7DE328A5-2C73-4FDC-B599-26E7B9C77F2D}"/>
               </a:ext>
             </a:extLst>
           </p:cNvPr>
@@ -9068,7 +8810,7 @@
           <p:cNvPr id="12" name="">
             <a:extLst xmlns:a="http://schemas.openxmlformats.org/drawingml/2006/main">
               <a:ext uri="{FF2B5EF4-FFF2-40B4-BE49-F238E27FC236}">
-                <a16:creationId xmlns:a16="http://schemas.microsoft.com/office/drawing/2014/main" id="{8C9741BF-9C4F-4AA4-B242-C4BF6342B332}"/>
+                <a16:creationId xmlns:a16="http://schemas.microsoft.com/office/drawing/2014/main" id="{CF47D612-817F-4D9F-8744-54D6EE2DDE87}"/>
               </a:ext>
             </a:extLst>
           </p:cNvPr>
@@ -9155,7 +8897,7 @@
           <p:cNvPr id="13" name="">
             <a:extLst xmlns:a="http://schemas.openxmlformats.org/drawingml/2006/main">
               <a:ext uri="{FF2B5EF4-FFF2-40B4-BE49-F238E27FC236}">
-                <a16:creationId xmlns:a16="http://schemas.microsoft.com/office/drawing/2014/main" id="{35DAA97D-A5AF-4A40-BB21-CBE480CA38E8}"/>
+                <a16:creationId xmlns:a16="http://schemas.microsoft.com/office/drawing/2014/main" id="{7E5ADB0E-EEAE-48B2-8CB0-9214DF120C76}"/>
               </a:ext>
             </a:extLst>
           </p:cNvPr>
@@ -9188,7 +8930,7 @@
           <p:cNvPr id="14" name="">
             <a:extLst xmlns:a="http://schemas.openxmlformats.org/drawingml/2006/main">
               <a:ext uri="{FF2B5EF4-FFF2-40B4-BE49-F238E27FC236}">
-                <a16:creationId xmlns:a16="http://schemas.microsoft.com/office/drawing/2014/main" id="{8848BD14-20DE-403D-BFD6-F7EE85D6B293}"/>
+                <a16:creationId xmlns:a16="http://schemas.microsoft.com/office/drawing/2014/main" id="{3C91977D-C8DF-401E-8736-514C3D2E2515}"/>
               </a:ext>
             </a:extLst>
           </p:cNvPr>
@@ -9252,7 +8994,7 @@
           <p:cNvPr id="15" name="">
             <a:extLst xmlns:a="http://schemas.openxmlformats.org/drawingml/2006/main">
               <a:ext uri="{FF2B5EF4-FFF2-40B4-BE49-F238E27FC236}">
-                <a16:creationId xmlns:a16="http://schemas.microsoft.com/office/drawing/2014/main" id="{032A4766-3C29-4D75-93E7-DED8A8A0B19E}"/>
+                <a16:creationId xmlns:a16="http://schemas.microsoft.com/office/drawing/2014/main" id="{4D35BC06-9408-4C87-A25B-46E479ECFB28}"/>
               </a:ext>
             </a:extLst>
           </p:cNvPr>
@@ -9339,7 +9081,7 @@
           <p:cNvPr id="16" name="">
             <a:extLst xmlns:a="http://schemas.openxmlformats.org/drawingml/2006/main">
               <a:ext uri="{FF2B5EF4-FFF2-40B4-BE49-F238E27FC236}">
-                <a16:creationId xmlns:a16="http://schemas.microsoft.com/office/drawing/2014/main" id="{7F305C2D-B10F-4065-8000-8938A606C3B9}"/>
+                <a16:creationId xmlns:a16="http://schemas.microsoft.com/office/drawing/2014/main" id="{7E4F07EF-9ABE-4415-8180-E5CA7051F44F}"/>
               </a:ext>
             </a:extLst>
           </p:cNvPr>
@@ -9374,7 +9116,7 @@
           <p:cNvPr id="17" name="">
             <a:extLst xmlns:a="http://schemas.openxmlformats.org/drawingml/2006/main">
               <a:ext uri="{FF2B5EF4-FFF2-40B4-BE49-F238E27FC236}">
-                <a16:creationId xmlns:a16="http://schemas.microsoft.com/office/drawing/2014/main" id="{F19FCBB7-10FB-422F-8E9E-2D0DA578DCA8}"/>
+                <a16:creationId xmlns:a16="http://schemas.microsoft.com/office/drawing/2014/main" id="{0491956D-6E58-4C7F-A22D-0CF30DEEE1E8}"/>
               </a:ext>
             </a:extLst>
           </p:cNvPr>
@@ -9409,7 +9151,7 @@
           <p:cNvPr id="18" name="">
             <a:extLst xmlns:a="http://schemas.openxmlformats.org/drawingml/2006/main">
               <a:ext uri="{FF2B5EF4-FFF2-40B4-BE49-F238E27FC236}">
-                <a16:creationId xmlns:a16="http://schemas.microsoft.com/office/drawing/2014/main" id="{1E7C7D14-A595-4C8C-881E-BB182D1139D8}"/>
+                <a16:creationId xmlns:a16="http://schemas.microsoft.com/office/drawing/2014/main" id="{AB9555AC-DC5F-4263-AB8E-4BED19454073}"/>
               </a:ext>
             </a:extLst>
           </p:cNvPr>
@@ -9442,7 +9184,7 @@
           <p:cNvPr id="19" name="">
             <a:extLst xmlns:a="http://schemas.openxmlformats.org/drawingml/2006/main">
               <a:ext uri="{FF2B5EF4-FFF2-40B4-BE49-F238E27FC236}">
-                <a16:creationId xmlns:a16="http://schemas.microsoft.com/office/drawing/2014/main" id="{FD492F8B-DDAE-4D89-AF24-483435C586BA}"/>
+                <a16:creationId xmlns:a16="http://schemas.microsoft.com/office/drawing/2014/main" id="{6FC73EB0-F044-49BD-9758-0E91A716EB58}"/>
               </a:ext>
             </a:extLst>
           </p:cNvPr>
@@ -9506,7 +9248,7 @@
           <p:cNvPr id="20" name="">
             <a:extLst xmlns:a="http://schemas.openxmlformats.org/drawingml/2006/main">
               <a:ext uri="{FF2B5EF4-FFF2-40B4-BE49-F238E27FC236}">
-                <a16:creationId xmlns:a16="http://schemas.microsoft.com/office/drawing/2014/main" id="{3E78A1E2-99D7-4758-9FCE-11F0CFACB149}"/>
+                <a16:creationId xmlns:a16="http://schemas.microsoft.com/office/drawing/2014/main" id="{1B37526F-7376-4DB4-9AA5-0D37192906BC}"/>
               </a:ext>
             </a:extLst>
           </p:cNvPr>
@@ -9570,7 +9312,7 @@
           <p:cNvPr id="21" name="">
             <a:extLst xmlns:a="http://schemas.openxmlformats.org/drawingml/2006/main">
               <a:ext uri="{FF2B5EF4-FFF2-40B4-BE49-F238E27FC236}">
-                <a16:creationId xmlns:a16="http://schemas.microsoft.com/office/drawing/2014/main" id="{B0FDA0EF-F244-4812-9E52-E1EC3A35F0DD}"/>
+                <a16:creationId xmlns:a16="http://schemas.microsoft.com/office/drawing/2014/main" id="{DDB7FB05-7307-4003-ADA1-013E3D70C3E1}"/>
               </a:ext>
             </a:extLst>
           </p:cNvPr>
@@ -9605,7 +9347,7 @@
           <p:cNvPr id="22" name="">
             <a:extLst xmlns:a="http://schemas.openxmlformats.org/drawingml/2006/main">
               <a:ext uri="{FF2B5EF4-FFF2-40B4-BE49-F238E27FC236}">
-                <a16:creationId xmlns:a16="http://schemas.microsoft.com/office/drawing/2014/main" id="{EE634810-1961-4F75-AD69-7D1E034D5EC8}"/>
+                <a16:creationId xmlns:a16="http://schemas.microsoft.com/office/drawing/2014/main" id="{48237FF6-2294-44FC-A391-D0ED2C61D787}"/>
               </a:ext>
             </a:extLst>
           </p:cNvPr>
@@ -9669,7 +9411,7 @@
           <p:cNvPr id="23" name="">
             <a:extLst xmlns:a="http://schemas.openxmlformats.org/drawingml/2006/main">
               <a:ext uri="{FF2B5EF4-FFF2-40B4-BE49-F238E27FC236}">
-                <a16:creationId xmlns:a16="http://schemas.microsoft.com/office/drawing/2014/main" id="{5056545B-DDE0-4420-9EB3-FF71541F3340}"/>
+                <a16:creationId xmlns:a16="http://schemas.microsoft.com/office/drawing/2014/main" id="{7C7F3E59-7541-43E3-B2CE-DBD1FFC2586F}"/>
               </a:ext>
             </a:extLst>
           </p:cNvPr>
@@ -9731,7 +9473,7 @@
     </p:spTree>
     <p:extLst>
       <p:ext uri="{BB962C8B-B14F-4D97-AF65-F5344CB8AC3E}">
-        <p14:creationId xmlns:p14="http://schemas.microsoft.com/office/powerpoint/2010/main" val="458871186"/>
+        <p14:creationId xmlns:p14="http://schemas.microsoft.com/office/powerpoint/2010/main" val="1621232613"/>
       </p:ext>
     </p:extLst>
   </p:cSld>
@@ -9755,7 +9497,7 @@
           <p:cNvPr id="1" name="">
             <a:extLst xmlns:a="http://schemas.openxmlformats.org/drawingml/2006/main">
               <a:ext uri="{FF2B5EF4-FFF2-40B4-BE49-F238E27FC236}">
-                <a16:creationId xmlns:a16="http://schemas.microsoft.com/office/drawing/2014/main" id="{D746EA1B-DBFE-49CF-B865-9AB5785474B4}"/>
+                <a16:creationId xmlns:a16="http://schemas.microsoft.com/office/drawing/2014/main" id="{FEA4DC4B-73E1-4F50-A1F3-B323392D5201}"/>
               </a:ext>
             </a:extLst>
           </p:cNvPr>
@@ -9790,7 +9532,7 @@
           <p:cNvPr id="2" name="">
             <a:extLst xmlns:a="http://schemas.openxmlformats.org/drawingml/2006/main">
               <a:ext uri="{FF2B5EF4-FFF2-40B4-BE49-F238E27FC236}">
-                <a16:creationId xmlns:a16="http://schemas.microsoft.com/office/drawing/2014/main" id="{DE1A3948-B2DF-4C1B-AC66-E893DEFD570C}"/>
+                <a16:creationId xmlns:a16="http://schemas.microsoft.com/office/drawing/2014/main" id="{17A2E701-E0B3-4000-B1B2-75C1D3A1CF37}"/>
               </a:ext>
             </a:extLst>
           </p:cNvPr>
@@ -9825,7 +9567,7 @@
           <p:cNvPr id="3" name="">
             <a:extLst xmlns:a="http://schemas.openxmlformats.org/drawingml/2006/main">
               <a:ext uri="{FF2B5EF4-FFF2-40B4-BE49-F238E27FC236}">
-                <a16:creationId xmlns:a16="http://schemas.microsoft.com/office/drawing/2014/main" id="{92248CFF-66E7-47EE-A803-4AFDB7A35E12}"/>
+                <a16:creationId xmlns:a16="http://schemas.microsoft.com/office/drawing/2014/main" id="{4C380F7C-E008-4C12-9988-108E9CD1C7A2}"/>
               </a:ext>
             </a:extLst>
           </p:cNvPr>
@@ -9889,7 +9631,7 @@
           <p:cNvPr id="4" name="">
             <a:extLst xmlns:a="http://schemas.openxmlformats.org/drawingml/2006/main">
               <a:ext uri="{FF2B5EF4-FFF2-40B4-BE49-F238E27FC236}">
-                <a16:creationId xmlns:a16="http://schemas.microsoft.com/office/drawing/2014/main" id="{BD517F02-F400-4655-A095-A9A4407E4011}"/>
+                <a16:creationId xmlns:a16="http://schemas.microsoft.com/office/drawing/2014/main" id="{F0528798-78D3-431C-8408-6F1D3C4D452D}"/>
               </a:ext>
             </a:extLst>
           </p:cNvPr>
@@ -9953,7 +9695,7 @@
           <p:cNvPr id="5" name="">
             <a:extLst xmlns:a="http://schemas.openxmlformats.org/drawingml/2006/main">
               <a:ext uri="{FF2B5EF4-FFF2-40B4-BE49-F238E27FC236}">
-                <a16:creationId xmlns:a16="http://schemas.microsoft.com/office/drawing/2014/main" id="{E05188CD-40F1-4834-9201-7B81AB0E79ED}"/>
+                <a16:creationId xmlns:a16="http://schemas.microsoft.com/office/drawing/2014/main" id="{CF6DD029-B455-4D6D-ABAA-EE4DA0988A67}"/>
               </a:ext>
             </a:extLst>
           </p:cNvPr>
@@ -10017,7 +9759,7 @@
           <p:cNvPr id="6" name="">
             <a:extLst xmlns:a="http://schemas.openxmlformats.org/drawingml/2006/main">
               <a:ext uri="{FF2B5EF4-FFF2-40B4-BE49-F238E27FC236}">
-                <a16:creationId xmlns:a16="http://schemas.microsoft.com/office/drawing/2014/main" id="{B201F6FB-608F-466F-BA69-1324DF1B57D4}"/>
+                <a16:creationId xmlns:a16="http://schemas.microsoft.com/office/drawing/2014/main" id="{48A445EC-0D9C-4A8F-926B-C0936BEE0558}"/>
               </a:ext>
             </a:extLst>
           </p:cNvPr>
@@ -10050,7 +9792,7 @@
           <p:cNvPr id="7" name="">
             <a:extLst xmlns:a="http://schemas.openxmlformats.org/drawingml/2006/main">
               <a:ext uri="{FF2B5EF4-FFF2-40B4-BE49-F238E27FC236}">
-                <a16:creationId xmlns:a16="http://schemas.microsoft.com/office/drawing/2014/main" id="{1BA39291-9944-4952-8B18-96344BAC0D4D}"/>
+                <a16:creationId xmlns:a16="http://schemas.microsoft.com/office/drawing/2014/main" id="{B36990B3-052E-4BF8-8370-F87A2221FEFE}"/>
               </a:ext>
             </a:extLst>
           </p:cNvPr>
@@ -10114,7 +9856,7 @@
           <p:cNvPr id="8" name="">
             <a:extLst xmlns:a="http://schemas.openxmlformats.org/drawingml/2006/main">
               <a:ext uri="{FF2B5EF4-FFF2-40B4-BE49-F238E27FC236}">
-                <a16:creationId xmlns:a16="http://schemas.microsoft.com/office/drawing/2014/main" id="{C3F22E97-770B-419C-B0D9-0C2D4090AFCB}"/>
+                <a16:creationId xmlns:a16="http://schemas.microsoft.com/office/drawing/2014/main" id="{02FC9134-2B7B-4F78-ABC4-BDB023A069CA}"/>
               </a:ext>
             </a:extLst>
           </p:cNvPr>
@@ -10270,7 +10012,7 @@
           <p:cNvPr id="9" name="">
             <a:extLst xmlns:a="http://schemas.openxmlformats.org/drawingml/2006/main">
               <a:ext uri="{FF2B5EF4-FFF2-40B4-BE49-F238E27FC236}">
-                <a16:creationId xmlns:a16="http://schemas.microsoft.com/office/drawing/2014/main" id="{BBB9FDA3-C33F-4B2B-9BCC-E936C4452C37}"/>
+                <a16:creationId xmlns:a16="http://schemas.microsoft.com/office/drawing/2014/main" id="{D8151759-A21E-405A-A600-C662B7F21E8F}"/>
               </a:ext>
             </a:extLst>
           </p:cNvPr>
@@ -10303,7 +10045,7 @@
           <p:cNvPr id="10" name="">
             <a:extLst xmlns:a="http://schemas.openxmlformats.org/drawingml/2006/main">
               <a:ext uri="{FF2B5EF4-FFF2-40B4-BE49-F238E27FC236}">
-                <a16:creationId xmlns:a16="http://schemas.microsoft.com/office/drawing/2014/main" id="{6FD8A061-E70F-4E4E-B1BF-8EF938D77F09}"/>
+                <a16:creationId xmlns:a16="http://schemas.microsoft.com/office/drawing/2014/main" id="{778E5516-EC7C-42A7-9206-32930940A01E}"/>
               </a:ext>
             </a:extLst>
           </p:cNvPr>
@@ -10367,7 +10109,7 @@
           <p:cNvPr id="11" name="">
             <a:extLst xmlns:a="http://schemas.openxmlformats.org/drawingml/2006/main">
               <a:ext uri="{FF2B5EF4-FFF2-40B4-BE49-F238E27FC236}">
-                <a16:creationId xmlns:a16="http://schemas.microsoft.com/office/drawing/2014/main" id="{8634A9DE-4A51-4869-9CF7-4E24A67EE416}"/>
+                <a16:creationId xmlns:a16="http://schemas.microsoft.com/office/drawing/2014/main" id="{DD924EA8-EB2F-40B3-A9C1-9A112F0A2EF4}"/>
               </a:ext>
             </a:extLst>
           </p:cNvPr>
@@ -10477,7 +10219,7 @@
           <p:cNvPr id="12" name="">
             <a:extLst xmlns:a="http://schemas.openxmlformats.org/drawingml/2006/main">
               <a:ext uri="{FF2B5EF4-FFF2-40B4-BE49-F238E27FC236}">
-                <a16:creationId xmlns:a16="http://schemas.microsoft.com/office/drawing/2014/main" id="{161F4696-D074-4930-B628-7EF277A8BB7A}"/>
+                <a16:creationId xmlns:a16="http://schemas.microsoft.com/office/drawing/2014/main" id="{E5C629D8-A67E-48A0-9528-530296DC0C8B}"/>
               </a:ext>
             </a:extLst>
           </p:cNvPr>
@@ -10510,7 +10252,7 @@
           <p:cNvPr id="13" name="">
             <a:extLst xmlns:a="http://schemas.openxmlformats.org/drawingml/2006/main">
               <a:ext uri="{FF2B5EF4-FFF2-40B4-BE49-F238E27FC236}">
-                <a16:creationId xmlns:a16="http://schemas.microsoft.com/office/drawing/2014/main" id="{5FA17E66-ECDF-49CD-B2C1-2C269ACE916A}"/>
+                <a16:creationId xmlns:a16="http://schemas.microsoft.com/office/drawing/2014/main" id="{3C4AF593-679D-4B66-B578-0838D4FA963D}"/>
               </a:ext>
             </a:extLst>
           </p:cNvPr>
@@ -10574,7 +10316,7 @@
           <p:cNvPr id="14" name="">
             <a:extLst xmlns:a="http://schemas.openxmlformats.org/drawingml/2006/main">
               <a:ext uri="{FF2B5EF4-FFF2-40B4-BE49-F238E27FC236}">
-                <a16:creationId xmlns:a16="http://schemas.microsoft.com/office/drawing/2014/main" id="{44F8706F-C959-461F-BE63-BCF6E6B58490}"/>
+                <a16:creationId xmlns:a16="http://schemas.microsoft.com/office/drawing/2014/main" id="{8FAB8156-AED5-4986-BF51-46635E6C6DEB}"/>
               </a:ext>
             </a:extLst>
           </p:cNvPr>
@@ -10707,7 +10449,7 @@
           <p:cNvPr id="15" name="">
             <a:extLst xmlns:a="http://schemas.openxmlformats.org/drawingml/2006/main">
               <a:ext uri="{FF2B5EF4-FFF2-40B4-BE49-F238E27FC236}">
-                <a16:creationId xmlns:a16="http://schemas.microsoft.com/office/drawing/2014/main" id="{49AA9AD2-0100-474A-B875-C9EF993A3841}"/>
+                <a16:creationId xmlns:a16="http://schemas.microsoft.com/office/drawing/2014/main" id="{CC6D6188-51C5-49BD-BE25-006E61749FD1}"/>
               </a:ext>
             </a:extLst>
           </p:cNvPr>
@@ -10740,7 +10482,7 @@
           <p:cNvPr id="16" name="">
             <a:extLst xmlns:a="http://schemas.openxmlformats.org/drawingml/2006/main">
               <a:ext uri="{FF2B5EF4-FFF2-40B4-BE49-F238E27FC236}">
-                <a16:creationId xmlns:a16="http://schemas.microsoft.com/office/drawing/2014/main" id="{F6E3CF27-D199-4CCA-9D8E-EF43AAAF252F}"/>
+                <a16:creationId xmlns:a16="http://schemas.microsoft.com/office/drawing/2014/main" id="{8259A013-DFB9-4EA7-9232-43BBF798ACD2}"/>
               </a:ext>
             </a:extLst>
           </p:cNvPr>
@@ -10804,7 +10546,7 @@
           <p:cNvPr id="17" name="">
             <a:extLst xmlns:a="http://schemas.openxmlformats.org/drawingml/2006/main">
               <a:ext uri="{FF2B5EF4-FFF2-40B4-BE49-F238E27FC236}">
-                <a16:creationId xmlns:a16="http://schemas.microsoft.com/office/drawing/2014/main" id="{43214B8A-F26A-4680-A218-F2338A029644}"/>
+                <a16:creationId xmlns:a16="http://schemas.microsoft.com/office/drawing/2014/main" id="{FF8B0E78-1218-4D9D-8FF1-D2B316B0E3C7}"/>
               </a:ext>
             </a:extLst>
           </p:cNvPr>
@@ -10937,7 +10679,7 @@
           <p:cNvPr id="18" name="">
             <a:extLst xmlns:a="http://schemas.openxmlformats.org/drawingml/2006/main">
               <a:ext uri="{FF2B5EF4-FFF2-40B4-BE49-F238E27FC236}">
-                <a16:creationId xmlns:a16="http://schemas.microsoft.com/office/drawing/2014/main" id="{A748135F-8773-48A6-8B08-6C6902579320}"/>
+                <a16:creationId xmlns:a16="http://schemas.microsoft.com/office/drawing/2014/main" id="{699F5182-0BC1-4909-A73D-8533C4726019}"/>
               </a:ext>
             </a:extLst>
           </p:cNvPr>
@@ -10970,7 +10712,7 @@
           <p:cNvPr id="19" name="">
             <a:extLst xmlns:a="http://schemas.openxmlformats.org/drawingml/2006/main">
               <a:ext uri="{FF2B5EF4-FFF2-40B4-BE49-F238E27FC236}">
-                <a16:creationId xmlns:a16="http://schemas.microsoft.com/office/drawing/2014/main" id="{7B5CBE8D-18DA-4513-BD52-575636078B32}"/>
+                <a16:creationId xmlns:a16="http://schemas.microsoft.com/office/drawing/2014/main" id="{5463145D-B6AB-4EEE-B4DF-6FAAEE11531E}"/>
               </a:ext>
             </a:extLst>
           </p:cNvPr>
@@ -11034,7 +10776,7 @@
           <p:cNvPr id="20" name="">
             <a:extLst xmlns:a="http://schemas.openxmlformats.org/drawingml/2006/main">
               <a:ext uri="{FF2B5EF4-FFF2-40B4-BE49-F238E27FC236}">
-                <a16:creationId xmlns:a16="http://schemas.microsoft.com/office/drawing/2014/main" id="{41F4A862-270D-4C66-8523-518019A3D341}"/>
+                <a16:creationId xmlns:a16="http://schemas.microsoft.com/office/drawing/2014/main" id="{3C9FBA6C-4917-4BBE-B164-EA87021CF32C}"/>
               </a:ext>
             </a:extLst>
           </p:cNvPr>
@@ -11144,7 +10886,7 @@
           <p:cNvPr id="21" name="">
             <a:extLst xmlns:a="http://schemas.openxmlformats.org/drawingml/2006/main">
               <a:ext uri="{FF2B5EF4-FFF2-40B4-BE49-F238E27FC236}">
-                <a16:creationId xmlns:a16="http://schemas.microsoft.com/office/drawing/2014/main" id="{54FFDCE6-6B3B-4E47-9B2C-4E4471CB8A3B}"/>
+                <a16:creationId xmlns:a16="http://schemas.microsoft.com/office/drawing/2014/main" id="{66CDC748-439B-4916-842B-BD6F5C99C891}"/>
               </a:ext>
             </a:extLst>
           </p:cNvPr>
@@ -11177,7 +10919,7 @@
           <p:cNvPr id="22" name="">
             <a:extLst xmlns:a="http://schemas.openxmlformats.org/drawingml/2006/main">
               <a:ext uri="{FF2B5EF4-FFF2-40B4-BE49-F238E27FC236}">
-                <a16:creationId xmlns:a16="http://schemas.microsoft.com/office/drawing/2014/main" id="{05FAC466-C4BE-43A0-9CA7-8A450B699984}"/>
+                <a16:creationId xmlns:a16="http://schemas.microsoft.com/office/drawing/2014/main" id="{E2DFBCE7-6D68-49AB-836A-87D5C3B8E97E}"/>
               </a:ext>
             </a:extLst>
           </p:cNvPr>
@@ -11241,7 +10983,7 @@
           <p:cNvPr id="23" name="">
             <a:extLst xmlns:a="http://schemas.openxmlformats.org/drawingml/2006/main">
               <a:ext uri="{FF2B5EF4-FFF2-40B4-BE49-F238E27FC236}">
-                <a16:creationId xmlns:a16="http://schemas.microsoft.com/office/drawing/2014/main" id="{D8432254-0E42-4548-A41F-6B611129624D}"/>
+                <a16:creationId xmlns:a16="http://schemas.microsoft.com/office/drawing/2014/main" id="{D76918D4-8C57-4A90-9341-389DF3FDC6BE}"/>
               </a:ext>
             </a:extLst>
           </p:cNvPr>
@@ -11351,7 +11093,7 @@
           <p:cNvPr id="24" name="">
             <a:extLst xmlns:a="http://schemas.openxmlformats.org/drawingml/2006/main">
               <a:ext uri="{FF2B5EF4-FFF2-40B4-BE49-F238E27FC236}">
-                <a16:creationId xmlns:a16="http://schemas.microsoft.com/office/drawing/2014/main" id="{9CB559CD-1797-45EF-AD83-7BE05BD563B1}"/>
+                <a16:creationId xmlns:a16="http://schemas.microsoft.com/office/drawing/2014/main" id="{5F5F3FF0-24A2-4A1F-B216-DA0876C4BF70}"/>
               </a:ext>
             </a:extLst>
           </p:cNvPr>
@@ -11386,7 +11128,7 @@
           <p:cNvPr id="25" name="">
             <a:extLst xmlns:a="http://schemas.openxmlformats.org/drawingml/2006/main">
               <a:ext uri="{FF2B5EF4-FFF2-40B4-BE49-F238E27FC236}">
-                <a16:creationId xmlns:a16="http://schemas.microsoft.com/office/drawing/2014/main" id="{631EB411-4141-41F8-A2B4-8842B66F1888}"/>
+                <a16:creationId xmlns:a16="http://schemas.microsoft.com/office/drawing/2014/main" id="{B11E9F16-EA26-408F-8831-5D8493333E79}"/>
               </a:ext>
             </a:extLst>
           </p:cNvPr>
@@ -11421,7 +11163,7 @@
           <p:cNvPr id="26" name="">
             <a:extLst xmlns:a="http://schemas.openxmlformats.org/drawingml/2006/main">
               <a:ext uri="{FF2B5EF4-FFF2-40B4-BE49-F238E27FC236}">
-                <a16:creationId xmlns:a16="http://schemas.microsoft.com/office/drawing/2014/main" id="{D8B77A86-B5C3-45D9-A4FA-121E3A94FF4B}"/>
+                <a16:creationId xmlns:a16="http://schemas.microsoft.com/office/drawing/2014/main" id="{9769DED3-AB64-4E01-992B-086C85B3835C}"/>
               </a:ext>
             </a:extLst>
           </p:cNvPr>
@@ -11456,7 +11198,7 @@
           <p:cNvPr id="27" name="">
             <a:extLst xmlns:a="http://schemas.openxmlformats.org/drawingml/2006/main">
               <a:ext uri="{FF2B5EF4-FFF2-40B4-BE49-F238E27FC236}">
-                <a16:creationId xmlns:a16="http://schemas.microsoft.com/office/drawing/2014/main" id="{368B3E79-62AD-4CAD-962D-B062C042DF16}"/>
+                <a16:creationId xmlns:a16="http://schemas.microsoft.com/office/drawing/2014/main" id="{97A7A6E3-EF41-4844-BF79-27FFCBAF4D5A}"/>
               </a:ext>
             </a:extLst>
           </p:cNvPr>
@@ -11491,7 +11233,7 @@
           <p:cNvPr id="28" name="">
             <a:extLst xmlns:a="http://schemas.openxmlformats.org/drawingml/2006/main">
               <a:ext uri="{FF2B5EF4-FFF2-40B4-BE49-F238E27FC236}">
-                <a16:creationId xmlns:a16="http://schemas.microsoft.com/office/drawing/2014/main" id="{11F8DCD0-DA33-489F-8424-8F98BC04A0E2}"/>
+                <a16:creationId xmlns:a16="http://schemas.microsoft.com/office/drawing/2014/main" id="{605009F5-FAF8-46B1-B302-051E24FFD3C7}"/>
               </a:ext>
             </a:extLst>
           </p:cNvPr>
@@ -11526,7 +11268,7 @@
           <p:cNvPr id="29" name="">
             <a:extLst xmlns:a="http://schemas.openxmlformats.org/drawingml/2006/main">
               <a:ext uri="{FF2B5EF4-FFF2-40B4-BE49-F238E27FC236}">
-                <a16:creationId xmlns:a16="http://schemas.microsoft.com/office/drawing/2014/main" id="{9C4ED8B6-5D4E-4F6B-83E3-E908B7A4F855}"/>
+                <a16:creationId xmlns:a16="http://schemas.microsoft.com/office/drawing/2014/main" id="{4819E37A-9EDC-4BC3-A312-9108F396ED8A}"/>
               </a:ext>
             </a:extLst>
           </p:cNvPr>
@@ -11590,7 +11332,7 @@
           <p:cNvPr id="30" name="">
             <a:extLst xmlns:a="http://schemas.openxmlformats.org/drawingml/2006/main">
               <a:ext uri="{FF2B5EF4-FFF2-40B4-BE49-F238E27FC236}">
-                <a16:creationId xmlns:a16="http://schemas.microsoft.com/office/drawing/2014/main" id="{22590819-D6F0-4914-B49B-CC338BC1AB1E}"/>
+                <a16:creationId xmlns:a16="http://schemas.microsoft.com/office/drawing/2014/main" id="{D7E99F29-00DB-4ADD-85B0-521FA519A9EC}"/>
               </a:ext>
             </a:extLst>
           </p:cNvPr>
@@ -11625,7 +11367,7 @@
           <p:cNvPr id="31" name="">
             <a:extLst xmlns:a="http://schemas.openxmlformats.org/drawingml/2006/main">
               <a:ext uri="{FF2B5EF4-FFF2-40B4-BE49-F238E27FC236}">
-                <a16:creationId xmlns:a16="http://schemas.microsoft.com/office/drawing/2014/main" id="{F3B33639-5F3A-48FC-9395-A7AA5A297216}"/>
+                <a16:creationId xmlns:a16="http://schemas.microsoft.com/office/drawing/2014/main" id="{B28A5087-0004-4D82-A11A-3DCAC9D0D25B}"/>
               </a:ext>
             </a:extLst>
           </p:cNvPr>
@@ -11689,7 +11431,7 @@
           <p:cNvPr id="32" name="">
             <a:extLst xmlns:a="http://schemas.openxmlformats.org/drawingml/2006/main">
               <a:ext uri="{FF2B5EF4-FFF2-40B4-BE49-F238E27FC236}">
-                <a16:creationId xmlns:a16="http://schemas.microsoft.com/office/drawing/2014/main" id="{38F83BEB-3905-49D8-A1B9-C09ED353721B}"/>
+                <a16:creationId xmlns:a16="http://schemas.microsoft.com/office/drawing/2014/main" id="{E0A27DD9-8144-44E9-82D8-063AA018E5D8}"/>
               </a:ext>
             </a:extLst>
           </p:cNvPr>
@@ -11751,7 +11493,7 @@
     </p:spTree>
     <p:extLst>
       <p:ext uri="{BB962C8B-B14F-4D97-AF65-F5344CB8AC3E}">
-        <p14:creationId xmlns:p14="http://schemas.microsoft.com/office/powerpoint/2010/main" val="757288447"/>
+        <p14:creationId xmlns:p14="http://schemas.microsoft.com/office/powerpoint/2010/main" val="2145423367"/>
       </p:ext>
     </p:extLst>
   </p:cSld>
@@ -11775,7 +11517,7 @@
           <p:cNvPr id="1" name="">
             <a:extLst xmlns:a="http://schemas.openxmlformats.org/drawingml/2006/main">
               <a:ext uri="{FF2B5EF4-FFF2-40B4-BE49-F238E27FC236}">
-                <a16:creationId xmlns:a16="http://schemas.microsoft.com/office/drawing/2014/main" id="{02935A65-5459-4619-8ACF-CCFA6A28AB3A}"/>
+                <a16:creationId xmlns:a16="http://schemas.microsoft.com/office/drawing/2014/main" id="{D2349701-39C7-4CAF-8FC3-F011BADB0CC0}"/>
               </a:ext>
             </a:extLst>
           </p:cNvPr>
@@ -11810,7 +11552,7 @@
           <p:cNvPr id="2" name="">
             <a:extLst xmlns:a="http://schemas.openxmlformats.org/drawingml/2006/main">
               <a:ext uri="{FF2B5EF4-FFF2-40B4-BE49-F238E27FC236}">
-                <a16:creationId xmlns:a16="http://schemas.microsoft.com/office/drawing/2014/main" id="{A34BC47C-1F6D-4F52-A357-8CDF51377877}"/>
+                <a16:creationId xmlns:a16="http://schemas.microsoft.com/office/drawing/2014/main" id="{A1DFB1EA-BC01-4937-9810-1D4617941A07}"/>
               </a:ext>
             </a:extLst>
           </p:cNvPr>
@@ -11845,7 +11587,7 @@
           <p:cNvPr id="3" name="">
             <a:extLst xmlns:a="http://schemas.openxmlformats.org/drawingml/2006/main">
               <a:ext uri="{FF2B5EF4-FFF2-40B4-BE49-F238E27FC236}">
-                <a16:creationId xmlns:a16="http://schemas.microsoft.com/office/drawing/2014/main" id="{7AEB37EF-881F-4C18-A0A7-260D1ABDAD5F}"/>
+                <a16:creationId xmlns:a16="http://schemas.microsoft.com/office/drawing/2014/main" id="{C9CB5076-4514-4642-AA9A-28342F48DA2D}"/>
               </a:ext>
             </a:extLst>
           </p:cNvPr>
@@ -11909,7 +11651,7 @@
           <p:cNvPr id="4" name="">
             <a:extLst xmlns:a="http://schemas.openxmlformats.org/drawingml/2006/main">
               <a:ext uri="{FF2B5EF4-FFF2-40B4-BE49-F238E27FC236}">
-                <a16:creationId xmlns:a16="http://schemas.microsoft.com/office/drawing/2014/main" id="{28631DA9-2096-4E14-A656-EB964C8E7651}"/>
+                <a16:creationId xmlns:a16="http://schemas.microsoft.com/office/drawing/2014/main" id="{F14C20CE-033E-41E5-A3BE-70BC23A9EC30}"/>
               </a:ext>
             </a:extLst>
           </p:cNvPr>
@@ -11973,7 +11715,7 @@
           <p:cNvPr id="5" name="">
             <a:extLst xmlns:a="http://schemas.openxmlformats.org/drawingml/2006/main">
               <a:ext uri="{FF2B5EF4-FFF2-40B4-BE49-F238E27FC236}">
-                <a16:creationId xmlns:a16="http://schemas.microsoft.com/office/drawing/2014/main" id="{7F92B2AD-9406-4F25-8715-B5EDC40C242D}"/>
+                <a16:creationId xmlns:a16="http://schemas.microsoft.com/office/drawing/2014/main" id="{B4A4FC9F-7847-489E-AEB6-6835AB22B9BC}"/>
               </a:ext>
             </a:extLst>
           </p:cNvPr>
@@ -12037,7 +11779,7 @@
           <p:cNvPr id="6" name="">
             <a:extLst xmlns:a="http://schemas.openxmlformats.org/drawingml/2006/main">
               <a:ext uri="{FF2B5EF4-FFF2-40B4-BE49-F238E27FC236}">
-                <a16:creationId xmlns:a16="http://schemas.microsoft.com/office/drawing/2014/main" id="{04117C2F-8BAB-4689-BBCF-60FD03F359D0}"/>
+                <a16:creationId xmlns:a16="http://schemas.microsoft.com/office/drawing/2014/main" id="{80AA2EA3-8719-42E4-8B63-68091AC074B5}"/>
               </a:ext>
             </a:extLst>
           </p:cNvPr>
@@ -12070,7 +11812,7 @@
           <p:cNvPr id="7" name="">
             <a:extLst xmlns:a="http://schemas.openxmlformats.org/drawingml/2006/main">
               <a:ext uri="{FF2B5EF4-FFF2-40B4-BE49-F238E27FC236}">
-                <a16:creationId xmlns:a16="http://schemas.microsoft.com/office/drawing/2014/main" id="{F9C54EBE-993A-4DDD-855D-0DF3B105FE7A}"/>
+                <a16:creationId xmlns:a16="http://schemas.microsoft.com/office/drawing/2014/main" id="{FEC97CD6-9D30-4861-ACB5-89BF535103A3}"/>
               </a:ext>
             </a:extLst>
           </p:cNvPr>
@@ -12103,7 +11845,7 @@
           <p:cNvPr id="8" name="">
             <a:extLst xmlns:a="http://schemas.openxmlformats.org/drawingml/2006/main">
               <a:ext uri="{FF2B5EF4-FFF2-40B4-BE49-F238E27FC236}">
-                <a16:creationId xmlns:a16="http://schemas.microsoft.com/office/drawing/2014/main" id="{6BB41F19-ACEE-4277-892D-88EB7F32F6E3}"/>
+                <a16:creationId xmlns:a16="http://schemas.microsoft.com/office/drawing/2014/main" id="{8E46703B-320E-43B1-B94B-AAB0EB15D130}"/>
               </a:ext>
             </a:extLst>
           </p:cNvPr>
@@ -12167,7 +11909,7 @@
           <p:cNvPr id="9" name="">
             <a:extLst xmlns:a="http://schemas.openxmlformats.org/drawingml/2006/main">
               <a:ext uri="{FF2B5EF4-FFF2-40B4-BE49-F238E27FC236}">
-                <a16:creationId xmlns:a16="http://schemas.microsoft.com/office/drawing/2014/main" id="{C244D071-0B12-4244-B71A-0D6AC0EF1343}"/>
+                <a16:creationId xmlns:a16="http://schemas.microsoft.com/office/drawing/2014/main" id="{368ABFCC-340E-4A8F-82C5-EC165078ECAB}"/>
               </a:ext>
             </a:extLst>
           </p:cNvPr>
@@ -12277,7 +12019,7 @@
           <p:cNvPr id="10" name="">
             <a:extLst xmlns:a="http://schemas.openxmlformats.org/drawingml/2006/main">
               <a:ext uri="{FF2B5EF4-FFF2-40B4-BE49-F238E27FC236}">
-                <a16:creationId xmlns:a16="http://schemas.microsoft.com/office/drawing/2014/main" id="{331DFE71-9D5D-4E98-BC76-27A86C1EB819}"/>
+                <a16:creationId xmlns:a16="http://schemas.microsoft.com/office/drawing/2014/main" id="{B5BF4D0B-65F8-45C1-BEF4-56C9C41858BA}"/>
               </a:ext>
             </a:extLst>
           </p:cNvPr>
@@ -12310,7 +12052,7 @@
           <p:cNvPr id="11" name="">
             <a:extLst xmlns:a="http://schemas.openxmlformats.org/drawingml/2006/main">
               <a:ext uri="{FF2B5EF4-FFF2-40B4-BE49-F238E27FC236}">
-                <a16:creationId xmlns:a16="http://schemas.microsoft.com/office/drawing/2014/main" id="{D4B3ADDA-2D67-4591-99E2-C7FE12690B2C}"/>
+                <a16:creationId xmlns:a16="http://schemas.microsoft.com/office/drawing/2014/main" id="{8B894F6A-7363-4D48-9924-A939E66FE984}"/>
               </a:ext>
             </a:extLst>
           </p:cNvPr>
@@ -12343,7 +12085,7 @@
           <p:cNvPr id="12" name="">
             <a:extLst xmlns:a="http://schemas.openxmlformats.org/drawingml/2006/main">
               <a:ext uri="{FF2B5EF4-FFF2-40B4-BE49-F238E27FC236}">
-                <a16:creationId xmlns:a16="http://schemas.microsoft.com/office/drawing/2014/main" id="{163A93B0-30EA-4467-BF45-52DFBCB9DF6E}"/>
+                <a16:creationId xmlns:a16="http://schemas.microsoft.com/office/drawing/2014/main" id="{6C5A86B8-4793-46BC-BA8A-8B851223D418}"/>
               </a:ext>
             </a:extLst>
           </p:cNvPr>
@@ -12407,7 +12149,7 @@
           <p:cNvPr id="13" name="">
             <a:extLst xmlns:a="http://schemas.openxmlformats.org/drawingml/2006/main">
               <a:ext uri="{FF2B5EF4-FFF2-40B4-BE49-F238E27FC236}">
-                <a16:creationId xmlns:a16="http://schemas.microsoft.com/office/drawing/2014/main" id="{BDA13560-AA96-4E7E-A7AD-746BBE14D477}"/>
+                <a16:creationId xmlns:a16="http://schemas.microsoft.com/office/drawing/2014/main" id="{772C04A2-E659-4575-AA2E-379C0CE564A0}"/>
               </a:ext>
             </a:extLst>
           </p:cNvPr>
@@ -12517,7 +12259,7 @@
           <p:cNvPr id="14" name="">
             <a:extLst xmlns:a="http://schemas.openxmlformats.org/drawingml/2006/main">
               <a:ext uri="{FF2B5EF4-FFF2-40B4-BE49-F238E27FC236}">
-                <a16:creationId xmlns:a16="http://schemas.microsoft.com/office/drawing/2014/main" id="{CD20F471-6736-4465-9D37-8E5A0AEA53AC}"/>
+                <a16:creationId xmlns:a16="http://schemas.microsoft.com/office/drawing/2014/main" id="{FB3E9A49-D707-4D0B-A4A5-7D1CDDF7BAFC}"/>
               </a:ext>
             </a:extLst>
           </p:cNvPr>
@@ -12550,7 +12292,7 @@
           <p:cNvPr id="15" name="">
             <a:extLst xmlns:a="http://schemas.openxmlformats.org/drawingml/2006/main">
               <a:ext uri="{FF2B5EF4-FFF2-40B4-BE49-F238E27FC236}">
-                <a16:creationId xmlns:a16="http://schemas.microsoft.com/office/drawing/2014/main" id="{654D6216-D486-4030-ADBC-C31A3F70CC8A}"/>
+                <a16:creationId xmlns:a16="http://schemas.microsoft.com/office/drawing/2014/main" id="{DB1C5ABF-47E7-4EB0-873C-5F7D398A9CC4}"/>
               </a:ext>
             </a:extLst>
           </p:cNvPr>
@@ -12583,7 +12325,7 @@
           <p:cNvPr id="16" name="">
             <a:extLst xmlns:a="http://schemas.openxmlformats.org/drawingml/2006/main">
               <a:ext uri="{FF2B5EF4-FFF2-40B4-BE49-F238E27FC236}">
-                <a16:creationId xmlns:a16="http://schemas.microsoft.com/office/drawing/2014/main" id="{4837C9C4-256F-4A7D-BA26-2498906C3471}"/>
+                <a16:creationId xmlns:a16="http://schemas.microsoft.com/office/drawing/2014/main" id="{9F68CE2F-5658-47B6-AB6A-3943FED68572}"/>
               </a:ext>
             </a:extLst>
           </p:cNvPr>
@@ -12647,7 +12389,7 @@
           <p:cNvPr id="17" name="">
             <a:extLst xmlns:a="http://schemas.openxmlformats.org/drawingml/2006/main">
               <a:ext uri="{FF2B5EF4-FFF2-40B4-BE49-F238E27FC236}">
-                <a16:creationId xmlns:a16="http://schemas.microsoft.com/office/drawing/2014/main" id="{D8F54011-761A-4993-86C9-514938C935C8}"/>
+                <a16:creationId xmlns:a16="http://schemas.microsoft.com/office/drawing/2014/main" id="{DF56735B-748B-478C-B3E4-7F98D1A87546}"/>
               </a:ext>
             </a:extLst>
           </p:cNvPr>
@@ -12757,7 +12499,7 @@
           <p:cNvPr id="18" name="">
             <a:extLst xmlns:a="http://schemas.openxmlformats.org/drawingml/2006/main">
               <a:ext uri="{FF2B5EF4-FFF2-40B4-BE49-F238E27FC236}">
-                <a16:creationId xmlns:a16="http://schemas.microsoft.com/office/drawing/2014/main" id="{BBBB72EF-C3BF-4DC4-94F1-2E99992C1FF6}"/>
+                <a16:creationId xmlns:a16="http://schemas.microsoft.com/office/drawing/2014/main" id="{D8B3B750-1812-4DC0-B770-7CCF564B98EB}"/>
               </a:ext>
             </a:extLst>
           </p:cNvPr>
@@ -12790,7 +12532,7 @@
           <p:cNvPr id="19" name="">
             <a:extLst xmlns:a="http://schemas.openxmlformats.org/drawingml/2006/main">
               <a:ext uri="{FF2B5EF4-FFF2-40B4-BE49-F238E27FC236}">
-                <a16:creationId xmlns:a16="http://schemas.microsoft.com/office/drawing/2014/main" id="{25A7A856-0FF5-4A1B-A2CA-D50A3D9C4ABA}"/>
+                <a16:creationId xmlns:a16="http://schemas.microsoft.com/office/drawing/2014/main" id="{C2CA6E21-54C7-48ED-8889-46F3DD413754}"/>
               </a:ext>
             </a:extLst>
           </p:cNvPr>
@@ -12854,7 +12596,7 @@
           <p:cNvPr id="20" name="">
             <a:extLst xmlns:a="http://schemas.openxmlformats.org/drawingml/2006/main">
               <a:ext uri="{FF2B5EF4-FFF2-40B4-BE49-F238E27FC236}">
-                <a16:creationId xmlns:a16="http://schemas.microsoft.com/office/drawing/2014/main" id="{1A4315AC-979E-4F55-82A9-F30424951ED7}"/>
+                <a16:creationId xmlns:a16="http://schemas.microsoft.com/office/drawing/2014/main" id="{CCD73313-AA49-442A-AB1A-37F4F317CAE1}"/>
               </a:ext>
             </a:extLst>
           </p:cNvPr>
@@ -12889,7 +12631,7 @@
           <p:cNvPr id="21" name="">
             <a:extLst xmlns:a="http://schemas.openxmlformats.org/drawingml/2006/main">
               <a:ext uri="{FF2B5EF4-FFF2-40B4-BE49-F238E27FC236}">
-                <a16:creationId xmlns:a16="http://schemas.microsoft.com/office/drawing/2014/main" id="{4BC929CB-90F5-4003-87E1-DA2EAE29960C}"/>
+                <a16:creationId xmlns:a16="http://schemas.microsoft.com/office/drawing/2014/main" id="{888BD148-BE6F-4B04-861B-C84D54EFAE95}"/>
               </a:ext>
             </a:extLst>
           </p:cNvPr>
@@ -12953,7 +12695,7 @@
           <p:cNvPr id="22" name="">
             <a:extLst xmlns:a="http://schemas.openxmlformats.org/drawingml/2006/main">
               <a:ext uri="{FF2B5EF4-FFF2-40B4-BE49-F238E27FC236}">
-                <a16:creationId xmlns:a16="http://schemas.microsoft.com/office/drawing/2014/main" id="{74875229-0008-44B7-B717-478CC451CCDA}"/>
+                <a16:creationId xmlns:a16="http://schemas.microsoft.com/office/drawing/2014/main" id="{0251DF7D-537F-4C82-8FB8-5AD17BD91803}"/>
               </a:ext>
             </a:extLst>
           </p:cNvPr>
@@ -12988,7 +12730,7 @@
           <p:cNvPr id="23" name="">
             <a:extLst xmlns:a="http://schemas.openxmlformats.org/drawingml/2006/main">
               <a:ext uri="{FF2B5EF4-FFF2-40B4-BE49-F238E27FC236}">
-                <a16:creationId xmlns:a16="http://schemas.microsoft.com/office/drawing/2014/main" id="{7885DFD3-F31B-47EA-8981-DD5066BE2538}"/>
+                <a16:creationId xmlns:a16="http://schemas.microsoft.com/office/drawing/2014/main" id="{AC409DDC-6755-4069-B83E-D8BB93668D1B}"/>
               </a:ext>
             </a:extLst>
           </p:cNvPr>
@@ -13052,7 +12794,7 @@
           <p:cNvPr id="24" name="">
             <a:extLst xmlns:a="http://schemas.openxmlformats.org/drawingml/2006/main">
               <a:ext uri="{FF2B5EF4-FFF2-40B4-BE49-F238E27FC236}">
-                <a16:creationId xmlns:a16="http://schemas.microsoft.com/office/drawing/2014/main" id="{0584384F-C621-4550-AB9F-DBB92885A1EC}"/>
+                <a16:creationId xmlns:a16="http://schemas.microsoft.com/office/drawing/2014/main" id="{8F825086-E0B2-4ECE-93EF-57C8DF210FD9}"/>
               </a:ext>
             </a:extLst>
           </p:cNvPr>
@@ -13087,7 +12829,7 @@
           <p:cNvPr id="25" name="">
             <a:extLst xmlns:a="http://schemas.openxmlformats.org/drawingml/2006/main">
               <a:ext uri="{FF2B5EF4-FFF2-40B4-BE49-F238E27FC236}">
-                <a16:creationId xmlns:a16="http://schemas.microsoft.com/office/drawing/2014/main" id="{46E33B27-C57F-49B6-9759-52D74B5E4A38}"/>
+                <a16:creationId xmlns:a16="http://schemas.microsoft.com/office/drawing/2014/main" id="{4EA2C88D-FB53-4525-A98A-2EC947BA1722}"/>
               </a:ext>
             </a:extLst>
           </p:cNvPr>
@@ -13151,7 +12893,7 @@
           <p:cNvPr id="26" name="">
             <a:extLst xmlns:a="http://schemas.openxmlformats.org/drawingml/2006/main">
               <a:ext uri="{FF2B5EF4-FFF2-40B4-BE49-F238E27FC236}">
-                <a16:creationId xmlns:a16="http://schemas.microsoft.com/office/drawing/2014/main" id="{90307A64-96DB-41AE-8425-314E1BA08BE1}"/>
+                <a16:creationId xmlns:a16="http://schemas.microsoft.com/office/drawing/2014/main" id="{1CD4FCC5-DBD9-4383-8E53-53F3F0AA6333}"/>
               </a:ext>
             </a:extLst>
           </p:cNvPr>
@@ -13186,7 +12928,7 @@
           <p:cNvPr id="27" name="">
             <a:extLst xmlns:a="http://schemas.openxmlformats.org/drawingml/2006/main">
               <a:ext uri="{FF2B5EF4-FFF2-40B4-BE49-F238E27FC236}">
-                <a16:creationId xmlns:a16="http://schemas.microsoft.com/office/drawing/2014/main" id="{1F7CAB13-605A-4D8D-94A6-7096B1A41779}"/>
+                <a16:creationId xmlns:a16="http://schemas.microsoft.com/office/drawing/2014/main" id="{77E912F6-B843-45FB-A7FD-BAFCF9935AFD}"/>
               </a:ext>
             </a:extLst>
           </p:cNvPr>
@@ -13250,7 +12992,7 @@
           <p:cNvPr id="28" name="">
             <a:extLst xmlns:a="http://schemas.openxmlformats.org/drawingml/2006/main">
               <a:ext uri="{FF2B5EF4-FFF2-40B4-BE49-F238E27FC236}">
-                <a16:creationId xmlns:a16="http://schemas.microsoft.com/office/drawing/2014/main" id="{6D57FC04-5C36-4310-8351-1B2C99B13814}"/>
+                <a16:creationId xmlns:a16="http://schemas.microsoft.com/office/drawing/2014/main" id="{2B759BE0-D340-4882-A987-561EBA05345C}"/>
               </a:ext>
             </a:extLst>
           </p:cNvPr>
@@ -13312,7 +13054,7 @@
     </p:spTree>
     <p:extLst>
       <p:ext uri="{BB962C8B-B14F-4D97-AF65-F5344CB8AC3E}">
-        <p14:creationId xmlns:p14="http://schemas.microsoft.com/office/powerpoint/2010/main" val="1268049403"/>
+        <p14:creationId xmlns:p14="http://schemas.microsoft.com/office/powerpoint/2010/main" val="1085907391"/>
       </p:ext>
     </p:extLst>
   </p:cSld>
@@ -13336,7 +13078,7 @@
           <p:cNvPr id="1" name="">
             <a:extLst xmlns:a="http://schemas.openxmlformats.org/drawingml/2006/main">
               <a:ext uri="{FF2B5EF4-FFF2-40B4-BE49-F238E27FC236}">
-                <a16:creationId xmlns:a16="http://schemas.microsoft.com/office/drawing/2014/main" id="{62CC259D-786A-4CEA-B167-68BDCB7810E6}"/>
+                <a16:creationId xmlns:a16="http://schemas.microsoft.com/office/drawing/2014/main" id="{6432975E-AFC1-4ECD-B9FA-E00E745BDF98}"/>
               </a:ext>
             </a:extLst>
           </p:cNvPr>
@@ -13371,7 +13113,7 @@
           <p:cNvPr id="2" name="">
             <a:extLst xmlns:a="http://schemas.openxmlformats.org/drawingml/2006/main">
               <a:ext uri="{FF2B5EF4-FFF2-40B4-BE49-F238E27FC236}">
-                <a16:creationId xmlns:a16="http://schemas.microsoft.com/office/drawing/2014/main" id="{B5FE7047-C434-4DC2-8F3F-38EC7A31F8E8}"/>
+                <a16:creationId xmlns:a16="http://schemas.microsoft.com/office/drawing/2014/main" id="{4C9F940C-6FBC-4B6E-8830-DFFAFED7224C}"/>
               </a:ext>
             </a:extLst>
           </p:cNvPr>
@@ -13406,7 +13148,7 @@
           <p:cNvPr id="3" name="">
             <a:extLst xmlns:a="http://schemas.openxmlformats.org/drawingml/2006/main">
               <a:ext uri="{FF2B5EF4-FFF2-40B4-BE49-F238E27FC236}">
-                <a16:creationId xmlns:a16="http://schemas.microsoft.com/office/drawing/2014/main" id="{506C29C4-CB17-45CC-85A4-558F7640BE3A}"/>
+                <a16:creationId xmlns:a16="http://schemas.microsoft.com/office/drawing/2014/main" id="{0B5A9ACA-616F-4AA7-9C87-3FB9B43356DF}"/>
               </a:ext>
             </a:extLst>
           </p:cNvPr>
@@ -13470,7 +13212,7 @@
           <p:cNvPr id="4" name="">
             <a:extLst xmlns:a="http://schemas.openxmlformats.org/drawingml/2006/main">
               <a:ext uri="{FF2B5EF4-FFF2-40B4-BE49-F238E27FC236}">
-                <a16:creationId xmlns:a16="http://schemas.microsoft.com/office/drawing/2014/main" id="{EF2450CB-82C0-4AF2-AFB9-C1F8D33A23C2}"/>
+                <a16:creationId xmlns:a16="http://schemas.microsoft.com/office/drawing/2014/main" id="{3E421238-2833-4E3E-A212-1F6FFC0ED0E6}"/>
               </a:ext>
             </a:extLst>
           </p:cNvPr>
@@ -13534,7 +13276,7 @@
           <p:cNvPr id="5" name="">
             <a:extLst xmlns:a="http://schemas.openxmlformats.org/drawingml/2006/main">
               <a:ext uri="{FF2B5EF4-FFF2-40B4-BE49-F238E27FC236}">
-                <a16:creationId xmlns:a16="http://schemas.microsoft.com/office/drawing/2014/main" id="{39DAA70F-CFEC-465A-8642-1642C772A678}"/>
+                <a16:creationId xmlns:a16="http://schemas.microsoft.com/office/drawing/2014/main" id="{E3ECA290-B158-4C2D-829D-0BC12B8A74ED}"/>
               </a:ext>
             </a:extLst>
           </p:cNvPr>
@@ -13598,7 +13340,7 @@
           <p:cNvPr id="6" name="">
             <a:extLst xmlns:a="http://schemas.openxmlformats.org/drawingml/2006/main">
               <a:ext uri="{FF2B5EF4-FFF2-40B4-BE49-F238E27FC236}">
-                <a16:creationId xmlns:a16="http://schemas.microsoft.com/office/drawing/2014/main" id="{DDC387BE-3E50-44DB-8E3C-32352294169C}"/>
+                <a16:creationId xmlns:a16="http://schemas.microsoft.com/office/drawing/2014/main" id="{792CDFAA-DC41-4767-9229-AD04A33F8528}"/>
               </a:ext>
             </a:extLst>
           </p:cNvPr>
@@ -13631,7 +13373,7 @@
           <p:cNvPr id="7" name="">
             <a:extLst xmlns:a="http://schemas.openxmlformats.org/drawingml/2006/main">
               <a:ext uri="{FF2B5EF4-FFF2-40B4-BE49-F238E27FC236}">
-                <a16:creationId xmlns:a16="http://schemas.microsoft.com/office/drawing/2014/main" id="{C57130BA-99F1-4958-A3A8-E0E991CAE140}"/>
+                <a16:creationId xmlns:a16="http://schemas.microsoft.com/office/drawing/2014/main" id="{43932FF1-D842-4D24-9EE7-77A3B8DED212}"/>
               </a:ext>
             </a:extLst>
           </p:cNvPr>
@@ -13695,7 +13437,7 @@
           <p:cNvPr id="8" name="">
             <a:extLst xmlns:a="http://schemas.openxmlformats.org/drawingml/2006/main">
               <a:ext uri="{FF2B5EF4-FFF2-40B4-BE49-F238E27FC236}">
-                <a16:creationId xmlns:a16="http://schemas.microsoft.com/office/drawing/2014/main" id="{ABDA6F34-59E3-46D6-97ED-CD52B0E67CD7}"/>
+                <a16:creationId xmlns:a16="http://schemas.microsoft.com/office/drawing/2014/main" id="{1066A1B3-7D02-4F5F-A1C3-4C3E4943E2A4}"/>
               </a:ext>
             </a:extLst>
           </p:cNvPr>
@@ -13728,7 +13470,7 @@
           <p:cNvPr id="9" name="">
             <a:extLst xmlns:a="http://schemas.openxmlformats.org/drawingml/2006/main">
               <a:ext uri="{FF2B5EF4-FFF2-40B4-BE49-F238E27FC236}">
-                <a16:creationId xmlns:a16="http://schemas.microsoft.com/office/drawing/2014/main" id="{E2CB61DB-3CB7-45AE-93AC-61573381F1A5}"/>
+                <a16:creationId xmlns:a16="http://schemas.microsoft.com/office/drawing/2014/main" id="{EF7044F6-CA66-4342-B4CE-C321EC68597D}"/>
               </a:ext>
             </a:extLst>
           </p:cNvPr>
@@ -13792,7 +13534,7 @@
           <p:cNvPr id="10" name="">
             <a:extLst xmlns:a="http://schemas.openxmlformats.org/drawingml/2006/main">
               <a:ext uri="{FF2B5EF4-FFF2-40B4-BE49-F238E27FC236}">
-                <a16:creationId xmlns:a16="http://schemas.microsoft.com/office/drawing/2014/main" id="{B5606EBC-F862-4AE8-9C4C-1293F35FC1A7}"/>
+                <a16:creationId xmlns:a16="http://schemas.microsoft.com/office/drawing/2014/main" id="{479FD259-0987-4D55-AA74-D79C8D4544ED}"/>
               </a:ext>
             </a:extLst>
           </p:cNvPr>
@@ -13856,7 +13598,7 @@
           <p:cNvPr id="11" name="">
             <a:extLst xmlns:a="http://schemas.openxmlformats.org/drawingml/2006/main">
               <a:ext uri="{FF2B5EF4-FFF2-40B4-BE49-F238E27FC236}">
-                <a16:creationId xmlns:a16="http://schemas.microsoft.com/office/drawing/2014/main" id="{22392E1D-B00B-4B74-8D0F-4E74D64F038E}"/>
+                <a16:creationId xmlns:a16="http://schemas.microsoft.com/office/drawing/2014/main" id="{D995E7F2-BA1A-45B4-BE42-46F4F3F551F4}"/>
               </a:ext>
             </a:extLst>
           </p:cNvPr>
@@ -13889,7 +13631,7 @@
           <p:cNvPr id="12" name="">
             <a:extLst xmlns:a="http://schemas.openxmlformats.org/drawingml/2006/main">
               <a:ext uri="{FF2B5EF4-FFF2-40B4-BE49-F238E27FC236}">
-                <a16:creationId xmlns:a16="http://schemas.microsoft.com/office/drawing/2014/main" id="{FBB4193A-A6C9-4572-8EB6-C37F9FD95F67}"/>
+                <a16:creationId xmlns:a16="http://schemas.microsoft.com/office/drawing/2014/main" id="{5F6F51CE-4ECB-4245-B702-1EA8C53FFC30}"/>
               </a:ext>
             </a:extLst>
           </p:cNvPr>
@@ -13953,7 +13695,7 @@
           <p:cNvPr id="13" name="">
             <a:extLst xmlns:a="http://schemas.openxmlformats.org/drawingml/2006/main">
               <a:ext uri="{FF2B5EF4-FFF2-40B4-BE49-F238E27FC236}">
-                <a16:creationId xmlns:a16="http://schemas.microsoft.com/office/drawing/2014/main" id="{4B91608B-BBF7-4150-B81B-40107B42EB84}"/>
+                <a16:creationId xmlns:a16="http://schemas.microsoft.com/office/drawing/2014/main" id="{96035E1D-984A-4501-8794-668EDB77EB5A}"/>
               </a:ext>
             </a:extLst>
           </p:cNvPr>
@@ -14017,7 +13759,7 @@
           <p:cNvPr id="14" name="">
             <a:extLst xmlns:a="http://schemas.openxmlformats.org/drawingml/2006/main">
               <a:ext uri="{FF2B5EF4-FFF2-40B4-BE49-F238E27FC236}">
-                <a16:creationId xmlns:a16="http://schemas.microsoft.com/office/drawing/2014/main" id="{1CB15B13-C76B-4972-B6A5-1F580A80733D}"/>
+                <a16:creationId xmlns:a16="http://schemas.microsoft.com/office/drawing/2014/main" id="{FD0EFCB1-3EBF-45A2-A181-941C495FFE29}"/>
               </a:ext>
             </a:extLst>
           </p:cNvPr>
@@ -14050,7 +13792,7 @@
           <p:cNvPr id="15" name="">
             <a:extLst xmlns:a="http://schemas.openxmlformats.org/drawingml/2006/main">
               <a:ext uri="{FF2B5EF4-FFF2-40B4-BE49-F238E27FC236}">
-                <a16:creationId xmlns:a16="http://schemas.microsoft.com/office/drawing/2014/main" id="{029F68C7-CBFF-4C7D-A2FE-98CAF1124CD5}"/>
+                <a16:creationId xmlns:a16="http://schemas.microsoft.com/office/drawing/2014/main" id="{F0B547D1-E2A2-4EBE-BDB6-B3BE0A9347E1}"/>
               </a:ext>
             </a:extLst>
           </p:cNvPr>
@@ -14114,7 +13856,7 @@
           <p:cNvPr id="16" name="">
             <a:extLst xmlns:a="http://schemas.openxmlformats.org/drawingml/2006/main">
               <a:ext uri="{FF2B5EF4-FFF2-40B4-BE49-F238E27FC236}">
-                <a16:creationId xmlns:a16="http://schemas.microsoft.com/office/drawing/2014/main" id="{9DFAAE6E-40AB-4967-AA8D-E54195C6CA7C}"/>
+                <a16:creationId xmlns:a16="http://schemas.microsoft.com/office/drawing/2014/main" id="{FA991BF9-C521-4F84-9EA7-8CE2C084D917}"/>
               </a:ext>
             </a:extLst>
           </p:cNvPr>
@@ -14178,7 +13920,7 @@
           <p:cNvPr id="17" name="">
             <a:extLst xmlns:a="http://schemas.openxmlformats.org/drawingml/2006/main">
               <a:ext uri="{FF2B5EF4-FFF2-40B4-BE49-F238E27FC236}">
-                <a16:creationId xmlns:a16="http://schemas.microsoft.com/office/drawing/2014/main" id="{718D6525-388B-4970-9DCB-8040E5C0A840}"/>
+                <a16:creationId xmlns:a16="http://schemas.microsoft.com/office/drawing/2014/main" id="{9AB6CBE6-D4D2-4BA1-B4AC-965E118F208A}"/>
               </a:ext>
             </a:extLst>
           </p:cNvPr>
@@ -14211,7 +13953,7 @@
           <p:cNvPr id="18" name="">
             <a:extLst xmlns:a="http://schemas.openxmlformats.org/drawingml/2006/main">
               <a:ext uri="{FF2B5EF4-FFF2-40B4-BE49-F238E27FC236}">
-                <a16:creationId xmlns:a16="http://schemas.microsoft.com/office/drawing/2014/main" id="{7E186859-133D-47D3-9661-90999DFF03DC}"/>
+                <a16:creationId xmlns:a16="http://schemas.microsoft.com/office/drawing/2014/main" id="{6A8D3C41-01EA-4656-876E-8046CC85CDB2}"/>
               </a:ext>
             </a:extLst>
           </p:cNvPr>
@@ -14275,7 +14017,7 @@
           <p:cNvPr id="19" name="">
             <a:extLst xmlns:a="http://schemas.openxmlformats.org/drawingml/2006/main">
               <a:ext uri="{FF2B5EF4-FFF2-40B4-BE49-F238E27FC236}">
-                <a16:creationId xmlns:a16="http://schemas.microsoft.com/office/drawing/2014/main" id="{31436874-406C-4DED-A6FB-CCCE83DEB72C}"/>
+                <a16:creationId xmlns:a16="http://schemas.microsoft.com/office/drawing/2014/main" id="{65424CF7-DF46-4244-A43F-3C5DE974AA35}"/>
               </a:ext>
             </a:extLst>
           </p:cNvPr>
@@ -14339,7 +14081,7 @@
           <p:cNvPr id="20" name="">
             <a:extLst xmlns:a="http://schemas.openxmlformats.org/drawingml/2006/main">
               <a:ext uri="{FF2B5EF4-FFF2-40B4-BE49-F238E27FC236}">
-                <a16:creationId xmlns:a16="http://schemas.microsoft.com/office/drawing/2014/main" id="{3AAA6BBF-BA0C-41B3-87E2-D72849546EB2}"/>
+                <a16:creationId xmlns:a16="http://schemas.microsoft.com/office/drawing/2014/main" id="{C4AA2843-671C-4F4F-BC5C-30FF28D37932}"/>
               </a:ext>
             </a:extLst>
           </p:cNvPr>
@@ -14372,7 +14114,7 @@
           <p:cNvPr id="21" name="">
             <a:extLst xmlns:a="http://schemas.openxmlformats.org/drawingml/2006/main">
               <a:ext uri="{FF2B5EF4-FFF2-40B4-BE49-F238E27FC236}">
-                <a16:creationId xmlns:a16="http://schemas.microsoft.com/office/drawing/2014/main" id="{61AE2550-D5EF-4B4F-95A6-4F22BC12775E}"/>
+                <a16:creationId xmlns:a16="http://schemas.microsoft.com/office/drawing/2014/main" id="{23A6CABE-397E-4DD0-BED0-F737CC082605}"/>
               </a:ext>
             </a:extLst>
           </p:cNvPr>
@@ -14436,7 +14178,7 @@
           <p:cNvPr id="22" name="">
             <a:extLst xmlns:a="http://schemas.openxmlformats.org/drawingml/2006/main">
               <a:ext uri="{FF2B5EF4-FFF2-40B4-BE49-F238E27FC236}">
-                <a16:creationId xmlns:a16="http://schemas.microsoft.com/office/drawing/2014/main" id="{2497B38E-E0DB-4191-AF42-09519C203B10}"/>
+                <a16:creationId xmlns:a16="http://schemas.microsoft.com/office/drawing/2014/main" id="{280CE06E-3114-4EC4-A3E6-7BEE0626BDEC}"/>
               </a:ext>
             </a:extLst>
           </p:cNvPr>
@@ -14500,7 +14242,7 @@
           <p:cNvPr id="23" name="">
             <a:extLst xmlns:a="http://schemas.openxmlformats.org/drawingml/2006/main">
               <a:ext uri="{FF2B5EF4-FFF2-40B4-BE49-F238E27FC236}">
-                <a16:creationId xmlns:a16="http://schemas.microsoft.com/office/drawing/2014/main" id="{B9B2CDEB-BF5E-4958-881E-B7E08849222A}"/>
+                <a16:creationId xmlns:a16="http://schemas.microsoft.com/office/drawing/2014/main" id="{D3FD4B32-4E71-4FA8-B871-17376E7BDB7D}"/>
               </a:ext>
             </a:extLst>
           </p:cNvPr>
@@ -14535,7 +14277,7 @@
           <p:cNvPr id="24" name="">
             <a:extLst xmlns:a="http://schemas.openxmlformats.org/drawingml/2006/main">
               <a:ext uri="{FF2B5EF4-FFF2-40B4-BE49-F238E27FC236}">
-                <a16:creationId xmlns:a16="http://schemas.microsoft.com/office/drawing/2014/main" id="{1D08DCCF-C88D-4814-95BE-DDDC380FBAE9}"/>
+                <a16:creationId xmlns:a16="http://schemas.microsoft.com/office/drawing/2014/main" id="{8DF2DBEF-697F-450A-BCEC-CC304611B9B6}"/>
               </a:ext>
             </a:extLst>
           </p:cNvPr>
@@ -14570,7 +14312,7 @@
           <p:cNvPr id="25" name="">
             <a:extLst xmlns:a="http://schemas.openxmlformats.org/drawingml/2006/main">
               <a:ext uri="{FF2B5EF4-FFF2-40B4-BE49-F238E27FC236}">
-                <a16:creationId xmlns:a16="http://schemas.microsoft.com/office/drawing/2014/main" id="{817C28E1-E4B5-44BC-BA7C-4AC1FFFFE309}"/>
+                <a16:creationId xmlns:a16="http://schemas.microsoft.com/office/drawing/2014/main" id="{8C7A9306-2A96-4467-9E96-1C50DDF57D13}"/>
               </a:ext>
             </a:extLst>
           </p:cNvPr>
@@ -14605,7 +14347,7 @@
           <p:cNvPr id="26" name="">
             <a:extLst xmlns:a="http://schemas.openxmlformats.org/drawingml/2006/main">
               <a:ext uri="{FF2B5EF4-FFF2-40B4-BE49-F238E27FC236}">
-                <a16:creationId xmlns:a16="http://schemas.microsoft.com/office/drawing/2014/main" id="{8AEDCF9B-0496-4D14-91E8-992E4A3E27F7}"/>
+                <a16:creationId xmlns:a16="http://schemas.microsoft.com/office/drawing/2014/main" id="{82EC9156-EB60-45DA-B11E-6178BEB804AA}"/>
               </a:ext>
             </a:extLst>
           </p:cNvPr>
@@ -14640,7 +14382,7 @@
           <p:cNvPr id="27" name="">
             <a:extLst xmlns:a="http://schemas.openxmlformats.org/drawingml/2006/main">
               <a:ext uri="{FF2B5EF4-FFF2-40B4-BE49-F238E27FC236}">
-                <a16:creationId xmlns:a16="http://schemas.microsoft.com/office/drawing/2014/main" id="{95A37675-50D4-4E86-A720-128C5D5C7C9B}"/>
+                <a16:creationId xmlns:a16="http://schemas.microsoft.com/office/drawing/2014/main" id="{D1BBDB97-0044-487D-BB78-A77DD6E0DAA8}"/>
               </a:ext>
             </a:extLst>
           </p:cNvPr>
@@ -14675,7 +14417,7 @@
           <p:cNvPr id="28" name="">
             <a:extLst xmlns:a="http://schemas.openxmlformats.org/drawingml/2006/main">
               <a:ext uri="{FF2B5EF4-FFF2-40B4-BE49-F238E27FC236}">
-                <a16:creationId xmlns:a16="http://schemas.microsoft.com/office/drawing/2014/main" id="{49CF3A3F-84D8-4286-AB05-BC81D85C92D7}"/>
+                <a16:creationId xmlns:a16="http://schemas.microsoft.com/office/drawing/2014/main" id="{A576073F-7837-4025-9905-CB9057682FCF}"/>
               </a:ext>
             </a:extLst>
           </p:cNvPr>
@@ -14708,7 +14450,7 @@
           <p:cNvPr id="29" name="">
             <a:extLst xmlns:a="http://schemas.openxmlformats.org/drawingml/2006/main">
               <a:ext uri="{FF2B5EF4-FFF2-40B4-BE49-F238E27FC236}">
-                <a16:creationId xmlns:a16="http://schemas.microsoft.com/office/drawing/2014/main" id="{CFC10990-C1AE-4818-9085-E7B122152B96}"/>
+                <a16:creationId xmlns:a16="http://schemas.microsoft.com/office/drawing/2014/main" id="{9BA275C8-62AE-46C2-BD3D-E6A5382BB8C7}"/>
               </a:ext>
             </a:extLst>
           </p:cNvPr>
@@ -14772,7 +14514,7 @@
           <p:cNvPr id="30" name="">
             <a:extLst xmlns:a="http://schemas.openxmlformats.org/drawingml/2006/main">
               <a:ext uri="{FF2B5EF4-FFF2-40B4-BE49-F238E27FC236}">
-                <a16:creationId xmlns:a16="http://schemas.microsoft.com/office/drawing/2014/main" id="{ACF864B8-6A7D-47D5-9043-1E815DD0F618}"/>
+                <a16:creationId xmlns:a16="http://schemas.microsoft.com/office/drawing/2014/main" id="{45E9E7EE-94D5-42B1-AAE9-44AA83201E4A}"/>
               </a:ext>
             </a:extLst>
           </p:cNvPr>
@@ -14836,7 +14578,7 @@
           <p:cNvPr id="31" name="">
             <a:extLst xmlns:a="http://schemas.openxmlformats.org/drawingml/2006/main">
               <a:ext uri="{FF2B5EF4-FFF2-40B4-BE49-F238E27FC236}">
-                <a16:creationId xmlns:a16="http://schemas.microsoft.com/office/drawing/2014/main" id="{11300793-98F8-460F-8FBC-B63BC0D776B7}"/>
+                <a16:creationId xmlns:a16="http://schemas.microsoft.com/office/drawing/2014/main" id="{94575BD5-7CDE-43DD-92F3-4BF79D440810}"/>
               </a:ext>
             </a:extLst>
           </p:cNvPr>
@@ -14871,7 +14613,7 @@
           <p:cNvPr id="32" name="">
             <a:extLst xmlns:a="http://schemas.openxmlformats.org/drawingml/2006/main">
               <a:ext uri="{FF2B5EF4-FFF2-40B4-BE49-F238E27FC236}">
-                <a16:creationId xmlns:a16="http://schemas.microsoft.com/office/drawing/2014/main" id="{1B568958-856B-4F8A-B397-2F9ACFC3A8C4}"/>
+                <a16:creationId xmlns:a16="http://schemas.microsoft.com/office/drawing/2014/main" id="{2E723241-6A4C-48F3-AFD0-2929F5CCDC4C}"/>
               </a:ext>
             </a:extLst>
           </p:cNvPr>
@@ -14935,7 +14677,7 @@
           <p:cNvPr id="33" name="">
             <a:extLst xmlns:a="http://schemas.openxmlformats.org/drawingml/2006/main">
               <a:ext uri="{FF2B5EF4-FFF2-40B4-BE49-F238E27FC236}">
-                <a16:creationId xmlns:a16="http://schemas.microsoft.com/office/drawing/2014/main" id="{2F988DD7-1D0A-42B6-AB02-4237076DDB93}"/>
+                <a16:creationId xmlns:a16="http://schemas.microsoft.com/office/drawing/2014/main" id="{82A414B2-294B-4905-A198-9C6495D5EA3A}"/>
               </a:ext>
             </a:extLst>
           </p:cNvPr>
@@ -14997,7 +14739,7 @@
     </p:spTree>
     <p:extLst>
       <p:ext uri="{BB962C8B-B14F-4D97-AF65-F5344CB8AC3E}">
-        <p14:creationId xmlns:p14="http://schemas.microsoft.com/office/powerpoint/2010/main" val="1844704277"/>
+        <p14:creationId xmlns:p14="http://schemas.microsoft.com/office/powerpoint/2010/main" val="1117809915"/>
       </p:ext>
     </p:extLst>
   </p:cSld>
@@ -15021,7 +14763,7 @@
           <p:cNvPr id="1" name="">
             <a:extLst xmlns:a="http://schemas.openxmlformats.org/drawingml/2006/main">
               <a:ext uri="{FF2B5EF4-FFF2-40B4-BE49-F238E27FC236}">
-                <a16:creationId xmlns:a16="http://schemas.microsoft.com/office/drawing/2014/main" id="{356A67DA-990A-43AB-ABDB-F4EF744C6CCA}"/>
+                <a16:creationId xmlns:a16="http://schemas.microsoft.com/office/drawing/2014/main" id="{7C1EC17C-1211-4FD4-8FAF-AC2B9602EF0A}"/>
               </a:ext>
             </a:extLst>
           </p:cNvPr>
@@ -15056,7 +14798,7 @@
           <p:cNvPr id="2" name="">
             <a:extLst xmlns:a="http://schemas.openxmlformats.org/drawingml/2006/main">
               <a:ext uri="{FF2B5EF4-FFF2-40B4-BE49-F238E27FC236}">
-                <a16:creationId xmlns:a16="http://schemas.microsoft.com/office/drawing/2014/main" id="{DECCBF45-F654-4A41-847D-CCAE52580087}"/>
+                <a16:creationId xmlns:a16="http://schemas.microsoft.com/office/drawing/2014/main" id="{72DDFF7A-1006-487F-B1D1-88DC614953A6}"/>
               </a:ext>
             </a:extLst>
           </p:cNvPr>
@@ -15091,7 +14833,7 @@
           <p:cNvPr id="3" name="">
             <a:extLst xmlns:a="http://schemas.openxmlformats.org/drawingml/2006/main">
               <a:ext uri="{FF2B5EF4-FFF2-40B4-BE49-F238E27FC236}">
-                <a16:creationId xmlns:a16="http://schemas.microsoft.com/office/drawing/2014/main" id="{0C8A818F-01DE-49BF-86D9-3753AC41DA36}"/>
+                <a16:creationId xmlns:a16="http://schemas.microsoft.com/office/drawing/2014/main" id="{FA0805E3-7B8D-4F90-BA9A-0F27CFB9A8E4}"/>
               </a:ext>
             </a:extLst>
           </p:cNvPr>
@@ -15155,7 +14897,7 @@
           <p:cNvPr id="4" name="">
             <a:extLst xmlns:a="http://schemas.openxmlformats.org/drawingml/2006/main">
               <a:ext uri="{FF2B5EF4-FFF2-40B4-BE49-F238E27FC236}">
-                <a16:creationId xmlns:a16="http://schemas.microsoft.com/office/drawing/2014/main" id="{404266AE-25B0-4F33-BD36-DD98ACBEAC38}"/>
+                <a16:creationId xmlns:a16="http://schemas.microsoft.com/office/drawing/2014/main" id="{850E4F4E-7252-46F4-A373-1F0E6A247039}"/>
               </a:ext>
             </a:extLst>
           </p:cNvPr>
@@ -15219,7 +14961,7 @@
           <p:cNvPr id="5" name="">
             <a:extLst xmlns:a="http://schemas.openxmlformats.org/drawingml/2006/main">
               <a:ext uri="{FF2B5EF4-FFF2-40B4-BE49-F238E27FC236}">
-                <a16:creationId xmlns:a16="http://schemas.microsoft.com/office/drawing/2014/main" id="{C4D5C6E5-A198-4C80-92AF-992CF6998FF9}"/>
+                <a16:creationId xmlns:a16="http://schemas.microsoft.com/office/drawing/2014/main" id="{202353B6-51DC-454F-BD7A-F42C2E59DF67}"/>
               </a:ext>
             </a:extLst>
           </p:cNvPr>
@@ -15283,7 +15025,7 @@
           <p:cNvPr id="6" name="">
             <a:extLst xmlns:a="http://schemas.openxmlformats.org/drawingml/2006/main">
               <a:ext uri="{FF2B5EF4-FFF2-40B4-BE49-F238E27FC236}">
-                <a16:creationId xmlns:a16="http://schemas.microsoft.com/office/drawing/2014/main" id="{A1E83DBC-9FAE-404F-8E96-F533E3178F63}"/>
+                <a16:creationId xmlns:a16="http://schemas.microsoft.com/office/drawing/2014/main" id="{D10C91E3-544B-4E69-A82B-D505A138A3E8}"/>
               </a:ext>
             </a:extLst>
           </p:cNvPr>
@@ -15316,7 +15058,7 @@
           <p:cNvPr id="7" name="">
             <a:extLst xmlns:a="http://schemas.openxmlformats.org/drawingml/2006/main">
               <a:ext uri="{FF2B5EF4-FFF2-40B4-BE49-F238E27FC236}">
-                <a16:creationId xmlns:a16="http://schemas.microsoft.com/office/drawing/2014/main" id="{AAC1CD15-0F52-4669-9FCF-D7A4F2685C5D}"/>
+                <a16:creationId xmlns:a16="http://schemas.microsoft.com/office/drawing/2014/main" id="{167454B4-8ADA-488E-A0DB-E8648118DDF6}"/>
               </a:ext>
             </a:extLst>
           </p:cNvPr>
@@ -15349,7 +15091,7 @@
           <p:cNvPr id="8" name="">
             <a:extLst xmlns:a="http://schemas.openxmlformats.org/drawingml/2006/main">
               <a:ext uri="{FF2B5EF4-FFF2-40B4-BE49-F238E27FC236}">
-                <a16:creationId xmlns:a16="http://schemas.microsoft.com/office/drawing/2014/main" id="{BD097E43-5CF5-4D07-BED6-3056D1F34E7E}"/>
+                <a16:creationId xmlns:a16="http://schemas.microsoft.com/office/drawing/2014/main" id="{0B2C79F3-0DB9-4D39-9B61-B9866CAD1666}"/>
               </a:ext>
             </a:extLst>
           </p:cNvPr>
@@ -15413,7 +15155,7 @@
           <p:cNvPr id="9" name="">
             <a:extLst xmlns:a="http://schemas.openxmlformats.org/drawingml/2006/main">
               <a:ext uri="{FF2B5EF4-FFF2-40B4-BE49-F238E27FC236}">
-                <a16:creationId xmlns:a16="http://schemas.microsoft.com/office/drawing/2014/main" id="{27956282-34AF-4D2D-9114-D00E51487EEE}"/>
+                <a16:creationId xmlns:a16="http://schemas.microsoft.com/office/drawing/2014/main" id="{F38E68CF-F2D8-466B-8C25-3E5E952955A7}"/>
               </a:ext>
             </a:extLst>
           </p:cNvPr>
@@ -15448,7 +15190,7 @@
           <p:cNvPr id="10" name="">
             <a:extLst xmlns:a="http://schemas.openxmlformats.org/drawingml/2006/main">
               <a:ext uri="{FF2B5EF4-FFF2-40B4-BE49-F238E27FC236}">
-                <a16:creationId xmlns:a16="http://schemas.microsoft.com/office/drawing/2014/main" id="{47D340D5-A1EC-4759-898A-B88D9BBEA4B3}"/>
+                <a16:creationId xmlns:a16="http://schemas.microsoft.com/office/drawing/2014/main" id="{02D86F26-A9BC-452A-94FE-558E2E11626B}"/>
               </a:ext>
             </a:extLst>
           </p:cNvPr>
@@ -15512,7 +15254,7 @@
           <p:cNvPr id="11" name="">
             <a:extLst xmlns:a="http://schemas.openxmlformats.org/drawingml/2006/main">
               <a:ext uri="{FF2B5EF4-FFF2-40B4-BE49-F238E27FC236}">
-                <a16:creationId xmlns:a16="http://schemas.microsoft.com/office/drawing/2014/main" id="{DCDD5E3D-D383-4507-ACB6-4A881A8872AB}"/>
+                <a16:creationId xmlns:a16="http://schemas.microsoft.com/office/drawing/2014/main" id="{C586FF42-8225-41A6-9F88-D2FAD10A8FEC}"/>
               </a:ext>
             </a:extLst>
           </p:cNvPr>
@@ -15547,7 +15289,7 @@
           <p:cNvPr id="12" name="">
             <a:extLst xmlns:a="http://schemas.openxmlformats.org/drawingml/2006/main">
               <a:ext uri="{FF2B5EF4-FFF2-40B4-BE49-F238E27FC236}">
-                <a16:creationId xmlns:a16="http://schemas.microsoft.com/office/drawing/2014/main" id="{FFA6077D-C22A-48AB-8D9F-DEC53B9DCC15}"/>
+                <a16:creationId xmlns:a16="http://schemas.microsoft.com/office/drawing/2014/main" id="{CB6978AF-2EA2-480E-8411-78DD5667DCA7}"/>
               </a:ext>
             </a:extLst>
           </p:cNvPr>
@@ -15611,7 +15353,7 @@
           <p:cNvPr id="13" name="">
             <a:extLst xmlns:a="http://schemas.openxmlformats.org/drawingml/2006/main">
               <a:ext uri="{FF2B5EF4-FFF2-40B4-BE49-F238E27FC236}">
-                <a16:creationId xmlns:a16="http://schemas.microsoft.com/office/drawing/2014/main" id="{D0CFFF85-A24D-4677-B0A5-FE5FF7DCFB57}"/>
+                <a16:creationId xmlns:a16="http://schemas.microsoft.com/office/drawing/2014/main" id="{18CBE6AA-DF00-491C-825B-E9FCE0FCC645}"/>
               </a:ext>
             </a:extLst>
           </p:cNvPr>
@@ -15646,7 +15388,7 @@
           <p:cNvPr id="14" name="">
             <a:extLst xmlns:a="http://schemas.openxmlformats.org/drawingml/2006/main">
               <a:ext uri="{FF2B5EF4-FFF2-40B4-BE49-F238E27FC236}">
-                <a16:creationId xmlns:a16="http://schemas.microsoft.com/office/drawing/2014/main" id="{03EEA47D-689E-4D64-AFAE-AA4CC5A3B723}"/>
+                <a16:creationId xmlns:a16="http://schemas.microsoft.com/office/drawing/2014/main" id="{3F4C7CD0-A74F-4210-AD0F-C232E3A29243}"/>
               </a:ext>
             </a:extLst>
           </p:cNvPr>
@@ -15710,7 +15452,7 @@
           <p:cNvPr id="15" name="">
             <a:extLst xmlns:a="http://schemas.openxmlformats.org/drawingml/2006/main">
               <a:ext uri="{FF2B5EF4-FFF2-40B4-BE49-F238E27FC236}">
-                <a16:creationId xmlns:a16="http://schemas.microsoft.com/office/drawing/2014/main" id="{EFC8A124-B4A8-43B4-8EC4-DC19AF7EAF9D}"/>
+                <a16:creationId xmlns:a16="http://schemas.microsoft.com/office/drawing/2014/main" id="{4A621123-D8CE-4780-8895-E29EE2009449}"/>
               </a:ext>
             </a:extLst>
           </p:cNvPr>
@@ -15745,7 +15487,7 @@
           <p:cNvPr id="16" name="">
             <a:extLst xmlns:a="http://schemas.openxmlformats.org/drawingml/2006/main">
               <a:ext uri="{FF2B5EF4-FFF2-40B4-BE49-F238E27FC236}">
-                <a16:creationId xmlns:a16="http://schemas.microsoft.com/office/drawing/2014/main" id="{4C4EF314-F031-40BF-9900-011C41DE8BFC}"/>
+                <a16:creationId xmlns:a16="http://schemas.microsoft.com/office/drawing/2014/main" id="{C7E13A5C-298A-46CD-A382-57EADC547AAB}"/>
               </a:ext>
             </a:extLst>
           </p:cNvPr>
@@ -15809,7 +15551,7 @@
           <p:cNvPr id="17" name="">
             <a:extLst xmlns:a="http://schemas.openxmlformats.org/drawingml/2006/main">
               <a:ext uri="{FF2B5EF4-FFF2-40B4-BE49-F238E27FC236}">
-                <a16:creationId xmlns:a16="http://schemas.microsoft.com/office/drawing/2014/main" id="{6E1E31F1-FDF4-4873-A0ED-945B0E5CD0EB}"/>
+                <a16:creationId xmlns:a16="http://schemas.microsoft.com/office/drawing/2014/main" id="{2ED2E453-FA79-4A35-A88B-CAB59FD2DC51}"/>
               </a:ext>
             </a:extLst>
           </p:cNvPr>
@@ -15842,7 +15584,7 @@
           <p:cNvPr id="18" name="">
             <a:extLst xmlns:a="http://schemas.openxmlformats.org/drawingml/2006/main">
               <a:ext uri="{FF2B5EF4-FFF2-40B4-BE49-F238E27FC236}">
-                <a16:creationId xmlns:a16="http://schemas.microsoft.com/office/drawing/2014/main" id="{DAB059EE-2CAF-4ABB-A139-71E099DFFEED}"/>
+                <a16:creationId xmlns:a16="http://schemas.microsoft.com/office/drawing/2014/main" id="{96A42E4F-5127-4C6F-90B7-271BD3516AB5}"/>
               </a:ext>
             </a:extLst>
           </p:cNvPr>
@@ -15875,7 +15617,7 @@
           <p:cNvPr id="19" name="">
             <a:extLst xmlns:a="http://schemas.openxmlformats.org/drawingml/2006/main">
               <a:ext uri="{FF2B5EF4-FFF2-40B4-BE49-F238E27FC236}">
-                <a16:creationId xmlns:a16="http://schemas.microsoft.com/office/drawing/2014/main" id="{E0AB2AA1-9811-4CEB-9727-15C191760A6A}"/>
+                <a16:creationId xmlns:a16="http://schemas.microsoft.com/office/drawing/2014/main" id="{4DCCC8AE-3447-4919-88D4-B60A0C240E31}"/>
               </a:ext>
             </a:extLst>
           </p:cNvPr>
@@ -15939,7 +15681,7 @@
           <p:cNvPr id="20" name="">
             <a:extLst xmlns:a="http://schemas.openxmlformats.org/drawingml/2006/main">
               <a:ext uri="{FF2B5EF4-FFF2-40B4-BE49-F238E27FC236}">
-                <a16:creationId xmlns:a16="http://schemas.microsoft.com/office/drawing/2014/main" id="{69A9587E-0911-4952-A0A8-C4DB53E73021}"/>
+                <a16:creationId xmlns:a16="http://schemas.microsoft.com/office/drawing/2014/main" id="{885C04DF-3185-48C6-99E9-F599F00C77E6}"/>
               </a:ext>
             </a:extLst>
           </p:cNvPr>
@@ -15974,7 +15716,7 @@
           <p:cNvPr id="21" name="">
             <a:extLst xmlns:a="http://schemas.openxmlformats.org/drawingml/2006/main">
               <a:ext uri="{FF2B5EF4-FFF2-40B4-BE49-F238E27FC236}">
-                <a16:creationId xmlns:a16="http://schemas.microsoft.com/office/drawing/2014/main" id="{57B59DAA-D0E9-461E-8B9E-37AA99447033}"/>
+                <a16:creationId xmlns:a16="http://schemas.microsoft.com/office/drawing/2014/main" id="{069A140E-ABDD-44AE-BAEE-38996F318EE8}"/>
               </a:ext>
             </a:extLst>
           </p:cNvPr>
@@ -16038,7 +15780,7 @@
           <p:cNvPr id="22" name="">
             <a:extLst xmlns:a="http://schemas.openxmlformats.org/drawingml/2006/main">
               <a:ext uri="{FF2B5EF4-FFF2-40B4-BE49-F238E27FC236}">
-                <a16:creationId xmlns:a16="http://schemas.microsoft.com/office/drawing/2014/main" id="{B45891DA-4171-45D0-AA08-C1D148DDE8F9}"/>
+                <a16:creationId xmlns:a16="http://schemas.microsoft.com/office/drawing/2014/main" id="{F3DA279B-AE60-46E7-935E-C247D20F98DF}"/>
               </a:ext>
             </a:extLst>
           </p:cNvPr>
@@ -16073,7 +15815,7 @@
           <p:cNvPr id="23" name="">
             <a:extLst xmlns:a="http://schemas.openxmlformats.org/drawingml/2006/main">
               <a:ext uri="{FF2B5EF4-FFF2-40B4-BE49-F238E27FC236}">
-                <a16:creationId xmlns:a16="http://schemas.microsoft.com/office/drawing/2014/main" id="{DA766C9A-72A7-4D46-A202-CEB620299829}"/>
+                <a16:creationId xmlns:a16="http://schemas.microsoft.com/office/drawing/2014/main" id="{C753A80F-EB3B-434C-A03A-7683BAD0A244}"/>
               </a:ext>
             </a:extLst>
           </p:cNvPr>
@@ -16137,7 +15879,7 @@
           <p:cNvPr id="24" name="">
             <a:extLst xmlns:a="http://schemas.openxmlformats.org/drawingml/2006/main">
               <a:ext uri="{FF2B5EF4-FFF2-40B4-BE49-F238E27FC236}">
-                <a16:creationId xmlns:a16="http://schemas.microsoft.com/office/drawing/2014/main" id="{6EC4E855-B9CB-416D-9E0B-85CE2ADC9CBD}"/>
+                <a16:creationId xmlns:a16="http://schemas.microsoft.com/office/drawing/2014/main" id="{173D9672-795F-4797-A61E-D7B1137C4D50}"/>
               </a:ext>
             </a:extLst>
           </p:cNvPr>
@@ -16172,7 +15914,7 @@
           <p:cNvPr id="25" name="">
             <a:extLst xmlns:a="http://schemas.openxmlformats.org/drawingml/2006/main">
               <a:ext uri="{FF2B5EF4-FFF2-40B4-BE49-F238E27FC236}">
-                <a16:creationId xmlns:a16="http://schemas.microsoft.com/office/drawing/2014/main" id="{F08AD74B-5816-4C14-9FDC-97B57D6A99B1}"/>
+                <a16:creationId xmlns:a16="http://schemas.microsoft.com/office/drawing/2014/main" id="{F0254298-74E7-4A6C-8B44-9C967822D54C}"/>
               </a:ext>
             </a:extLst>
           </p:cNvPr>
@@ -16236,7 +15978,7 @@
           <p:cNvPr id="26" name="">
             <a:extLst xmlns:a="http://schemas.openxmlformats.org/drawingml/2006/main">
               <a:ext uri="{FF2B5EF4-FFF2-40B4-BE49-F238E27FC236}">
-                <a16:creationId xmlns:a16="http://schemas.microsoft.com/office/drawing/2014/main" id="{6AFCEE9D-4195-4273-AF85-13C9E7A0E287}"/>
+                <a16:creationId xmlns:a16="http://schemas.microsoft.com/office/drawing/2014/main" id="{6C5DBF0C-2F78-4443-B187-A43F7DCFBC5E}"/>
               </a:ext>
             </a:extLst>
           </p:cNvPr>
@@ -16271,7 +16013,7 @@
           <p:cNvPr id="27" name="">
             <a:extLst xmlns:a="http://schemas.openxmlformats.org/drawingml/2006/main">
               <a:ext uri="{FF2B5EF4-FFF2-40B4-BE49-F238E27FC236}">
-                <a16:creationId xmlns:a16="http://schemas.microsoft.com/office/drawing/2014/main" id="{00C02783-006F-4214-983E-24AA8DD06609}"/>
+                <a16:creationId xmlns:a16="http://schemas.microsoft.com/office/drawing/2014/main" id="{D157603D-B9B9-4276-8C98-E0A87E19A8F1}"/>
               </a:ext>
             </a:extLst>
           </p:cNvPr>
@@ -16335,7 +16077,7 @@
           <p:cNvPr id="28" name="">
             <a:extLst xmlns:a="http://schemas.openxmlformats.org/drawingml/2006/main">
               <a:ext uri="{FF2B5EF4-FFF2-40B4-BE49-F238E27FC236}">
-                <a16:creationId xmlns:a16="http://schemas.microsoft.com/office/drawing/2014/main" id="{B451A94D-AE22-4066-A151-D45CB3DBF587}"/>
+                <a16:creationId xmlns:a16="http://schemas.microsoft.com/office/drawing/2014/main" id="{67405140-3228-4A1B-BEAD-EBFC0F9494AE}"/>
               </a:ext>
             </a:extLst>
           </p:cNvPr>
@@ -16368,7 +16110,7 @@
           <p:cNvPr id="29" name="">
             <a:extLst xmlns:a="http://schemas.openxmlformats.org/drawingml/2006/main">
               <a:ext uri="{FF2B5EF4-FFF2-40B4-BE49-F238E27FC236}">
-                <a16:creationId xmlns:a16="http://schemas.microsoft.com/office/drawing/2014/main" id="{7AE14DE5-0DA4-403B-BCDB-949ED88F3815}"/>
+                <a16:creationId xmlns:a16="http://schemas.microsoft.com/office/drawing/2014/main" id="{3549FBAC-8B94-4A00-A131-777CFB6A3175}"/>
               </a:ext>
             </a:extLst>
           </p:cNvPr>
@@ -16401,7 +16143,7 @@
           <p:cNvPr id="30" name="">
             <a:extLst xmlns:a="http://schemas.openxmlformats.org/drawingml/2006/main">
               <a:ext uri="{FF2B5EF4-FFF2-40B4-BE49-F238E27FC236}">
-                <a16:creationId xmlns:a16="http://schemas.microsoft.com/office/drawing/2014/main" id="{1F407CB3-5E20-4F03-AB8D-248287B43DE4}"/>
+                <a16:creationId xmlns:a16="http://schemas.microsoft.com/office/drawing/2014/main" id="{BD305BBE-C174-45C1-9510-E7CBC26DA767}"/>
               </a:ext>
             </a:extLst>
           </p:cNvPr>
@@ -16465,7 +16207,7 @@
           <p:cNvPr id="31" name="">
             <a:extLst xmlns:a="http://schemas.openxmlformats.org/drawingml/2006/main">
               <a:ext uri="{FF2B5EF4-FFF2-40B4-BE49-F238E27FC236}">
-                <a16:creationId xmlns:a16="http://schemas.microsoft.com/office/drawing/2014/main" id="{7C8EE669-A063-4C6F-BEED-7B85943F0746}"/>
+                <a16:creationId xmlns:a16="http://schemas.microsoft.com/office/drawing/2014/main" id="{AC3CFFE3-1304-41A2-B12C-EB340682C1C7}"/>
               </a:ext>
             </a:extLst>
           </p:cNvPr>
@@ -16500,7 +16242,7 @@
           <p:cNvPr id="32" name="">
             <a:extLst xmlns:a="http://schemas.openxmlformats.org/drawingml/2006/main">
               <a:ext uri="{FF2B5EF4-FFF2-40B4-BE49-F238E27FC236}">
-                <a16:creationId xmlns:a16="http://schemas.microsoft.com/office/drawing/2014/main" id="{594F119E-1562-4AA7-A6DE-CBB6C48E45C7}"/>
+                <a16:creationId xmlns:a16="http://schemas.microsoft.com/office/drawing/2014/main" id="{A282B0C6-B408-486B-A0B9-58C6EF8AE883}"/>
               </a:ext>
             </a:extLst>
           </p:cNvPr>
@@ -16564,7 +16306,7 @@
           <p:cNvPr id="33" name="">
             <a:extLst xmlns:a="http://schemas.openxmlformats.org/drawingml/2006/main">
               <a:ext uri="{FF2B5EF4-FFF2-40B4-BE49-F238E27FC236}">
-                <a16:creationId xmlns:a16="http://schemas.microsoft.com/office/drawing/2014/main" id="{0D12524C-AC7E-48B6-8367-FD38E7F3DDB6}"/>
+                <a16:creationId xmlns:a16="http://schemas.microsoft.com/office/drawing/2014/main" id="{AF6A5FF0-B02A-42C1-B6E1-4C642FFC623B}"/>
               </a:ext>
             </a:extLst>
           </p:cNvPr>
@@ -16599,7 +16341,7 @@
           <p:cNvPr id="34" name="">
             <a:extLst xmlns:a="http://schemas.openxmlformats.org/drawingml/2006/main">
               <a:ext uri="{FF2B5EF4-FFF2-40B4-BE49-F238E27FC236}">
-                <a16:creationId xmlns:a16="http://schemas.microsoft.com/office/drawing/2014/main" id="{87D8EAEE-8D85-453D-905E-4E57E8DEFA11}"/>
+                <a16:creationId xmlns:a16="http://schemas.microsoft.com/office/drawing/2014/main" id="{413A539B-E40A-485F-A618-73B932A6A552}"/>
               </a:ext>
             </a:extLst>
           </p:cNvPr>
@@ -16663,7 +16405,7 @@
           <p:cNvPr id="35" name="">
             <a:extLst xmlns:a="http://schemas.openxmlformats.org/drawingml/2006/main">
               <a:ext uri="{FF2B5EF4-FFF2-40B4-BE49-F238E27FC236}">
-                <a16:creationId xmlns:a16="http://schemas.microsoft.com/office/drawing/2014/main" id="{058744CF-9B84-49CF-A6F1-668C00E74271}"/>
+                <a16:creationId xmlns:a16="http://schemas.microsoft.com/office/drawing/2014/main" id="{C981C2AD-1CF3-4BE4-8644-08452C96C8B3}"/>
               </a:ext>
             </a:extLst>
           </p:cNvPr>
@@ -16698,7 +16440,7 @@
           <p:cNvPr id="36" name="">
             <a:extLst xmlns:a="http://schemas.openxmlformats.org/drawingml/2006/main">
               <a:ext uri="{FF2B5EF4-FFF2-40B4-BE49-F238E27FC236}">
-                <a16:creationId xmlns:a16="http://schemas.microsoft.com/office/drawing/2014/main" id="{E153B82C-4009-44F0-9130-A4B1A4B5AF97}"/>
+                <a16:creationId xmlns:a16="http://schemas.microsoft.com/office/drawing/2014/main" id="{5E075EDF-C0AB-42C7-9C7E-5D3F40AFFC04}"/>
               </a:ext>
             </a:extLst>
           </p:cNvPr>
@@ -16762,7 +16504,7 @@
           <p:cNvPr id="37" name="">
             <a:extLst xmlns:a="http://schemas.openxmlformats.org/drawingml/2006/main">
               <a:ext uri="{FF2B5EF4-FFF2-40B4-BE49-F238E27FC236}">
-                <a16:creationId xmlns:a16="http://schemas.microsoft.com/office/drawing/2014/main" id="{6084B440-4656-46B9-A720-218D778C6AC6}"/>
+                <a16:creationId xmlns:a16="http://schemas.microsoft.com/office/drawing/2014/main" id="{7D748FC8-6A9C-46EF-85B6-C4F281996E16}"/>
               </a:ext>
             </a:extLst>
           </p:cNvPr>
@@ -16797,7 +16539,7 @@
           <p:cNvPr id="38" name="">
             <a:extLst xmlns:a="http://schemas.openxmlformats.org/drawingml/2006/main">
               <a:ext uri="{FF2B5EF4-FFF2-40B4-BE49-F238E27FC236}">
-                <a16:creationId xmlns:a16="http://schemas.microsoft.com/office/drawing/2014/main" id="{CEE6CF29-E486-4E27-B2CD-BADDC71485C7}"/>
+                <a16:creationId xmlns:a16="http://schemas.microsoft.com/office/drawing/2014/main" id="{0210328B-BCE3-4AEC-90C4-3FCE16B49491}"/>
               </a:ext>
             </a:extLst>
           </p:cNvPr>
@@ -16861,7 +16603,7 @@
           <p:cNvPr id="39" name="">
             <a:extLst xmlns:a="http://schemas.openxmlformats.org/drawingml/2006/main">
               <a:ext uri="{FF2B5EF4-FFF2-40B4-BE49-F238E27FC236}">
-                <a16:creationId xmlns:a16="http://schemas.microsoft.com/office/drawing/2014/main" id="{6878E7E8-174B-4FB1-86CD-35171A17B2AC}"/>
+                <a16:creationId xmlns:a16="http://schemas.microsoft.com/office/drawing/2014/main" id="{C82360C3-10C6-45FF-94CC-5D68F6354E83}"/>
               </a:ext>
             </a:extLst>
           </p:cNvPr>
@@ -16896,7 +16638,7 @@
           <p:cNvPr id="40" name="">
             <a:extLst xmlns:a="http://schemas.openxmlformats.org/drawingml/2006/main">
               <a:ext uri="{FF2B5EF4-FFF2-40B4-BE49-F238E27FC236}">
-                <a16:creationId xmlns:a16="http://schemas.microsoft.com/office/drawing/2014/main" id="{A2FDA3B8-002F-4D9B-BAED-4AC0708C44A0}"/>
+                <a16:creationId xmlns:a16="http://schemas.microsoft.com/office/drawing/2014/main" id="{DFE73E61-D33A-4171-A4BD-78D7B40EE0A8}"/>
               </a:ext>
             </a:extLst>
           </p:cNvPr>
@@ -16960,7 +16702,7 @@
           <p:cNvPr id="41" name="">
             <a:extLst xmlns:a="http://schemas.openxmlformats.org/drawingml/2006/main">
               <a:ext uri="{FF2B5EF4-FFF2-40B4-BE49-F238E27FC236}">
-                <a16:creationId xmlns:a16="http://schemas.microsoft.com/office/drawing/2014/main" id="{49BA7950-18D2-47D7-92E6-3BE4A637CBF6}"/>
+                <a16:creationId xmlns:a16="http://schemas.microsoft.com/office/drawing/2014/main" id="{F8E6ECF2-78DE-43E5-9CAC-97C9800B1718}"/>
               </a:ext>
             </a:extLst>
           </p:cNvPr>
@@ -16993,7 +16735,7 @@
           <p:cNvPr id="42" name="">
             <a:extLst xmlns:a="http://schemas.openxmlformats.org/drawingml/2006/main">
               <a:ext uri="{FF2B5EF4-FFF2-40B4-BE49-F238E27FC236}">
-                <a16:creationId xmlns:a16="http://schemas.microsoft.com/office/drawing/2014/main" id="{9D351420-414A-4AC9-99FF-14353797E134}"/>
+                <a16:creationId xmlns:a16="http://schemas.microsoft.com/office/drawing/2014/main" id="{38A6CFEC-3652-41F1-812F-D0B702590A6B}"/>
               </a:ext>
             </a:extLst>
           </p:cNvPr>
@@ -17057,7 +16799,7 @@
           <p:cNvPr id="43" name="">
             <a:extLst xmlns:a="http://schemas.openxmlformats.org/drawingml/2006/main">
               <a:ext uri="{FF2B5EF4-FFF2-40B4-BE49-F238E27FC236}">
-                <a16:creationId xmlns:a16="http://schemas.microsoft.com/office/drawing/2014/main" id="{921A702E-8C5F-431C-8727-247D711ECF0F}"/>
+                <a16:creationId xmlns:a16="http://schemas.microsoft.com/office/drawing/2014/main" id="{059B75AC-2C6D-4937-9146-8126BDC1B3EB}"/>
               </a:ext>
             </a:extLst>
           </p:cNvPr>
@@ -17092,7 +16834,7 @@
           <p:cNvPr id="44" name="">
             <a:extLst xmlns:a="http://schemas.openxmlformats.org/drawingml/2006/main">
               <a:ext uri="{FF2B5EF4-FFF2-40B4-BE49-F238E27FC236}">
-                <a16:creationId xmlns:a16="http://schemas.microsoft.com/office/drawing/2014/main" id="{66FCADE9-2910-4C3B-84FE-759EF41D4F68}"/>
+                <a16:creationId xmlns:a16="http://schemas.microsoft.com/office/drawing/2014/main" id="{A13145B5-522C-47D9-91FB-405841C6FBD2}"/>
               </a:ext>
             </a:extLst>
           </p:cNvPr>
@@ -17156,7 +16898,7 @@
           <p:cNvPr id="45" name="">
             <a:extLst xmlns:a="http://schemas.openxmlformats.org/drawingml/2006/main">
               <a:ext uri="{FF2B5EF4-FFF2-40B4-BE49-F238E27FC236}">
-                <a16:creationId xmlns:a16="http://schemas.microsoft.com/office/drawing/2014/main" id="{F53F800D-EEDB-40C3-9240-40AD641FB11E}"/>
+                <a16:creationId xmlns:a16="http://schemas.microsoft.com/office/drawing/2014/main" id="{4B723F98-C420-4B32-95C6-7E21B1F93FDD}"/>
               </a:ext>
             </a:extLst>
           </p:cNvPr>
@@ -17218,7 +16960,7 @@
     </p:spTree>
     <p:extLst>
       <p:ext uri="{BB962C8B-B14F-4D97-AF65-F5344CB8AC3E}">
-        <p14:creationId xmlns:p14="http://schemas.microsoft.com/office/powerpoint/2010/main" val="1298981077"/>
+        <p14:creationId xmlns:p14="http://schemas.microsoft.com/office/powerpoint/2010/main" val="1724006600"/>
       </p:ext>
     </p:extLst>
   </p:cSld>
@@ -17242,7 +16984,7 @@
           <p:cNvPr id="1" name="">
             <a:extLst xmlns:a="http://schemas.openxmlformats.org/drawingml/2006/main">
               <a:ext uri="{FF2B5EF4-FFF2-40B4-BE49-F238E27FC236}">
-                <a16:creationId xmlns:a16="http://schemas.microsoft.com/office/drawing/2014/main" id="{D3DA76B1-C997-4BE7-9DE7-57ED9CD57BF7}"/>
+                <a16:creationId xmlns:a16="http://schemas.microsoft.com/office/drawing/2014/main" id="{ABE3B2ED-F52F-4A32-BC87-8C0F12F5B9D9}"/>
               </a:ext>
             </a:extLst>
           </p:cNvPr>
@@ -17277,7 +17019,7 @@
           <p:cNvPr id="2" name="">
             <a:extLst xmlns:a="http://schemas.openxmlformats.org/drawingml/2006/main">
               <a:ext uri="{FF2B5EF4-FFF2-40B4-BE49-F238E27FC236}">
-                <a16:creationId xmlns:a16="http://schemas.microsoft.com/office/drawing/2014/main" id="{A281FC7B-DD44-4C44-8CE3-7CA580E2D40E}"/>
+                <a16:creationId xmlns:a16="http://schemas.microsoft.com/office/drawing/2014/main" id="{C1C4982E-96A1-4C28-B42C-E034CDB93C9D}"/>
               </a:ext>
             </a:extLst>
           </p:cNvPr>
@@ -17312,7 +17054,7 @@
           <p:cNvPr id="3" name="">
             <a:extLst xmlns:a="http://schemas.openxmlformats.org/drawingml/2006/main">
               <a:ext uri="{FF2B5EF4-FFF2-40B4-BE49-F238E27FC236}">
-                <a16:creationId xmlns:a16="http://schemas.microsoft.com/office/drawing/2014/main" id="{6FCED97B-791B-43BE-B118-C919E901DFBD}"/>
+                <a16:creationId xmlns:a16="http://schemas.microsoft.com/office/drawing/2014/main" id="{B08A79FA-DD6C-49B8-A777-5307861B889D}"/>
               </a:ext>
             </a:extLst>
           </p:cNvPr>
@@ -17376,7 +17118,7 @@
           <p:cNvPr id="4" name="">
             <a:extLst xmlns:a="http://schemas.openxmlformats.org/drawingml/2006/main">
               <a:ext uri="{FF2B5EF4-FFF2-40B4-BE49-F238E27FC236}">
-                <a16:creationId xmlns:a16="http://schemas.microsoft.com/office/drawing/2014/main" id="{7B129661-D7A3-41A4-B06C-8B6A1F764ADE}"/>
+                <a16:creationId xmlns:a16="http://schemas.microsoft.com/office/drawing/2014/main" id="{B6C8B4D3-09D6-463C-8E40-B4E5EAFAA2DA}"/>
               </a:ext>
             </a:extLst>
           </p:cNvPr>
@@ -17440,7 +17182,7 @@
           <p:cNvPr id="5" name="">
             <a:extLst xmlns:a="http://schemas.openxmlformats.org/drawingml/2006/main">
               <a:ext uri="{FF2B5EF4-FFF2-40B4-BE49-F238E27FC236}">
-                <a16:creationId xmlns:a16="http://schemas.microsoft.com/office/drawing/2014/main" id="{A6E64548-633B-4BA6-8339-E75AC61225E0}"/>
+                <a16:creationId xmlns:a16="http://schemas.microsoft.com/office/drawing/2014/main" id="{439F87E4-1221-42B3-9B8F-2108C6855AB3}"/>
               </a:ext>
             </a:extLst>
           </p:cNvPr>
@@ -17504,7 +17246,7 @@
           <p:cNvPr id="6" name="">
             <a:extLst xmlns:a="http://schemas.openxmlformats.org/drawingml/2006/main">
               <a:ext uri="{FF2B5EF4-FFF2-40B4-BE49-F238E27FC236}">
-                <a16:creationId xmlns:a16="http://schemas.microsoft.com/office/drawing/2014/main" id="{20DB69A8-D37C-48FE-9E04-87EBCDD0F7E5}"/>
+                <a16:creationId xmlns:a16="http://schemas.microsoft.com/office/drawing/2014/main" id="{2C7F07F2-C300-4D59-9DBD-95A9B895E341}"/>
               </a:ext>
             </a:extLst>
           </p:cNvPr>
@@ -17537,7 +17279,7 @@
           <p:cNvPr id="7" name="">
             <a:extLst xmlns:a="http://schemas.openxmlformats.org/drawingml/2006/main">
               <a:ext uri="{FF2B5EF4-FFF2-40B4-BE49-F238E27FC236}">
-                <a16:creationId xmlns:a16="http://schemas.microsoft.com/office/drawing/2014/main" id="{E0EB27E6-B7C3-49D1-B002-4D99AECF8F4C}"/>
+                <a16:creationId xmlns:a16="http://schemas.microsoft.com/office/drawing/2014/main" id="{440120CF-4E59-4725-8BBF-1D49229E84C3}"/>
               </a:ext>
             </a:extLst>
           </p:cNvPr>
@@ -17601,7 +17343,7 @@
           <p:cNvPr id="8" name="">
             <a:extLst xmlns:a="http://schemas.openxmlformats.org/drawingml/2006/main">
               <a:ext uri="{FF2B5EF4-FFF2-40B4-BE49-F238E27FC236}">
-                <a16:creationId xmlns:a16="http://schemas.microsoft.com/office/drawing/2014/main" id="{C653EC91-EB92-4299-B862-2DC561DE477B}"/>
+                <a16:creationId xmlns:a16="http://schemas.microsoft.com/office/drawing/2014/main" id="{788C698B-C712-42A2-8D9E-572A812C9C47}"/>
               </a:ext>
             </a:extLst>
           </p:cNvPr>
@@ -17634,7 +17376,7 @@
           <p:cNvPr id="9" name="">
             <a:extLst xmlns:a="http://schemas.openxmlformats.org/drawingml/2006/main">
               <a:ext uri="{FF2B5EF4-FFF2-40B4-BE49-F238E27FC236}">
-                <a16:creationId xmlns:a16="http://schemas.microsoft.com/office/drawing/2014/main" id="{C32E535A-15D8-40D1-BFFE-678E9AB72806}"/>
+                <a16:creationId xmlns:a16="http://schemas.microsoft.com/office/drawing/2014/main" id="{B6D689FF-86F1-4A60-A4ED-8F0F928DF9DC}"/>
               </a:ext>
             </a:extLst>
           </p:cNvPr>
@@ -17698,7 +17440,7 @@
           <p:cNvPr id="10" name="">
             <a:extLst xmlns:a="http://schemas.openxmlformats.org/drawingml/2006/main">
               <a:ext uri="{FF2B5EF4-FFF2-40B4-BE49-F238E27FC236}">
-                <a16:creationId xmlns:a16="http://schemas.microsoft.com/office/drawing/2014/main" id="{BC624ABF-E512-49FD-AAF6-A91C69B388B5}"/>
+                <a16:creationId xmlns:a16="http://schemas.microsoft.com/office/drawing/2014/main" id="{0DFEFE6D-78D8-4807-BE3E-CA3F78E58C11}"/>
               </a:ext>
             </a:extLst>
           </p:cNvPr>
@@ -17762,7 +17504,7 @@
           <p:cNvPr id="11" name="">
             <a:extLst xmlns:a="http://schemas.openxmlformats.org/drawingml/2006/main">
               <a:ext uri="{FF2B5EF4-FFF2-40B4-BE49-F238E27FC236}">
-                <a16:creationId xmlns:a16="http://schemas.microsoft.com/office/drawing/2014/main" id="{DECFB64F-3629-4085-ACDF-A4FB9E388F67}"/>
+                <a16:creationId xmlns:a16="http://schemas.microsoft.com/office/drawing/2014/main" id="{E474E003-6E42-4AEA-BE89-E71846C5DF84}"/>
               </a:ext>
             </a:extLst>
           </p:cNvPr>
@@ -17795,7 +17537,7 @@
           <p:cNvPr id="12" name="">
             <a:extLst xmlns:a="http://schemas.openxmlformats.org/drawingml/2006/main">
               <a:ext uri="{FF2B5EF4-FFF2-40B4-BE49-F238E27FC236}">
-                <a16:creationId xmlns:a16="http://schemas.microsoft.com/office/drawing/2014/main" id="{13A28578-972F-47A1-8505-0EF12E3B2B1E}"/>
+                <a16:creationId xmlns:a16="http://schemas.microsoft.com/office/drawing/2014/main" id="{424AF4CF-896C-4965-B636-B3001AF95F94}"/>
               </a:ext>
             </a:extLst>
           </p:cNvPr>
@@ -17859,7 +17601,7 @@
           <p:cNvPr id="13" name="">
             <a:extLst xmlns:a="http://schemas.openxmlformats.org/drawingml/2006/main">
               <a:ext uri="{FF2B5EF4-FFF2-40B4-BE49-F238E27FC236}">
-                <a16:creationId xmlns:a16="http://schemas.microsoft.com/office/drawing/2014/main" id="{1ED38A39-D2D3-4214-BB1C-3B8D05B6A97C}"/>
+                <a16:creationId xmlns:a16="http://schemas.microsoft.com/office/drawing/2014/main" id="{D0027416-C8D9-41C1-832B-31A647C4EDEE}"/>
               </a:ext>
             </a:extLst>
           </p:cNvPr>
@@ -17923,7 +17665,7 @@
           <p:cNvPr id="14" name="">
             <a:extLst xmlns:a="http://schemas.openxmlformats.org/drawingml/2006/main">
               <a:ext uri="{FF2B5EF4-FFF2-40B4-BE49-F238E27FC236}">
-                <a16:creationId xmlns:a16="http://schemas.microsoft.com/office/drawing/2014/main" id="{ACFFBE34-A1C8-469F-A0C9-C49827D5150B}"/>
+                <a16:creationId xmlns:a16="http://schemas.microsoft.com/office/drawing/2014/main" id="{C3BB22CA-03EA-45EA-A4B8-F3A55E7023AF}"/>
               </a:ext>
             </a:extLst>
           </p:cNvPr>
@@ -17956,7 +17698,7 @@
           <p:cNvPr id="15" name="">
             <a:extLst xmlns:a="http://schemas.openxmlformats.org/drawingml/2006/main">
               <a:ext uri="{FF2B5EF4-FFF2-40B4-BE49-F238E27FC236}">
-                <a16:creationId xmlns:a16="http://schemas.microsoft.com/office/drawing/2014/main" id="{0852D765-A3AD-4D17-AE22-85B7110F4E08}"/>
+                <a16:creationId xmlns:a16="http://schemas.microsoft.com/office/drawing/2014/main" id="{763E2F89-2EF4-41C8-B206-CE8EC83B0275}"/>
               </a:ext>
             </a:extLst>
           </p:cNvPr>
@@ -18020,7 +17762,7 @@
           <p:cNvPr id="16" name="">
             <a:extLst xmlns:a="http://schemas.openxmlformats.org/drawingml/2006/main">
               <a:ext uri="{FF2B5EF4-FFF2-40B4-BE49-F238E27FC236}">
-                <a16:creationId xmlns:a16="http://schemas.microsoft.com/office/drawing/2014/main" id="{A51DE06B-32B8-4AE5-ABE1-709D2D3B4E29}"/>
+                <a16:creationId xmlns:a16="http://schemas.microsoft.com/office/drawing/2014/main" id="{2C0A3162-03F2-4B76-99E1-11AA329F0988}"/>
               </a:ext>
             </a:extLst>
           </p:cNvPr>
@@ -18084,7 +17826,7 @@
           <p:cNvPr id="17" name="">
             <a:extLst xmlns:a="http://schemas.openxmlformats.org/drawingml/2006/main">
               <a:ext uri="{FF2B5EF4-FFF2-40B4-BE49-F238E27FC236}">
-                <a16:creationId xmlns:a16="http://schemas.microsoft.com/office/drawing/2014/main" id="{B900A8DF-11FC-4176-861A-28B9FD7F2BB3}"/>
+                <a16:creationId xmlns:a16="http://schemas.microsoft.com/office/drawing/2014/main" id="{F3B81BE8-77B5-4597-B3ED-2333CC403F05}"/>
               </a:ext>
             </a:extLst>
           </p:cNvPr>
@@ -18117,7 +17859,7 @@
           <p:cNvPr id="18" name="">
             <a:extLst xmlns:a="http://schemas.openxmlformats.org/drawingml/2006/main">
               <a:ext uri="{FF2B5EF4-FFF2-40B4-BE49-F238E27FC236}">
-                <a16:creationId xmlns:a16="http://schemas.microsoft.com/office/drawing/2014/main" id="{F2AABCA2-AB3B-4904-BB52-F266B4DAA23B}"/>
+                <a16:creationId xmlns:a16="http://schemas.microsoft.com/office/drawing/2014/main" id="{89FF4296-12A9-4AD6-9F96-E5190126E659}"/>
               </a:ext>
             </a:extLst>
           </p:cNvPr>
@@ -18150,7 +17892,7 @@
           <p:cNvPr id="19" name="">
             <a:extLst xmlns:a="http://schemas.openxmlformats.org/drawingml/2006/main">
               <a:ext uri="{FF2B5EF4-FFF2-40B4-BE49-F238E27FC236}">
-                <a16:creationId xmlns:a16="http://schemas.microsoft.com/office/drawing/2014/main" id="{655DE5EE-5181-4574-B778-D0A30F2E0805}"/>
+                <a16:creationId xmlns:a16="http://schemas.microsoft.com/office/drawing/2014/main" id="{C764A2F6-153F-491E-8B4A-4DE602401A31}"/>
               </a:ext>
             </a:extLst>
           </p:cNvPr>
@@ -18214,7 +17956,7 @@
           <p:cNvPr id="20" name="">
             <a:extLst xmlns:a="http://schemas.openxmlformats.org/drawingml/2006/main">
               <a:ext uri="{FF2B5EF4-FFF2-40B4-BE49-F238E27FC236}">
-                <a16:creationId xmlns:a16="http://schemas.microsoft.com/office/drawing/2014/main" id="{824E0C1E-882C-47A7-994C-819D31309087}"/>
+                <a16:creationId xmlns:a16="http://schemas.microsoft.com/office/drawing/2014/main" id="{31A37052-4B97-435E-8822-B86394E83DDA}"/>
               </a:ext>
             </a:extLst>
           </p:cNvPr>
@@ -18278,7 +18020,7 @@
           <p:cNvPr id="21" name="">
             <a:extLst xmlns:a="http://schemas.openxmlformats.org/drawingml/2006/main">
               <a:ext uri="{FF2B5EF4-FFF2-40B4-BE49-F238E27FC236}">
-                <a16:creationId xmlns:a16="http://schemas.microsoft.com/office/drawing/2014/main" id="{A1BA8BCA-445C-4B6B-A3A0-73BED4E1D8DF}"/>
+                <a16:creationId xmlns:a16="http://schemas.microsoft.com/office/drawing/2014/main" id="{082EB29C-E73D-4933-B715-905419C0CA4C}"/>
               </a:ext>
             </a:extLst>
           </p:cNvPr>
@@ -18342,7 +18084,7 @@
           <p:cNvPr id="22" name="">
             <a:extLst xmlns:a="http://schemas.openxmlformats.org/drawingml/2006/main">
               <a:ext uri="{FF2B5EF4-FFF2-40B4-BE49-F238E27FC236}">
-                <a16:creationId xmlns:a16="http://schemas.microsoft.com/office/drawing/2014/main" id="{CE5E2DBE-C71B-43CD-87B7-ACA011039356}"/>
+                <a16:creationId xmlns:a16="http://schemas.microsoft.com/office/drawing/2014/main" id="{AD72EBEB-DB41-4E8B-B258-F7FF448B5BAD}"/>
               </a:ext>
             </a:extLst>
           </p:cNvPr>
@@ -18406,7 +18148,7 @@
           <p:cNvPr id="23" name="">
             <a:extLst xmlns:a="http://schemas.openxmlformats.org/drawingml/2006/main">
               <a:ext uri="{FF2B5EF4-FFF2-40B4-BE49-F238E27FC236}">
-                <a16:creationId xmlns:a16="http://schemas.microsoft.com/office/drawing/2014/main" id="{C45D36D4-AF72-4852-82A8-FEB573FC6169}"/>
+                <a16:creationId xmlns:a16="http://schemas.microsoft.com/office/drawing/2014/main" id="{C67D52E2-62EF-4AE0-B079-D26B03520EB2}"/>
               </a:ext>
             </a:extLst>
           </p:cNvPr>
@@ -18470,7 +18212,7 @@
           <p:cNvPr id="24" name="">
             <a:extLst xmlns:a="http://schemas.openxmlformats.org/drawingml/2006/main">
               <a:ext uri="{FF2B5EF4-FFF2-40B4-BE49-F238E27FC236}">
-                <a16:creationId xmlns:a16="http://schemas.microsoft.com/office/drawing/2014/main" id="{CACE1769-6291-4F4C-9DBA-C6581F091B82}"/>
+                <a16:creationId xmlns:a16="http://schemas.microsoft.com/office/drawing/2014/main" id="{07DDC0FC-9C30-48CD-8203-9EE0A6C3EE35}"/>
               </a:ext>
             </a:extLst>
           </p:cNvPr>
@@ -18534,7 +18276,7 @@
           <p:cNvPr id="25" name="">
             <a:extLst xmlns:a="http://schemas.openxmlformats.org/drawingml/2006/main">
               <a:ext uri="{FF2B5EF4-FFF2-40B4-BE49-F238E27FC236}">
-                <a16:creationId xmlns:a16="http://schemas.microsoft.com/office/drawing/2014/main" id="{028B13B3-F91D-46E3-9CBB-C160E1169AAB}"/>
+                <a16:creationId xmlns:a16="http://schemas.microsoft.com/office/drawing/2014/main" id="{5DD774DF-7462-4FD8-814E-2136201EA85F}"/>
               </a:ext>
             </a:extLst>
           </p:cNvPr>
@@ -18569,7 +18311,7 @@
           <p:cNvPr id="26" name="">
             <a:extLst xmlns:a="http://schemas.openxmlformats.org/drawingml/2006/main">
               <a:ext uri="{FF2B5EF4-FFF2-40B4-BE49-F238E27FC236}">
-                <a16:creationId xmlns:a16="http://schemas.microsoft.com/office/drawing/2014/main" id="{9C79B791-B6DC-4C04-B77B-BFBBC3CD698F}"/>
+                <a16:creationId xmlns:a16="http://schemas.microsoft.com/office/drawing/2014/main" id="{8D5BACA9-E11F-4109-8AB4-811B30C082EE}"/>
               </a:ext>
             </a:extLst>
           </p:cNvPr>
@@ -18633,7 +18375,7 @@
           <p:cNvPr id="27" name="">
             <a:extLst xmlns:a="http://schemas.openxmlformats.org/drawingml/2006/main">
               <a:ext uri="{FF2B5EF4-FFF2-40B4-BE49-F238E27FC236}">
-                <a16:creationId xmlns:a16="http://schemas.microsoft.com/office/drawing/2014/main" id="{C0FDA41C-7FDF-4181-B8E6-96D5023DBA08}"/>
+                <a16:creationId xmlns:a16="http://schemas.microsoft.com/office/drawing/2014/main" id="{6FDC952C-F8E7-4AD7-905D-7FE9B0381911}"/>
               </a:ext>
             </a:extLst>
           </p:cNvPr>
@@ -18697,7 +18439,7 @@
           <p:cNvPr id="28" name="">
             <a:extLst xmlns:a="http://schemas.openxmlformats.org/drawingml/2006/main">
               <a:ext uri="{FF2B5EF4-FFF2-40B4-BE49-F238E27FC236}">
-                <a16:creationId xmlns:a16="http://schemas.microsoft.com/office/drawing/2014/main" id="{3412C794-67ED-4B78-A379-D0792E50EDD5}"/>
+                <a16:creationId xmlns:a16="http://schemas.microsoft.com/office/drawing/2014/main" id="{36474642-EC90-467F-9408-6D7EC9EA5B91}"/>
               </a:ext>
             </a:extLst>
           </p:cNvPr>
@@ -18761,7 +18503,7 @@
           <p:cNvPr id="29" name="">
             <a:extLst xmlns:a="http://schemas.openxmlformats.org/drawingml/2006/main">
               <a:ext uri="{FF2B5EF4-FFF2-40B4-BE49-F238E27FC236}">
-                <a16:creationId xmlns:a16="http://schemas.microsoft.com/office/drawing/2014/main" id="{FBBE4E6B-5377-4E8E-A038-349288339F29}"/>
+                <a16:creationId xmlns:a16="http://schemas.microsoft.com/office/drawing/2014/main" id="{42764B83-E6DD-492B-84A3-01021AFB4517}"/>
               </a:ext>
             </a:extLst>
           </p:cNvPr>
@@ -18825,7 +18567,7 @@
           <p:cNvPr id="30" name="">
             <a:extLst xmlns:a="http://schemas.openxmlformats.org/drawingml/2006/main">
               <a:ext uri="{FF2B5EF4-FFF2-40B4-BE49-F238E27FC236}">
-                <a16:creationId xmlns:a16="http://schemas.microsoft.com/office/drawing/2014/main" id="{E099C5D4-F685-463C-B55D-7CC0A86DF04E}"/>
+                <a16:creationId xmlns:a16="http://schemas.microsoft.com/office/drawing/2014/main" id="{47A0E9E8-E96E-4CC4-9FD2-31ACA61A8BEA}"/>
               </a:ext>
             </a:extLst>
           </p:cNvPr>
@@ -18889,7 +18631,7 @@
           <p:cNvPr id="31" name="">
             <a:extLst xmlns:a="http://schemas.openxmlformats.org/drawingml/2006/main">
               <a:ext uri="{FF2B5EF4-FFF2-40B4-BE49-F238E27FC236}">
-                <a16:creationId xmlns:a16="http://schemas.microsoft.com/office/drawing/2014/main" id="{E0FBB684-F8C7-4BBA-83C4-79D8CCE8D529}"/>
+                <a16:creationId xmlns:a16="http://schemas.microsoft.com/office/drawing/2014/main" id="{C269EB41-FA74-4437-994F-D1B08741ADBF}"/>
               </a:ext>
             </a:extLst>
           </p:cNvPr>
@@ -18924,7 +18666,7 @@
           <p:cNvPr id="32" name="">
             <a:extLst xmlns:a="http://schemas.openxmlformats.org/drawingml/2006/main">
               <a:ext uri="{FF2B5EF4-FFF2-40B4-BE49-F238E27FC236}">
-                <a16:creationId xmlns:a16="http://schemas.microsoft.com/office/drawing/2014/main" id="{45E37655-6DCB-45A6-AF9D-29FBAAD2271D}"/>
+                <a16:creationId xmlns:a16="http://schemas.microsoft.com/office/drawing/2014/main" id="{6F9585D7-4E95-47D3-97F5-F8C2B78A381D}"/>
               </a:ext>
             </a:extLst>
           </p:cNvPr>
@@ -18988,7 +18730,7 @@
           <p:cNvPr id="33" name="">
             <a:extLst xmlns:a="http://schemas.openxmlformats.org/drawingml/2006/main">
               <a:ext uri="{FF2B5EF4-FFF2-40B4-BE49-F238E27FC236}">
-                <a16:creationId xmlns:a16="http://schemas.microsoft.com/office/drawing/2014/main" id="{A2566290-B0C3-46F0-A83D-BEF30A0E4E61}"/>
+                <a16:creationId xmlns:a16="http://schemas.microsoft.com/office/drawing/2014/main" id="{10B9620B-AAFB-4EDD-B1A1-25BD79365A09}"/>
               </a:ext>
             </a:extLst>
           </p:cNvPr>
@@ -19052,7 +18794,7 @@
           <p:cNvPr id="34" name="">
             <a:extLst xmlns:a="http://schemas.openxmlformats.org/drawingml/2006/main">
               <a:ext uri="{FF2B5EF4-FFF2-40B4-BE49-F238E27FC236}">
-                <a16:creationId xmlns:a16="http://schemas.microsoft.com/office/drawing/2014/main" id="{12E0D3DB-A07E-4A23-9E28-775EDCE1C2E1}"/>
+                <a16:creationId xmlns:a16="http://schemas.microsoft.com/office/drawing/2014/main" id="{2AB783CC-4F73-4D5B-A7AC-6133571E4709}"/>
               </a:ext>
             </a:extLst>
           </p:cNvPr>
@@ -19116,7 +18858,7 @@
           <p:cNvPr id="35" name="">
             <a:extLst xmlns:a="http://schemas.openxmlformats.org/drawingml/2006/main">
               <a:ext uri="{FF2B5EF4-FFF2-40B4-BE49-F238E27FC236}">
-                <a16:creationId xmlns:a16="http://schemas.microsoft.com/office/drawing/2014/main" id="{B7944900-3315-486F-8DC7-A9D33799606A}"/>
+                <a16:creationId xmlns:a16="http://schemas.microsoft.com/office/drawing/2014/main" id="{536874F3-9A6E-4589-928A-73E05B4BF776}"/>
               </a:ext>
             </a:extLst>
           </p:cNvPr>
@@ -19180,7 +18922,7 @@
           <p:cNvPr id="36" name="">
             <a:extLst xmlns:a="http://schemas.openxmlformats.org/drawingml/2006/main">
               <a:ext uri="{FF2B5EF4-FFF2-40B4-BE49-F238E27FC236}">
-                <a16:creationId xmlns:a16="http://schemas.microsoft.com/office/drawing/2014/main" id="{3128ED4C-A6E2-41ED-BFBC-3397467AECDF}"/>
+                <a16:creationId xmlns:a16="http://schemas.microsoft.com/office/drawing/2014/main" id="{E17DFF84-798A-405B-A2AE-FA7E144D9F7C}"/>
               </a:ext>
             </a:extLst>
           </p:cNvPr>
@@ -19244,7 +18986,7 @@
           <p:cNvPr id="37" name="">
             <a:extLst xmlns:a="http://schemas.openxmlformats.org/drawingml/2006/main">
               <a:ext uri="{FF2B5EF4-FFF2-40B4-BE49-F238E27FC236}">
-                <a16:creationId xmlns:a16="http://schemas.microsoft.com/office/drawing/2014/main" id="{CE9C617E-256A-463D-87C0-4F73AE611CB3}"/>
+                <a16:creationId xmlns:a16="http://schemas.microsoft.com/office/drawing/2014/main" id="{B936350E-D2E6-4F20-AFB1-DFC3122FCC58}"/>
               </a:ext>
             </a:extLst>
           </p:cNvPr>
@@ -19279,7 +19021,7 @@
           <p:cNvPr id="38" name="">
             <a:extLst xmlns:a="http://schemas.openxmlformats.org/drawingml/2006/main">
               <a:ext uri="{FF2B5EF4-FFF2-40B4-BE49-F238E27FC236}">
-                <a16:creationId xmlns:a16="http://schemas.microsoft.com/office/drawing/2014/main" id="{FF12C315-0CD7-4A98-97E1-A20BC83CDFAE}"/>
+                <a16:creationId xmlns:a16="http://schemas.microsoft.com/office/drawing/2014/main" id="{E069399D-9273-4EC8-9ABA-F579DD86D761}"/>
               </a:ext>
             </a:extLst>
           </p:cNvPr>
@@ -19343,7 +19085,7 @@
           <p:cNvPr id="39" name="">
             <a:extLst xmlns:a="http://schemas.openxmlformats.org/drawingml/2006/main">
               <a:ext uri="{FF2B5EF4-FFF2-40B4-BE49-F238E27FC236}">
-                <a16:creationId xmlns:a16="http://schemas.microsoft.com/office/drawing/2014/main" id="{134FC113-41A1-46F8-89C7-723C7A7088C9}"/>
+                <a16:creationId xmlns:a16="http://schemas.microsoft.com/office/drawing/2014/main" id="{0B66165F-0A5A-4B7A-9744-E4350D6D0711}"/>
               </a:ext>
             </a:extLst>
           </p:cNvPr>
@@ -19407,7 +19149,7 @@
           <p:cNvPr id="40" name="">
             <a:extLst xmlns:a="http://schemas.openxmlformats.org/drawingml/2006/main">
               <a:ext uri="{FF2B5EF4-FFF2-40B4-BE49-F238E27FC236}">
-                <a16:creationId xmlns:a16="http://schemas.microsoft.com/office/drawing/2014/main" id="{6473957E-021F-43A3-9D22-A942C8AEC2CF}"/>
+                <a16:creationId xmlns:a16="http://schemas.microsoft.com/office/drawing/2014/main" id="{BBBAEFFF-6AFB-4106-8367-293675E64227}"/>
               </a:ext>
             </a:extLst>
           </p:cNvPr>
@@ -19471,7 +19213,7 @@
           <p:cNvPr id="41" name="">
             <a:extLst xmlns:a="http://schemas.openxmlformats.org/drawingml/2006/main">
               <a:ext uri="{FF2B5EF4-FFF2-40B4-BE49-F238E27FC236}">
-                <a16:creationId xmlns:a16="http://schemas.microsoft.com/office/drawing/2014/main" id="{BB180815-1D29-4C09-8C9D-E7CB46CF1411}"/>
+                <a16:creationId xmlns:a16="http://schemas.microsoft.com/office/drawing/2014/main" id="{BC1760AB-FEB8-4881-BF94-16680E258238}"/>
               </a:ext>
             </a:extLst>
           </p:cNvPr>
@@ -19535,7 +19277,7 @@
           <p:cNvPr id="42" name="">
             <a:extLst xmlns:a="http://schemas.openxmlformats.org/drawingml/2006/main">
               <a:ext uri="{FF2B5EF4-FFF2-40B4-BE49-F238E27FC236}">
-                <a16:creationId xmlns:a16="http://schemas.microsoft.com/office/drawing/2014/main" id="{27693DF9-E585-4A34-8D4E-5AEA7E94EAB9}"/>
+                <a16:creationId xmlns:a16="http://schemas.microsoft.com/office/drawing/2014/main" id="{7314BBC6-A349-4AD1-A541-4DB96566F05F}"/>
               </a:ext>
             </a:extLst>
           </p:cNvPr>
@@ -19599,7 +19341,7 @@
           <p:cNvPr id="43" name="">
             <a:extLst xmlns:a="http://schemas.openxmlformats.org/drawingml/2006/main">
               <a:ext uri="{FF2B5EF4-FFF2-40B4-BE49-F238E27FC236}">
-                <a16:creationId xmlns:a16="http://schemas.microsoft.com/office/drawing/2014/main" id="{7D386358-972C-4381-8B69-FC300C37DC4E}"/>
+                <a16:creationId xmlns:a16="http://schemas.microsoft.com/office/drawing/2014/main" id="{066EF5C3-CC13-4885-A57D-AE20223325A5}"/>
               </a:ext>
             </a:extLst>
           </p:cNvPr>
@@ -19634,7 +19376,7 @@
           <p:cNvPr id="44" name="">
             <a:extLst xmlns:a="http://schemas.openxmlformats.org/drawingml/2006/main">
               <a:ext uri="{FF2B5EF4-FFF2-40B4-BE49-F238E27FC236}">
-                <a16:creationId xmlns:a16="http://schemas.microsoft.com/office/drawing/2014/main" id="{AA97A71C-0AB8-463C-A36C-66712B91A29B}"/>
+                <a16:creationId xmlns:a16="http://schemas.microsoft.com/office/drawing/2014/main" id="{3828C15B-AD16-4509-A78D-1B120118580D}"/>
               </a:ext>
             </a:extLst>
           </p:cNvPr>
@@ -19698,7 +19440,7 @@
           <p:cNvPr id="45" name="">
             <a:extLst xmlns:a="http://schemas.openxmlformats.org/drawingml/2006/main">
               <a:ext uri="{FF2B5EF4-FFF2-40B4-BE49-F238E27FC236}">
-                <a16:creationId xmlns:a16="http://schemas.microsoft.com/office/drawing/2014/main" id="{F0EAE1BE-3D6C-4F4A-B993-E6A1F31C461F}"/>
+                <a16:creationId xmlns:a16="http://schemas.microsoft.com/office/drawing/2014/main" id="{5BA43FCC-E0A5-48C1-A41D-71C4B2094C60}"/>
               </a:ext>
             </a:extLst>
           </p:cNvPr>
@@ -19762,7 +19504,7 @@
           <p:cNvPr id="46" name="">
             <a:extLst xmlns:a="http://schemas.openxmlformats.org/drawingml/2006/main">
               <a:ext uri="{FF2B5EF4-FFF2-40B4-BE49-F238E27FC236}">
-                <a16:creationId xmlns:a16="http://schemas.microsoft.com/office/drawing/2014/main" id="{707C9CD3-BAFA-4E09-8650-BFC206477C36}"/>
+                <a16:creationId xmlns:a16="http://schemas.microsoft.com/office/drawing/2014/main" id="{7AE0790F-2C7A-4390-8568-EE2C19F6B65A}"/>
               </a:ext>
             </a:extLst>
           </p:cNvPr>
@@ -19826,7 +19568,7 @@
           <p:cNvPr id="47" name="">
             <a:extLst xmlns:a="http://schemas.openxmlformats.org/drawingml/2006/main">
               <a:ext uri="{FF2B5EF4-FFF2-40B4-BE49-F238E27FC236}">
-                <a16:creationId xmlns:a16="http://schemas.microsoft.com/office/drawing/2014/main" id="{B03275BB-B870-4D35-8221-7C2153ED0466}"/>
+                <a16:creationId xmlns:a16="http://schemas.microsoft.com/office/drawing/2014/main" id="{AB840DFE-5137-4163-A431-FF5EC872D879}"/>
               </a:ext>
             </a:extLst>
           </p:cNvPr>
@@ -19890,7 +19632,7 @@
           <p:cNvPr id="48" name="">
             <a:extLst xmlns:a="http://schemas.openxmlformats.org/drawingml/2006/main">
               <a:ext uri="{FF2B5EF4-FFF2-40B4-BE49-F238E27FC236}">
-                <a16:creationId xmlns:a16="http://schemas.microsoft.com/office/drawing/2014/main" id="{DC557798-3A18-4DF3-B3B7-CEDF7633B8A9}"/>
+                <a16:creationId xmlns:a16="http://schemas.microsoft.com/office/drawing/2014/main" id="{BC66530A-7C64-4408-8644-56B5AA5A0053}"/>
               </a:ext>
             </a:extLst>
           </p:cNvPr>
@@ -19954,7 +19696,7 @@
           <p:cNvPr id="49" name="">
             <a:extLst xmlns:a="http://schemas.openxmlformats.org/drawingml/2006/main">
               <a:ext uri="{FF2B5EF4-FFF2-40B4-BE49-F238E27FC236}">
-                <a16:creationId xmlns:a16="http://schemas.microsoft.com/office/drawing/2014/main" id="{3E82516D-A801-453A-8D50-B503EEF6E818}"/>
+                <a16:creationId xmlns:a16="http://schemas.microsoft.com/office/drawing/2014/main" id="{40EC95E5-2BA2-40F6-AF95-6A2A7E0889A6}"/>
               </a:ext>
             </a:extLst>
           </p:cNvPr>
@@ -20018,7 +19760,7 @@
           <p:cNvPr id="50" name="">
             <a:extLst xmlns:a="http://schemas.openxmlformats.org/drawingml/2006/main">
               <a:ext uri="{FF2B5EF4-FFF2-40B4-BE49-F238E27FC236}">
-                <a16:creationId xmlns:a16="http://schemas.microsoft.com/office/drawing/2014/main" id="{CC30AB1E-283E-412D-8C21-F9D97F1943A4}"/>
+                <a16:creationId xmlns:a16="http://schemas.microsoft.com/office/drawing/2014/main" id="{C5CD0944-7295-4537-A05F-C62EFD33F3B7}"/>
               </a:ext>
             </a:extLst>
           </p:cNvPr>
@@ -20053,7 +19795,7 @@
           <p:cNvPr id="51" name="">
             <a:extLst xmlns:a="http://schemas.openxmlformats.org/drawingml/2006/main">
               <a:ext uri="{FF2B5EF4-FFF2-40B4-BE49-F238E27FC236}">
-                <a16:creationId xmlns:a16="http://schemas.microsoft.com/office/drawing/2014/main" id="{4C20572C-1E65-4439-9517-2771D8E9357E}"/>
+                <a16:creationId xmlns:a16="http://schemas.microsoft.com/office/drawing/2014/main" id="{EEC4961C-A083-4A25-BA4E-CBB42D27F56B}"/>
               </a:ext>
             </a:extLst>
           </p:cNvPr>
@@ -20117,7 +19859,7 @@
           <p:cNvPr id="52" name="">
             <a:extLst xmlns:a="http://schemas.openxmlformats.org/drawingml/2006/main">
               <a:ext uri="{FF2B5EF4-FFF2-40B4-BE49-F238E27FC236}">
-                <a16:creationId xmlns:a16="http://schemas.microsoft.com/office/drawing/2014/main" id="{43387F38-32ED-4057-A4C0-F1D50A1ECE04}"/>
+                <a16:creationId xmlns:a16="http://schemas.microsoft.com/office/drawing/2014/main" id="{00543243-CD11-49AC-8E16-940E80E623D3}"/>
               </a:ext>
             </a:extLst>
           </p:cNvPr>
@@ -20179,7 +19921,7 @@
     </p:spTree>
     <p:extLst>
       <p:ext uri="{BB962C8B-B14F-4D97-AF65-F5344CB8AC3E}">
-        <p14:creationId xmlns:p14="http://schemas.microsoft.com/office/powerpoint/2010/main" val="1329148638"/>
+        <p14:creationId xmlns:p14="http://schemas.microsoft.com/office/powerpoint/2010/main" val="1214791383"/>
       </p:ext>
     </p:extLst>
   </p:cSld>

</xml_diff>